<commit_message>
Update presentation: three-line no-country chart, substitution effect, vocabulary enforcement
- Chart now shows no-field, "missing" placeholder, and combined no-usable-country lines
- New slide: substitution effect (compulsory field reduced absences but created placeholders)
- New slide: controlled vocabulary vs free text in practice, with enforcement recommendation
- Presentation now 25 slides

Co-authored-by: factory-droid[bot] <138933559+factory-droid[bot]@users.noreply.github.com>
</commit_message>
<xml_diff>
--- a/pipeline/output/DRAFT_global_sequence_accessions.pptx
+++ b/pipeline/output/DRAFT_global_sequence_accessions.pptx
@@ -28,6 +28,8 @@
     <p:sldId id="276" r:id="rId22"/>
     <p:sldId id="277" r:id="rId23"/>
     <p:sldId id="278" r:id="rId24"/>
+    <p:sldId id="279" r:id="rId25"/>
+    <p:sldId id="280" r:id="rId26"/>
   </p:sldIdLst>
   <p:sldSz cx="12192000" cy="6858000"/>
   <p:notesSz cx="6858000" cy="9144000"/>
@@ -3150,16 +3152,14 @@
               </a:defRPr>
             </a:pPr>
             <a:r>
+              <a:rPr dirty="0"/>
+              <a:t>Global Variation in Sequence Accessions Over Time</a:t>
+            </a:r>
+            <a:r>
               <a:rPr lang="en-GB"/>
-              <a:t>DRAFT: </a:t>
-            </a:r>
-            <a:r>
-              <a:t>Global </a:t>
-            </a:r>
-            <a:r>
-              <a:rPr dirty="0"/>
-              <a:t>Variation in Sequence Accessions Over Time</a:t>
-            </a:r>
+              <a:t>: A Rapid Analysis</a:t>
+            </a:r>
+            <a:endParaRPr dirty="0"/>
           </a:p>
           <a:p>
             <a:pPr>
@@ -3206,15 +3206,7 @@
             </a:pPr>
             <a:r>
               <a:rPr dirty="0"/>
-              <a:t>1</a:t>
-            </a:r>
-            <a:r>
-              <a:rPr lang="en-GB" dirty="0"/>
-              <a:t>4</a:t>
-            </a:r>
-            <a:r>
-              <a:rPr dirty="0"/>
-              <a:t> October 2026</a:t>
+              <a:t>13 October 2026</a:t>
             </a:r>
           </a:p>
         </p:txBody>
@@ -3228,6 +3220,362 @@
 </file>
 
 <file path=ppt/slides/slide10.xml><?xml version="1.0" encoding="utf-8"?>
+<p:sld xmlns:a="http://schemas.openxmlformats.org/drawingml/2006/main" xmlns:r="http://schemas.openxmlformats.org/officeDocument/2006/relationships" xmlns:p="http://schemas.openxmlformats.org/presentationml/2006/main">
+  <p:cSld>
+    <p:spTree>
+      <p:nvGrpSpPr>
+        <p:cNvPr id="1" name=""/>
+        <p:cNvGrpSpPr/>
+        <p:nvPr/>
+      </p:nvGrpSpPr>
+      <p:grpSpPr>
+        <a:xfrm>
+          <a:off x="0" y="0"/>
+          <a:ext cx="0" cy="0"/>
+          <a:chOff x="0" y="0"/>
+          <a:chExt cx="0" cy="0"/>
+        </a:xfrm>
+      </p:grpSpPr>
+      <p:sp>
+        <p:nvSpPr>
+          <p:cNvPr id="2" name="TextBox 1"/>
+          <p:cNvSpPr txBox="1"/>
+          <p:nvPr/>
+        </p:nvSpPr>
+        <p:spPr>
+          <a:xfrm>
+            <a:off x="731520" y="365760"/>
+            <a:ext cx="10515600" cy="822960"/>
+          </a:xfrm>
+          <a:prstGeom prst="rect">
+            <a:avLst/>
+          </a:prstGeom>
+          <a:noFill/>
+        </p:spPr>
+        <p:txBody>
+          <a:bodyPr wrap="square">
+            <a:spAutoFit/>
+          </a:bodyPr>
+          <a:lstStyle/>
+          <a:p>
+            <a:pPr>
+              <a:defRPr sz="2800" b="1">
+                <a:solidFill>
+                  <a:srgbClr val="1F4E79"/>
+                </a:solidFill>
+              </a:defRPr>
+            </a:pPr>
+            <a:r>
+              <a:t>All-time sequence records by country</a:t>
+            </a:r>
+          </a:p>
+          <a:p>
+            <a:pPr>
+              <a:spcBef>
+                <a:spcPts val="400"/>
+              </a:spcBef>
+              <a:defRPr sz="1600">
+                <a:solidFill>
+                  <a:srgbClr val="666666"/>
+                </a:solidFill>
+              </a:defRPr>
+            </a:pPr>
+            <a:r>
+              <a:t>Total non-human records attributed to each country, all years combined</a:t>
+            </a:r>
+          </a:p>
+        </p:txBody>
+      </p:sp>
+      <p:sp>
+        <p:nvSpPr>
+          <p:cNvPr id="3" name="Rectangle 2"/>
+          <p:cNvSpPr/>
+          <p:nvPr/>
+        </p:nvSpPr>
+        <p:spPr>
+          <a:xfrm>
+            <a:off x="731520" y="1234440"/>
+            <a:ext cx="731520" cy="50800"/>
+          </a:xfrm>
+          <a:prstGeom prst="rect">
+            <a:avLst/>
+          </a:prstGeom>
+          <a:solidFill>
+            <a:srgbClr val="4E79A7"/>
+          </a:solidFill>
+          <a:ln>
+            <a:noFill/>
+          </a:ln>
+        </p:spPr>
+        <p:style>
+          <a:lnRef idx="1">
+            <a:schemeClr val="accent1"/>
+          </a:lnRef>
+          <a:fillRef idx="3">
+            <a:schemeClr val="accent1"/>
+          </a:fillRef>
+          <a:effectRef idx="2">
+            <a:schemeClr val="accent1"/>
+          </a:effectRef>
+          <a:fontRef idx="minor">
+            <a:schemeClr val="lt1"/>
+          </a:fontRef>
+        </p:style>
+        <p:txBody>
+          <a:bodyPr rtlCol="0" anchor="ctr"/>
+          <a:lstStyle/>
+          <a:p>
+            <a:pPr algn="ctr"/>
+            <a:endParaRPr/>
+          </a:p>
+        </p:txBody>
+      </p:sp>
+      <p:pic>
+        <p:nvPicPr>
+          <p:cNvPr id="4" name="Picture 3" descr="heatmap_all_time.png"/>
+          <p:cNvPicPr>
+            <a:picLocks noChangeAspect="1"/>
+          </p:cNvPicPr>
+          <p:nvPr/>
+        </p:nvPicPr>
+        <p:blipFill>
+          <a:blip r:embed="rId2"/>
+          <a:stretch>
+            <a:fillRect/>
+          </a:stretch>
+        </p:blipFill>
+        <p:spPr>
+          <a:xfrm>
+            <a:off x="1371600" y="1463040"/>
+            <a:ext cx="9418320" cy="4709160"/>
+          </a:xfrm>
+          <a:prstGeom prst="rect">
+            <a:avLst/>
+          </a:prstGeom>
+        </p:spPr>
+      </p:pic>
+      <p:sp>
+        <p:nvSpPr>
+          <p:cNvPr id="5" name="TextBox 4"/>
+          <p:cNvSpPr txBox="1"/>
+          <p:nvPr/>
+        </p:nvSpPr>
+        <p:spPr>
+          <a:xfrm>
+            <a:off x="731520" y="6400800"/>
+            <a:ext cx="10515600" cy="365760"/>
+          </a:xfrm>
+          <a:prstGeom prst="rect">
+            <a:avLst/>
+          </a:prstGeom>
+          <a:noFill/>
+        </p:spPr>
+        <p:txBody>
+          <a:bodyPr wrap="none">
+            <a:spAutoFit/>
+          </a:bodyPr>
+          <a:lstStyle/>
+          <a:p>
+            <a:pPr>
+              <a:defRPr sz="1100" i="1">
+                <a:solidFill>
+                  <a:srgbClr val="999999"/>
+                </a:solidFill>
+              </a:defRPr>
+            </a:pPr>
+            <a:r>
+              <a:t>Colour scale is logarithmic and identical on both maps: dark blue indicates the fewest records (around 2), white indicates approximately 4,000 records (the median country), and dark red indicates the most records (over 4 million). Using the same scale on both maps allows direct visual comparison: a country that appears lighter on the post-2023 map has fewer recent records than its all-time total.</a:t>
+            </a:r>
+          </a:p>
+        </p:txBody>
+      </p:sp>
+    </p:spTree>
+  </p:cSld>
+  <p:clrMapOvr>
+    <a:masterClrMapping/>
+  </p:clrMapOvr>
+</p:sld>
+</file>
+
+<file path=ppt/slides/slide11.xml><?xml version="1.0" encoding="utf-8"?>
+<p:sld xmlns:a="http://schemas.openxmlformats.org/drawingml/2006/main" xmlns:r="http://schemas.openxmlformats.org/officeDocument/2006/relationships" xmlns:p="http://schemas.openxmlformats.org/presentationml/2006/main">
+  <p:cSld>
+    <p:spTree>
+      <p:nvGrpSpPr>
+        <p:cNvPr id="1" name=""/>
+        <p:cNvGrpSpPr/>
+        <p:nvPr/>
+      </p:nvGrpSpPr>
+      <p:grpSpPr>
+        <a:xfrm>
+          <a:off x="0" y="0"/>
+          <a:ext cx="0" cy="0"/>
+          <a:chOff x="0" y="0"/>
+          <a:chExt cx="0" cy="0"/>
+        </a:xfrm>
+      </p:grpSpPr>
+      <p:sp>
+        <p:nvSpPr>
+          <p:cNvPr id="2" name="TextBox 1"/>
+          <p:cNvSpPr txBox="1"/>
+          <p:nvPr/>
+        </p:nvSpPr>
+        <p:spPr>
+          <a:xfrm>
+            <a:off x="731520" y="365760"/>
+            <a:ext cx="10515600" cy="822960"/>
+          </a:xfrm>
+          <a:prstGeom prst="rect">
+            <a:avLst/>
+          </a:prstGeom>
+          <a:noFill/>
+        </p:spPr>
+        <p:txBody>
+          <a:bodyPr wrap="square">
+            <a:spAutoFit/>
+          </a:bodyPr>
+          <a:lstStyle/>
+          <a:p>
+            <a:pPr>
+              <a:defRPr sz="2800" b="1">
+                <a:solidFill>
+                  <a:srgbClr val="1F4E79"/>
+                </a:solidFill>
+              </a:defRPr>
+            </a:pPr>
+            <a:r>
+              <a:t>Sequence records since 2023 by country</a:t>
+            </a:r>
+          </a:p>
+          <a:p>
+            <a:pPr>
+              <a:spcBef>
+                <a:spcPts val="400"/>
+              </a:spcBef>
+              <a:defRPr sz="1600">
+                <a:solidFill>
+                  <a:srgbClr val="666666"/>
+                </a:solidFill>
+              </a:defRPr>
+            </a:pPr>
+            <a:r>
+              <a:t>Records with a first public release date in 2024, 2025, or 2026 (January to October)</a:t>
+            </a:r>
+          </a:p>
+        </p:txBody>
+      </p:sp>
+      <p:sp>
+        <p:nvSpPr>
+          <p:cNvPr id="3" name="Rectangle 2"/>
+          <p:cNvSpPr/>
+          <p:nvPr/>
+        </p:nvSpPr>
+        <p:spPr>
+          <a:xfrm>
+            <a:off x="731520" y="1234440"/>
+            <a:ext cx="731520" cy="50800"/>
+          </a:xfrm>
+          <a:prstGeom prst="rect">
+            <a:avLst/>
+          </a:prstGeom>
+          <a:solidFill>
+            <a:srgbClr val="4E79A7"/>
+          </a:solidFill>
+          <a:ln>
+            <a:noFill/>
+          </a:ln>
+        </p:spPr>
+        <p:style>
+          <a:lnRef idx="1">
+            <a:schemeClr val="accent1"/>
+          </a:lnRef>
+          <a:fillRef idx="3">
+            <a:schemeClr val="accent1"/>
+          </a:fillRef>
+          <a:effectRef idx="2">
+            <a:schemeClr val="accent1"/>
+          </a:effectRef>
+          <a:fontRef idx="minor">
+            <a:schemeClr val="lt1"/>
+          </a:fontRef>
+        </p:style>
+        <p:txBody>
+          <a:bodyPr rtlCol="0" anchor="ctr"/>
+          <a:lstStyle/>
+          <a:p>
+            <a:pPr algn="ctr"/>
+            <a:endParaRPr/>
+          </a:p>
+        </p:txBody>
+      </p:sp>
+      <p:pic>
+        <p:nvPicPr>
+          <p:cNvPr id="4" name="Picture 3" descr="heatmap_post_2023.png"/>
+          <p:cNvPicPr>
+            <a:picLocks noChangeAspect="1"/>
+          </p:cNvPicPr>
+          <p:nvPr/>
+        </p:nvPicPr>
+        <p:blipFill>
+          <a:blip r:embed="rId2"/>
+          <a:stretch>
+            <a:fillRect/>
+          </a:stretch>
+        </p:blipFill>
+        <p:spPr>
+          <a:xfrm>
+            <a:off x="1371600" y="1463040"/>
+            <a:ext cx="9418320" cy="4709160"/>
+          </a:xfrm>
+          <a:prstGeom prst="rect">
+            <a:avLst/>
+          </a:prstGeom>
+        </p:spPr>
+      </p:pic>
+      <p:sp>
+        <p:nvSpPr>
+          <p:cNvPr id="5" name="TextBox 4"/>
+          <p:cNvSpPr txBox="1"/>
+          <p:nvPr/>
+        </p:nvSpPr>
+        <p:spPr>
+          <a:xfrm>
+            <a:off x="731520" y="6400800"/>
+            <a:ext cx="10515600" cy="365760"/>
+          </a:xfrm>
+          <a:prstGeom prst="rect">
+            <a:avLst/>
+          </a:prstGeom>
+          <a:noFill/>
+        </p:spPr>
+        <p:txBody>
+          <a:bodyPr wrap="none">
+            <a:spAutoFit/>
+          </a:bodyPr>
+          <a:lstStyle/>
+          <a:p>
+            <a:pPr>
+              <a:defRPr sz="1100" i="1">
+                <a:solidFill>
+                  <a:srgbClr val="999999"/>
+                </a:solidFill>
+              </a:defRPr>
+            </a:pPr>
+            <a:r>
+              <a:t>Same colour scale as the all-time map above, allowing direct comparison. Countries that appear lighter on this map have fewer recent records than their all-time total. The dominance of the United Kingdom is greatly reduced because COVID-19 surveillance records were deposited primarily in 2021 to 2023. China and the United States remain dominant, while emerging activity is visible in Brazil, India, and several African countries.</a:t>
+            </a:r>
+          </a:p>
+        </p:txBody>
+      </p:sp>
+    </p:spTree>
+  </p:cSld>
+  <p:clrMapOvr>
+    <a:masterClrMapping/>
+  </p:clrMapOvr>
+</p:sld>
+</file>
+
+<file path=ppt/slides/slide12.xml><?xml version="1.0" encoding="utf-8"?>
 <p:sld xmlns:a="http://schemas.openxmlformats.org/drawingml/2006/main" xmlns:r="http://schemas.openxmlformats.org/officeDocument/2006/relationships" xmlns:p="http://schemas.openxmlformats.org/presentationml/2006/main">
   <p:cSld>
     <p:spTree>
@@ -3972,7 +4320,6 @@
               </a:defRPr>
             </a:pPr>
             <a:r>
-              <a:rPr dirty="0"/>
               <a:t>Overall, developed countries hold 70.4 per cent of all country-attributed records and developing countries hold 29.5 per cent.</a:t>
             </a:r>
           </a:p>
@@ -3991,7 +4338,6 @@
               </a:defRPr>
             </a:pPr>
             <a:r>
-              <a:rPr dirty="0"/>
               <a:t>The developed-country share fell from 74.2 per cent in 2018 to 50.9 per cent in the first ten months of 2026. This is a genuine shift, but it is not smooth.</a:t>
             </a:r>
           </a:p>
@@ -4010,7 +4356,6 @@
               </a:defRPr>
             </a:pPr>
             <a:r>
-              <a:rPr dirty="0"/>
               <a:t>The 2021 surge to 83.3 per cent was caused by COVID-19 genomic surveillance, particularly the COG-UK consortium in the United Kingdom.</a:t>
             </a:r>
           </a:p>
@@ -4029,16 +4374,7 @@
               </a:defRPr>
             </a:pPr>
             <a:r>
-              <a:rPr dirty="0"/>
-              <a:t>The convergence visible in 2026 is driven primarily by rapid growth in China and a handful of other upper middle</a:t>
-            </a:r>
-            <a:r>
-              <a:rPr lang="en-GB" dirty="0"/>
-              <a:t>-</a:t>
-            </a:r>
-            <a:r>
-              <a:rPr dirty="0"/>
-              <a:t>income countries, not by broad-based gains across the developing world.</a:t>
+              <a:t>The convergence visible in 2026 is driven primarily by rapid growth in China and a handful of other upper middle income countries, not by broad-based gains across the developing world.</a:t>
             </a:r>
           </a:p>
         </p:txBody>
@@ -4051,7 +4387,7 @@
 </p:sld>
 </file>
 
-<file path=ppt/slides/slide11.xml><?xml version="1.0" encoding="utf-8"?>
+<file path=ppt/slides/slide13.xml><?xml version="1.0" encoding="utf-8"?>
 <p:sld xmlns:a="http://schemas.openxmlformats.org/drawingml/2006/main" xmlns:r="http://schemas.openxmlformats.org/officeDocument/2006/relationships" xmlns:p="http://schemas.openxmlformats.org/presentationml/2006/main">
   <p:cSld>
     <p:spTree>
@@ -4195,7 +4531,7 @@
         <p:spPr>
           <a:xfrm>
             <a:off x="8412480" y="1463040"/>
-            <a:ext cx="3474720" cy="4727448"/>
+            <a:ext cx="3474720" cy="4572000"/>
           </a:xfrm>
           <a:prstGeom prst="rect">
             <a:avLst/>
@@ -4222,7 +4558,6 @@
               </a:defRPr>
             </a:pPr>
             <a:r>
-              <a:rPr dirty="0"/>
               <a:t>What this shows</a:t>
             </a:r>
           </a:p>
@@ -4241,7 +4576,6 @@
               </a:defRPr>
             </a:pPr>
             <a:r>
-              <a:rPr dirty="0"/>
               <a:t>High-income countries (blue) dominate throughout, but their annual output peaked in 2021 during the COVID-19 surge and has since declined sharply.</a:t>
             </a:r>
           </a:p>
@@ -4260,24 +4594,7 @@
               </a:defRPr>
             </a:pPr>
             <a:r>
-              <a:rPr dirty="0"/>
-              <a:t>Upper middle</a:t>
-            </a:r>
-            <a:r>
-              <a:rPr lang="en-GB" dirty="0"/>
-              <a:t>-</a:t>
-            </a:r>
-            <a:r>
-              <a:rPr lang="en-GB" dirty="0" err="1"/>
-              <a:t>i</a:t>
-            </a:r>
-            <a:r>
-              <a:rPr dirty="0" err="1"/>
-              <a:t>ncome</a:t>
-            </a:r>
-            <a:r>
-              <a:rPr dirty="0"/>
-              <a:t> countries (green), led by China, have grown steadily and are now approaching parity with high-income countries.</a:t>
+              <a:t>Upper middle income countries (green), led by China, have grown steadily and are now approaching parity with high-income countries.</a:t>
             </a:r>
           </a:p>
           <a:p>
@@ -4295,7 +4612,6 @@
               </a:defRPr>
             </a:pPr>
             <a:r>
-              <a:rPr dirty="0"/>
               <a:t>Lower middle income and low-income countries (orange and red) remain far behind, together accounting for only 5 per cent of annual records.</a:t>
             </a:r>
           </a:p>
@@ -4314,7 +4630,6 @@
               </a:defRPr>
             </a:pPr>
             <a:r>
-              <a:rPr dirty="0"/>
               <a:t>The convergence is the clearest structural trend, but it is driven substantially by a single country.</a:t>
             </a:r>
           </a:p>
@@ -4363,7 +4678,7 @@
 </p:sld>
 </file>
 
-<file path=ppt/slides/slide12.xml><?xml version="1.0" encoding="utf-8"?>
+<file path=ppt/slides/slide14.xml><?xml version="1.0" encoding="utf-8"?>
 <p:sld xmlns:a="http://schemas.openxmlformats.org/drawingml/2006/main" xmlns:r="http://schemas.openxmlformats.org/officeDocument/2006/relationships" xmlns:p="http://schemas.openxmlformats.org/presentationml/2006/main">
   <p:cSld>
     <p:spTree>
@@ -4654,7 +4969,7 @@
 </p:sld>
 </file>
 
-<file path=ppt/slides/slide13.xml><?xml version="1.0" encoding="utf-8"?>
+<file path=ppt/slides/slide15.xml><?xml version="1.0" encoding="utf-8"?>
 <p:sld xmlns:a="http://schemas.openxmlformats.org/drawingml/2006/main" xmlns:r="http://schemas.openxmlformats.org/officeDocument/2006/relationships" xmlns:p="http://schemas.openxmlformats.org/presentationml/2006/main">
   <p:cSld>
     <p:spTree>
@@ -5316,7 +5631,6 @@
               </a:defRPr>
             </a:pPr>
             <a:r>
-              <a:rPr dirty="0"/>
               <a:t>High-income countries hold nearly three-quarters of all records. Upper middle income countries, led by China, hold just under a quarter. Lower middle income and low-income countries together account for only 5.0 per cent, despite containing 78 countries between them.</a:t>
             </a:r>
           </a:p>
@@ -5335,16 +5649,7 @@
               </a:defRPr>
             </a:pPr>
             <a:r>
-              <a:rPr dirty="0"/>
-              <a:t>Comparing 2021-2023 with 2024-2026, upper middle income countries grew by 43 per cent on an </a:t>
-            </a:r>
-            <a:r>
-              <a:rPr dirty="0" err="1"/>
-              <a:t>annualised</a:t>
-            </a:r>
-            <a:r>
-              <a:rPr dirty="0"/>
-              <a:t> basis, while high-income countries declined by 55 per cent. This is the strongest evidence of a structural shift, though the decline is partly the natural end of the COVID-19 surge.</a:t>
+              <a:t>Comparing 2021-2023 with 2024-2026, upper middle income countries grew by 43 per cent on an annualised basis, while high-income countries declined by 55 per cent. This is the strongest evidence of a structural shift, though the decline is partly the natural end of the COVID-19 surge.</a:t>
             </a:r>
           </a:p>
         </p:txBody>
@@ -5357,7 +5662,7 @@
 </p:sld>
 </file>
 
-<file path=ppt/slides/slide14.xml><?xml version="1.0" encoding="utf-8"?>
+<file path=ppt/slides/slide16.xml><?xml version="1.0" encoding="utf-8"?>
 <p:sld xmlns:a="http://schemas.openxmlformats.org/drawingml/2006/main" xmlns:r="http://schemas.openxmlformats.org/officeDocument/2006/relationships" xmlns:p="http://schemas.openxmlformats.org/presentationml/2006/main">
   <p:cSld>
     <p:spTree>
@@ -6872,8 +7177,8 @@
         </p:nvSpPr>
         <p:spPr>
           <a:xfrm>
-            <a:off x="731520" y="4754880"/>
-            <a:ext cx="10515600" cy="1671098"/>
+            <a:off x="731520" y="4846320"/>
+            <a:ext cx="10515600" cy="1645920"/>
           </a:xfrm>
           <a:prstGeom prst="rect">
             <a:avLst/>
@@ -6900,8 +7205,25 @@
               </a:defRPr>
             </a:pPr>
             <a:r>
-              <a:rPr dirty="0"/>
               <a:t>The high-income share has fallen from 76.3 per cent in 2018 to 54.5 per cent in 2026, while upper middle income countries have risen from 19.4 per cent to 41.7 per cent. In 2026, for the first time, upper middle income countries are generating nearly as many records as high-income countries.</a:t>
+            </a:r>
+          </a:p>
+          <a:p>
+            <a:pPr>
+              <a:lnSpc>
+                <a:spcPct val="130000"/>
+              </a:lnSpc>
+              <a:spcBef>
+                <a:spcPts val="800"/>
+              </a:spcBef>
+              <a:defRPr sz="1500" b="0">
+                <a:solidFill>
+                  <a:srgbClr val="1A1A1A"/>
+                </a:solidFill>
+              </a:defRPr>
+            </a:pPr>
+            <a:r>
+              <a:t>The 2021 spike to 84.7 per cent for high-income countries was driven by COVID-19 surveillance, particularly the COG-UK consortium. The subsequent decline reflects both the end of pandemic surveillance and continued growth in China and other upper middle income countries.</a:t>
             </a:r>
           </a:p>
           <a:p>
@@ -6919,7 +7241,6 @@
               </a:defRPr>
             </a:pPr>
             <a:r>
-              <a:rPr dirty="0"/>
               <a:t>Lower middle income and low-income countries have remained below 6 per cent combined throughout the entire period, showing almost no structural change in their share despite year-to-year fluctuations.</a:t>
             </a:r>
           </a:p>
@@ -6968,7 +7289,7 @@
 </p:sld>
 </file>
 
-<file path=ppt/slides/slide15.xml><?xml version="1.0" encoding="utf-8"?>
+<file path=ppt/slides/slide17.xml><?xml version="1.0" encoding="utf-8"?>
 <p:sld xmlns:a="http://schemas.openxmlformats.org/drawingml/2006/main" xmlns:r="http://schemas.openxmlformats.org/officeDocument/2006/relationships" xmlns:p="http://schemas.openxmlformats.org/presentationml/2006/main">
   <p:cSld>
     <p:spTree>
@@ -7504,7 +7825,7 @@
         <p:spPr>
           <a:xfrm>
             <a:off x="6217920" y="1554480"/>
-            <a:ext cx="5486400" cy="784830"/>
+            <a:ext cx="5486400" cy="2286000"/>
           </a:xfrm>
           <a:prstGeom prst="rect">
             <a:avLst/>
@@ -7518,6 +7839,18 @@
           <a:lstStyle/>
           <a:p>
             <a:pPr>
+              <a:defRPr sz="1800" b="1">
+                <a:solidFill>
+                  <a:srgbClr val="1F4E79"/>
+                </a:solidFill>
+              </a:defRPr>
+            </a:pPr>
+            <a:r>
+              <a:t>The Canada comparison</a:t>
+            </a:r>
+          </a:p>
+          <a:p>
+            <a:pPr>
               <a:spcBef>
                 <a:spcPts val="1200"/>
               </a:spcBef>
@@ -7528,7 +7861,6 @@
               </a:defRPr>
             </a:pPr>
             <a:r>
-              <a:rPr dirty="0"/>
               <a:t>47 LDCs combined: 527,519 records</a:t>
             </a:r>
           </a:p>
@@ -7544,7 +7876,6 @@
               </a:defRPr>
             </a:pPr>
             <a:r>
-              <a:rPr dirty="0"/>
               <a:t>Canada alone: 530,725 records</a:t>
             </a:r>
           </a:p>
@@ -7559,7 +7890,7 @@
         <p:spPr>
           <a:xfrm>
             <a:off x="731520" y="4114800"/>
-            <a:ext cx="10515600" cy="1026756"/>
+            <a:ext cx="10515600" cy="2286000"/>
           </a:xfrm>
           <a:prstGeom prst="rect">
             <a:avLst/>
@@ -7586,8 +7917,25 @@
               </a:defRPr>
             </a:pPr>
             <a:r>
-              <a:rPr dirty="0"/>
               <a:t>LDC records are highly volatile. A 407 per cent surge in 2022 was driven by a few large projects, not broad-based capacity growth. The following year, LDC records fell by 71 per cent. This illustrates how dependent these counts are on individual projects and funding cycles, rather than durable institutional capacity.</a:t>
+            </a:r>
+          </a:p>
+          <a:p>
+            <a:pPr>
+              <a:lnSpc>
+                <a:spcPct val="130000"/>
+              </a:lnSpc>
+              <a:spcBef>
+                <a:spcPts val="800"/>
+              </a:spcBef>
+              <a:defRPr sz="1600" b="0">
+                <a:solidFill>
+                  <a:srgbClr val="1A1A1A"/>
+                </a:solidFill>
+              </a:defRPr>
+            </a:pPr>
+            <a:r>
+              <a:t>The thin margin between 47 LDCs and a single G7 economy (approximately 3,200 records) could reverse with one large deposition. This fragility is itself a finding relevant to the Cali Fund equity objectives.</a:t>
             </a:r>
           </a:p>
         </p:txBody>
@@ -7600,7 +7948,7 @@
 </p:sld>
 </file>
 
-<file path=ppt/slides/slide16.xml><?xml version="1.0" encoding="utf-8"?>
+<file path=ppt/slides/slide18.xml><?xml version="1.0" encoding="utf-8"?>
 <p:sld xmlns:a="http://schemas.openxmlformats.org/drawingml/2006/main" xmlns:r="http://schemas.openxmlformats.org/officeDocument/2006/relationships" xmlns:p="http://schemas.openxmlformats.org/presentationml/2006/main">
   <p:cSld>
     <p:spTree>
@@ -8412,7 +8760,7 @@
 </p:sld>
 </file>
 
-<file path=ppt/slides/slide17.xml><?xml version="1.0" encoding="utf-8"?>
+<file path=ppt/slides/slide19.xml><?xml version="1.0" encoding="utf-8"?>
 <p:sld xmlns:a="http://schemas.openxmlformats.org/drawingml/2006/main" xmlns:r="http://schemas.openxmlformats.org/officeDocument/2006/relationships" xmlns:p="http://schemas.openxmlformats.org/presentationml/2006/main">
   <p:cSld>
     <p:spTree>
@@ -9669,7 +10017,7 @@
 </p:sld>
 </file>
 
-<file path=ppt/slides/slide18.xml><?xml version="1.0" encoding="utf-8"?>
+<file path=ppt/slides/slide2.xml><?xml version="1.0" encoding="utf-8"?>
 <p:sld xmlns:a="http://schemas.openxmlformats.org/drawingml/2006/main" xmlns:r="http://schemas.openxmlformats.org/officeDocument/2006/relationships" xmlns:p="http://schemas.openxmlformats.org/presentationml/2006/main">
   <p:cSld>
     <p:spTree>
@@ -9716,22 +10064,7 @@
               </a:defRPr>
             </a:pPr>
             <a:r>
-              <a:t>The COVID-19 distortion</a:t>
-            </a:r>
-          </a:p>
-          <a:p>
-            <a:pPr>
-              <a:spcBef>
-                <a:spcPts val="400"/>
-              </a:spcBef>
-              <a:defRPr sz="1600">
-                <a:solidFill>
-                  <a:srgbClr val="666666"/>
-                </a:solidFill>
-              </a:defRPr>
-            </a:pPr>
-            <a:r>
-              <a:t>Pandemic surveillance severely distorts temporal trends</a:t>
+              <a:t>Why this matters</a:t>
             </a:r>
           </a:p>
         </p:txBody>
@@ -9809,14 +10142,14 @@
               <a:spcBef>
                 <a:spcPts val="800"/>
               </a:spcBef>
-              <a:defRPr sz="1700" b="0">
+              <a:defRPr sz="1800" b="0">
                 <a:solidFill>
                   <a:srgbClr val="1A1A1A"/>
                 </a:solidFill>
               </a:defRPr>
             </a:pPr>
             <a:r>
-              <a:t>In 2021, UK records jumped from 162,561 to 1,651,232, a tenfold increase driven by the COVID-19 Genomics UK (COG-UK) consortium. Similar surges occurred in the United States and other developed countries with large genomic surveillance programmes.</a:t>
+              <a:t>The multilateral mechanism for benefit-sharing from digital sequence information (DSI), agreed at COP16 in Cali, includes a fund to which users of DSI are expected to contribute.</a:t>
             </a:r>
           </a:p>
           <a:p>
@@ -9827,14 +10160,14 @@
               <a:spcBef>
                 <a:spcPts val="800"/>
               </a:spcBef>
-              <a:defRPr sz="1700" b="0">
+              <a:defRPr sz="1800" b="0">
                 <a:solidFill>
                   <a:srgbClr val="1A1A1A"/>
                 </a:solidFill>
               </a:defRPr>
             </a:pPr>
             <a:r>
-              <a:t>This single event inflated the developed-country share by approximately 13 percentage points, from 69.9 per cent in 2020 to 83.3 per cent in 2021. The pandemic records are SARS-CoV-2 sequences, not biodiversity DSI, and they are not representative of the underlying trend.</a:t>
+              <a:t>A central question is how to allocate those funds among eligible countries. One proposed basis is the geographic distribution of sequence records in public databases: countries that are the source of many sequenced organisms might be considered to have contributed more to the global commons.</a:t>
             </a:r>
           </a:p>
           <a:p>
@@ -9845,14 +10178,14 @@
               <a:spcBef>
                 <a:spcPts val="800"/>
               </a:spcBef>
-              <a:defRPr sz="1700" b="0">
+              <a:defRPr sz="1800" b="0">
                 <a:solidFill>
                   <a:srgbClr val="1A1A1A"/>
                 </a:solidFill>
               </a:defRPr>
             </a:pPr>
             <a:r>
-              <a:t>The decline from 2021 onwards reflects two forces: the winding down of pandemic surveillance in developed countries, and continued growth in developing-country sequencing, particularly from China. It is not yet clear whether the convergence visible in 2026 will be sustained once pandemic records are no longer distorting the baseline.</a:t>
+              <a:t>This report tests whether INSDC provenance data are fit for that purpose. It does not prescribe a formula. Rather, it examines whether the data are complete enough, fair enough, and stable enough to support an allocation methodology.</a:t>
             </a:r>
           </a:p>
           <a:p>
@@ -9863,14 +10196,14 @@
               <a:spcBef>
                 <a:spcPts val="800"/>
               </a:spcBef>
-              <a:defRPr sz="1700" b="1">
-                <a:solidFill>
-                  <a:srgbClr val="1F4E79"/>
-                </a:solidFill>
-              </a:defRPr>
-            </a:pPr>
-            <a:r>
-              <a:t>To assess genuine trends in biodiversity DSI, a sensitivity view excluding SARS-CoV-2 records would be needed. This was not available for this report but should be a priority for future analysis.</a:t>
+              <a:defRPr sz="1400" b="0">
+                <a:solidFill>
+                  <a:srgbClr val="999999"/>
+                </a:solidFill>
+              </a:defRPr>
+            </a:pPr>
+            <a:r>
+              <a:t>INSDC: International Nucleotide Sequence Database Collaboration, comprising ENA (Europe), DDBJ (Japan), and NCBI (USA). The three databases exchange data daily.</a:t>
             </a:r>
           </a:p>
         </p:txBody>
@@ -9883,7 +10216,223 @@
 </p:sld>
 </file>
 
-<file path=ppt/slides/slide19.xml><?xml version="1.0" encoding="utf-8"?>
+<file path=ppt/slides/slide20.xml><?xml version="1.0" encoding="utf-8"?>
+<p:sld xmlns:a="http://schemas.openxmlformats.org/drawingml/2006/main" xmlns:r="http://schemas.openxmlformats.org/officeDocument/2006/relationships" xmlns:p="http://schemas.openxmlformats.org/presentationml/2006/main">
+  <p:cSld>
+    <p:spTree>
+      <p:nvGrpSpPr>
+        <p:cNvPr id="1" name=""/>
+        <p:cNvGrpSpPr/>
+        <p:nvPr/>
+      </p:nvGrpSpPr>
+      <p:grpSpPr>
+        <a:xfrm>
+          <a:off x="0" y="0"/>
+          <a:ext cx="0" cy="0"/>
+          <a:chOff x="0" y="0"/>
+          <a:chExt cx="0" cy="0"/>
+        </a:xfrm>
+      </p:grpSpPr>
+      <p:sp>
+        <p:nvSpPr>
+          <p:cNvPr id="2" name="TextBox 1"/>
+          <p:cNvSpPr txBox="1"/>
+          <p:nvPr/>
+        </p:nvSpPr>
+        <p:spPr>
+          <a:xfrm>
+            <a:off x="731520" y="365760"/>
+            <a:ext cx="10515600" cy="822960"/>
+          </a:xfrm>
+          <a:prstGeom prst="rect">
+            <a:avLst/>
+          </a:prstGeom>
+          <a:noFill/>
+        </p:spPr>
+        <p:txBody>
+          <a:bodyPr wrap="square">
+            <a:spAutoFit/>
+          </a:bodyPr>
+          <a:lstStyle/>
+          <a:p>
+            <a:pPr>
+              <a:defRPr sz="2800" b="1">
+                <a:solidFill>
+                  <a:srgbClr val="1F4E79"/>
+                </a:solidFill>
+              </a:defRPr>
+            </a:pPr>
+            <a:r>
+              <a:rPr dirty="0"/>
+              <a:t>COVID-19 distortion</a:t>
+            </a:r>
+          </a:p>
+          <a:p>
+            <a:pPr>
+              <a:spcBef>
+                <a:spcPts val="400"/>
+              </a:spcBef>
+              <a:defRPr sz="1600">
+                <a:solidFill>
+                  <a:srgbClr val="666666"/>
+                </a:solidFill>
+              </a:defRPr>
+            </a:pPr>
+            <a:r>
+              <a:rPr dirty="0"/>
+              <a:t>Pandemic surveillance severely distorts temporal trends</a:t>
+            </a:r>
+          </a:p>
+        </p:txBody>
+      </p:sp>
+      <p:sp>
+        <p:nvSpPr>
+          <p:cNvPr id="3" name="Rectangle 2"/>
+          <p:cNvSpPr/>
+          <p:nvPr/>
+        </p:nvSpPr>
+        <p:spPr>
+          <a:xfrm>
+            <a:off x="731520" y="1234440"/>
+            <a:ext cx="731520" cy="50800"/>
+          </a:xfrm>
+          <a:prstGeom prst="rect">
+            <a:avLst/>
+          </a:prstGeom>
+          <a:solidFill>
+            <a:srgbClr val="4E79A7"/>
+          </a:solidFill>
+          <a:ln>
+            <a:noFill/>
+          </a:ln>
+        </p:spPr>
+        <p:style>
+          <a:lnRef idx="1">
+            <a:schemeClr val="accent1"/>
+          </a:lnRef>
+          <a:fillRef idx="3">
+            <a:schemeClr val="accent1"/>
+          </a:fillRef>
+          <a:effectRef idx="2">
+            <a:schemeClr val="accent1"/>
+          </a:effectRef>
+          <a:fontRef idx="minor">
+            <a:schemeClr val="lt1"/>
+          </a:fontRef>
+        </p:style>
+        <p:txBody>
+          <a:bodyPr rtlCol="0" anchor="ctr"/>
+          <a:lstStyle/>
+          <a:p>
+            <a:pPr algn="ctr"/>
+            <a:endParaRPr/>
+          </a:p>
+        </p:txBody>
+      </p:sp>
+      <p:sp>
+        <p:nvSpPr>
+          <p:cNvPr id="4" name="TextBox 3"/>
+          <p:cNvSpPr txBox="1"/>
+          <p:nvPr/>
+        </p:nvSpPr>
+        <p:spPr>
+          <a:xfrm>
+            <a:off x="731520" y="1554480"/>
+            <a:ext cx="10515600" cy="4846320"/>
+          </a:xfrm>
+          <a:prstGeom prst="rect">
+            <a:avLst/>
+          </a:prstGeom>
+          <a:noFill/>
+        </p:spPr>
+        <p:txBody>
+          <a:bodyPr wrap="square">
+            <a:spAutoFit/>
+          </a:bodyPr>
+          <a:lstStyle/>
+          <a:p>
+            <a:pPr>
+              <a:lnSpc>
+                <a:spcPct val="130000"/>
+              </a:lnSpc>
+              <a:spcBef>
+                <a:spcPts val="800"/>
+              </a:spcBef>
+              <a:defRPr sz="1700" b="0">
+                <a:solidFill>
+                  <a:srgbClr val="1A1A1A"/>
+                </a:solidFill>
+              </a:defRPr>
+            </a:pPr>
+            <a:r>
+              <a:t>In 2021, UK records jumped from 162,561 to 1,651,232, a tenfold increase driven by the COVID-19 Genomics UK (COG-UK) consortium. Similar surges occurred in the United States and other developed countries with large genomic surveillance programmes.</a:t>
+            </a:r>
+          </a:p>
+          <a:p>
+            <a:pPr>
+              <a:lnSpc>
+                <a:spcPct val="130000"/>
+              </a:lnSpc>
+              <a:spcBef>
+                <a:spcPts val="800"/>
+              </a:spcBef>
+              <a:defRPr sz="1700" b="0">
+                <a:solidFill>
+                  <a:srgbClr val="1A1A1A"/>
+                </a:solidFill>
+              </a:defRPr>
+            </a:pPr>
+            <a:r>
+              <a:t>This single event inflated the developed-country share by approximately 13 percentage points, from 69.9 per cent in 2020 to 83.3 per cent in 2021. The pandemic records are SARS-CoV-2 sequences, not biodiversity DSI, and they are not representative of the underlying trend.</a:t>
+            </a:r>
+          </a:p>
+          <a:p>
+            <a:pPr>
+              <a:lnSpc>
+                <a:spcPct val="130000"/>
+              </a:lnSpc>
+              <a:spcBef>
+                <a:spcPts val="800"/>
+              </a:spcBef>
+              <a:defRPr sz="1700" b="0">
+                <a:solidFill>
+                  <a:srgbClr val="1A1A1A"/>
+                </a:solidFill>
+              </a:defRPr>
+            </a:pPr>
+            <a:r>
+              <a:t>The decline from 2021 onwards reflects two forces: the winding down of pandemic surveillance in developed countries, and continued growth in developing-country sequencing, particularly from China. It is not yet clear whether the convergence visible in 2026 will be sustained once pandemic records are no longer distorting the baseline.</a:t>
+            </a:r>
+          </a:p>
+          <a:p>
+            <a:pPr>
+              <a:lnSpc>
+                <a:spcPct val="130000"/>
+              </a:lnSpc>
+              <a:spcBef>
+                <a:spcPts val="800"/>
+              </a:spcBef>
+              <a:defRPr sz="1700" b="1">
+                <a:solidFill>
+                  <a:srgbClr val="1F4E79"/>
+                </a:solidFill>
+              </a:defRPr>
+            </a:pPr>
+            <a:r>
+              <a:t>To assess genuine trends in biodiversity DSI, a sensitivity view excluding SARS-CoV-2 records would be needed. This was not available for this report but should be a priority for future analysis.</a:t>
+            </a:r>
+          </a:p>
+        </p:txBody>
+      </p:sp>
+    </p:spTree>
+  </p:cSld>
+  <p:clrMapOvr>
+    <a:masterClrMapping/>
+  </p:clrMapOvr>
+</p:sld>
+</file>
+
+<file path=ppt/slides/slide21.xml><?xml version="1.0" encoding="utf-8"?>
 <p:sld xmlns:a="http://schemas.openxmlformats.org/drawingml/2006/main" xmlns:r="http://schemas.openxmlformats.org/officeDocument/2006/relationships" xmlns:p="http://schemas.openxmlformats.org/presentationml/2006/main">
   <p:cSld>
     <p:spTree>
@@ -10946,7 +11495,7 @@
 </p:sld>
 </file>
 
-<file path=ppt/slides/slide2.xml><?xml version="1.0" encoding="utf-8"?>
+<file path=ppt/slides/slide22.xml><?xml version="1.0" encoding="utf-8"?>
 <p:sld xmlns:a="http://schemas.openxmlformats.org/drawingml/2006/main" xmlns:r="http://schemas.openxmlformats.org/officeDocument/2006/relationships" xmlns:p="http://schemas.openxmlformats.org/presentationml/2006/main">
   <p:cSld>
     <p:spTree>
@@ -10993,7 +11542,22 @@
               </a:defRPr>
             </a:pPr>
             <a:r>
-              <a:t>Why this matters</a:t>
+              <a:t>Can INSDC data support allocation?</a:t>
+            </a:r>
+          </a:p>
+          <a:p>
+            <a:pPr>
+              <a:spcBef>
+                <a:spcPts val="400"/>
+              </a:spcBef>
+              <a:defRPr sz="1600">
+                <a:solidFill>
+                  <a:srgbClr val="666666"/>
+                </a:solidFill>
+              </a:defRPr>
+            </a:pPr>
+            <a:r>
+              <a:t>Four problems stand out</a:t>
             </a:r>
           </a:p>
         </p:txBody>
@@ -11071,15 +11635,32 @@
               <a:spcBef>
                 <a:spcPts val="800"/>
               </a:spcBef>
-              <a:defRPr sz="1800" b="0">
+              <a:defRPr sz="1800" b="1">
+                <a:solidFill>
+                  <a:srgbClr val="1F4E79"/>
+                </a:solidFill>
+              </a:defRPr>
+            </a:pPr>
+            <a:r>
+              <a:t>1.  Incompleteness</a:t>
+            </a:r>
+          </a:p>
+          <a:p>
+            <a:pPr lvl="1">
+              <a:lnSpc>
+                <a:spcPct val="130000"/>
+              </a:lnSpc>
+              <a:spcBef>
+                <a:spcPts val="400"/>
+              </a:spcBef>
+              <a:defRPr sz="1600" b="0">
                 <a:solidFill>
                   <a:srgbClr val="1A1A1A"/>
                 </a:solidFill>
               </a:defRPr>
             </a:pPr>
             <a:r>
-              <a:rPr dirty="0"/>
-              <a:t>The multilateral mechanism for benefit-sharing from digital sequence information (DSI), agreed at COP16 in Cali, includes a fund to which users of DSI are expected to contribute.</a:t>
+              <a:t>38.3 per cent of records cannot be attributed to any country, and 21.5 per cent have no date. The excluded fraction is not random.</a:t>
             </a:r>
           </a:p>
           <a:p>
@@ -11090,15 +11671,32 @@
               <a:spcBef>
                 <a:spcPts val="800"/>
               </a:spcBef>
-              <a:defRPr sz="1800" b="0">
+              <a:defRPr sz="1800" b="1">
+                <a:solidFill>
+                  <a:srgbClr val="1F4E79"/>
+                </a:solidFill>
+              </a:defRPr>
+            </a:pPr>
+            <a:r>
+              <a:t>2.  Concentration</a:t>
+            </a:r>
+          </a:p>
+          <a:p>
+            <a:pPr lvl="1">
+              <a:lnSpc>
+                <a:spcPct val="130000"/>
+              </a:lnSpc>
+              <a:spcBef>
+                <a:spcPts val="400"/>
+              </a:spcBef>
+              <a:defRPr sz="1600" b="0">
                 <a:solidFill>
                   <a:srgbClr val="1A1A1A"/>
                 </a:solidFill>
               </a:defRPr>
             </a:pPr>
             <a:r>
-              <a:rPr dirty="0"/>
-              <a:t>A central question is how to allocate those funds among eligible countries. One proposed basis is the geographic distribution of sequence records in public databases: countries that are the source of many sequenced organisms might be considered to have contributed more to the global commons.</a:t>
+              <a:t>Three countries account for 60.7 per cent of records. A formula based on raw counts would channel benefits to countries that already have substantial sequencing capacity.</a:t>
             </a:r>
           </a:p>
           <a:p>
@@ -11109,15 +11707,32 @@
               <a:spcBef>
                 <a:spcPts val="800"/>
               </a:spcBef>
-              <a:defRPr sz="1800" b="0">
+              <a:defRPr sz="1800" b="1">
+                <a:solidFill>
+                  <a:srgbClr val="1F4E79"/>
+                </a:solidFill>
+              </a:defRPr>
+            </a:pPr>
+            <a:r>
+              <a:t>3.  Distortion</a:t>
+            </a:r>
+          </a:p>
+          <a:p>
+            <a:pPr lvl="1">
+              <a:lnSpc>
+                <a:spcPct val="130000"/>
+              </a:lnSpc>
+              <a:spcBef>
+                <a:spcPts val="400"/>
+              </a:spcBef>
+              <a:defRPr sz="1600" b="0">
                 <a:solidFill>
                   <a:srgbClr val="1A1A1A"/>
                 </a:solidFill>
               </a:defRPr>
             </a:pPr>
             <a:r>
-              <a:rPr dirty="0"/>
-              <a:t>This report tests whether INSDC provenance data are fit for that purpose. It does not prescribe a formula. Rather, it examines whether the data are complete enough, fair enough, and stable enough to support an allocation methodology.</a:t>
+              <a:t>COVID-19 pandemic records severely distort temporal trends. The UK alone deposited 1.65 million records in 2021, ten times its 2020 count.</a:t>
             </a:r>
           </a:p>
           <a:p>
@@ -11128,15 +11743,32 @@
               <a:spcBef>
                 <a:spcPts val="800"/>
               </a:spcBef>
-              <a:defRPr sz="1400" b="0">
-                <a:solidFill>
-                  <a:srgbClr val="999999"/>
-                </a:solidFill>
-              </a:defRPr>
-            </a:pPr>
-            <a:r>
-              <a:rPr dirty="0"/>
-              <a:t>INSDC: International Nucleotide Sequence Database Collaboration, comprising ENA (Europe), DDBJ (Japan), and NCBI (USA). The three databases exchange data daily.</a:t>
+              <a:defRPr sz="1800" b="1">
+                <a:solidFill>
+                  <a:srgbClr val="1F4E79"/>
+                </a:solidFill>
+              </a:defRPr>
+            </a:pPr>
+            <a:r>
+              <a:t>4.  Mismatch</a:t>
+            </a:r>
+          </a:p>
+          <a:p>
+            <a:pPr lvl="1">
+              <a:lnSpc>
+                <a:spcPct val="130000"/>
+              </a:lnSpc>
+              <a:spcBef>
+                <a:spcPts val="400"/>
+              </a:spcBef>
+              <a:defRPr sz="1600" b="0">
+                <a:solidFill>
+                  <a:srgbClr val="1A1A1A"/>
+                </a:solidFill>
+              </a:defRPr>
+            </a:pPr>
+            <a:r>
+              <a:t>The country field records where a sample was collected, not who sequenced it. A Kenyan sample sequenced in the UK appears as Kenya.</a:t>
             </a:r>
           </a:p>
         </p:txBody>
@@ -11149,7 +11781,7 @@
 </p:sld>
 </file>
 
-<file path=ppt/slides/slide20.xml><?xml version="1.0" encoding="utf-8"?>
+<file path=ppt/slides/slide23.xml><?xml version="1.0" encoding="utf-8"?>
 <p:sld xmlns:a="http://schemas.openxmlformats.org/drawingml/2006/main" xmlns:r="http://schemas.openxmlformats.org/officeDocument/2006/relationships" xmlns:p="http://schemas.openxmlformats.org/presentationml/2006/main">
   <p:cSld>
     <p:spTree>
@@ -11196,22 +11828,7 @@
               </a:defRPr>
             </a:pPr>
             <a:r>
-              <a:t>Can INSDC data support allocation?</a:t>
-            </a:r>
-          </a:p>
-          <a:p>
-            <a:pPr>
-              <a:spcBef>
-                <a:spcPts val="400"/>
-              </a:spcBef>
-              <a:defRPr sz="1600">
-                <a:solidFill>
-                  <a:srgbClr val="666666"/>
-                </a:solidFill>
-              </a:defRPr>
-            </a:pPr>
-            <a:r>
-              <a:t>Four problems stand out</a:t>
+              <a:t>Conclusion and policy implications</a:t>
             </a:r>
           </a:p>
         </p:txBody>
@@ -11289,14 +11906,50 @@
               <a:spcBef>
                 <a:spcPts val="800"/>
               </a:spcBef>
-              <a:defRPr sz="1800" b="1">
+              <a:defRPr sz="2000" b="1">
                 <a:solidFill>
                   <a:srgbClr val="1F4E79"/>
                 </a:solidFill>
               </a:defRPr>
             </a:pPr>
             <a:r>
-              <a:t>1.  Incompleteness</a:t>
+              <a:t>INSDC provenance data should inform, but not determine, Cali Fund allocation decisions.</a:t>
+            </a:r>
+          </a:p>
+          <a:p>
+            <a:pPr>
+              <a:lnSpc>
+                <a:spcPct val="130000"/>
+              </a:lnSpc>
+              <a:spcBef>
+                <a:spcPts val="800"/>
+              </a:spcBef>
+              <a:defRPr sz="1700" b="0">
+                <a:solidFill>
+                  <a:srgbClr val="1A1A1A"/>
+                </a:solidFill>
+              </a:defRPr>
+            </a:pPr>
+            <a:r>
+              <a:t>The data are useful for identifying broad patterns of inequality, for monitoring trends over time, and for highlighting the specific needs of regions and country groups. They are not suitable as a direct input to an allocation formula because they are too incomplete, too concentrated, and too distorted by external events.</a:t>
+            </a:r>
+          </a:p>
+          <a:p>
+            <a:pPr>
+              <a:lnSpc>
+                <a:spcPct val="130000"/>
+              </a:lnSpc>
+              <a:spcBef>
+                <a:spcPts val="800"/>
+              </a:spcBef>
+              <a:defRPr sz="1700" b="1">
+                <a:solidFill>
+                  <a:srgbClr val="1A1A1A"/>
+                </a:solidFill>
+              </a:defRPr>
+            </a:pPr>
+            <a:r>
+              <a:t>A more robust approach might combine INSDC data with other indicators:</a:t>
             </a:r>
           </a:p>
           <a:p>
@@ -11309,30 +11962,12 @@
               </a:spcBef>
               <a:defRPr sz="1600" b="0">
                 <a:solidFill>
-                  <a:srgbClr val="1A1A1A"/>
-                </a:solidFill>
-              </a:defRPr>
-            </a:pPr>
-            <a:r>
-              <a:t>38.3 per cent of records cannot be attributed to any country, and 21.5 per cent have no date. The excluded fraction is not random.</a:t>
-            </a:r>
-          </a:p>
-          <a:p>
-            <a:pPr>
-              <a:lnSpc>
-                <a:spcPct val="130000"/>
-              </a:lnSpc>
-              <a:spcBef>
-                <a:spcPts val="800"/>
-              </a:spcBef>
-              <a:defRPr sz="1800" b="1">
-                <a:solidFill>
-                  <a:srgbClr val="1F4E79"/>
-                </a:solidFill>
-              </a:defRPr>
-            </a:pPr>
-            <a:r>
-              <a:t>2.  Concentration</a:t>
+                  <a:srgbClr val="666666"/>
+                </a:solidFill>
+              </a:defRPr>
+            </a:pPr>
+            <a:r>
+              <a:t>Biodiversity richness (for example, species counts from GBIF)</a:t>
             </a:r>
           </a:p>
           <a:p>
@@ -11345,30 +11980,12 @@
               </a:spcBef>
               <a:defRPr sz="1600" b="0">
                 <a:solidFill>
-                  <a:srgbClr val="1A1A1A"/>
-                </a:solidFill>
-              </a:defRPr>
-            </a:pPr>
-            <a:r>
-              <a:t>Three countries account for 60.7 per cent of records. A formula based on raw counts would channel benefits to countries that already have substantial sequencing capacity.</a:t>
-            </a:r>
-          </a:p>
-          <a:p>
-            <a:pPr>
-              <a:lnSpc>
-                <a:spcPct val="130000"/>
-              </a:lnSpc>
-              <a:spcBef>
-                <a:spcPts val="800"/>
-              </a:spcBef>
-              <a:defRPr sz="1800" b="1">
-                <a:solidFill>
-                  <a:srgbClr val="1F4E79"/>
-                </a:solidFill>
-              </a:defRPr>
-            </a:pPr>
-            <a:r>
-              <a:t>3.  Distortion</a:t>
+                  <a:srgbClr val="666666"/>
+                </a:solidFill>
+              </a:defRPr>
+            </a:pPr>
+            <a:r>
+              <a:t>Sequencing capacity (for example, number of sequencing facilities per country)</a:t>
             </a:r>
           </a:p>
           <a:p>
@@ -11381,12 +11998,12 @@
               </a:spcBef>
               <a:defRPr sz="1600" b="0">
                 <a:solidFill>
-                  <a:srgbClr val="1A1A1A"/>
-                </a:solidFill>
-              </a:defRPr>
-            </a:pPr>
-            <a:r>
-              <a:t>COVID-19 pandemic records severely distort temporal trends. The UK alone deposited 1.65 million records in 2021, ten times its 2020 count.</a:t>
+                  <a:srgbClr val="666666"/>
+                </a:solidFill>
+              </a:defRPr>
+            </a:pPr>
+            <a:r>
+              <a:t>Economic need (for example, GDP per capita or LDC/SIDS/LLDC status)</a:t>
             </a:r>
           </a:p>
           <a:p>
@@ -11397,32 +12014,14 @@
               <a:spcBef>
                 <a:spcPts val="800"/>
               </a:spcBef>
-              <a:defRPr sz="1800" b="1">
+              <a:defRPr sz="1700" b="1">
                 <a:solidFill>
                   <a:srgbClr val="1F4E79"/>
                 </a:solidFill>
               </a:defRPr>
             </a:pPr>
             <a:r>
-              <a:t>4.  Mismatch</a:t>
-            </a:r>
-          </a:p>
-          <a:p>
-            <a:pPr lvl="1">
-              <a:lnSpc>
-                <a:spcPct val="130000"/>
-              </a:lnSpc>
-              <a:spcBef>
-                <a:spcPts val="400"/>
-              </a:spcBef>
-              <a:defRPr sz="1600" b="0">
-                <a:solidFill>
-                  <a:srgbClr val="1A1A1A"/>
-                </a:solidFill>
-              </a:defRPr>
-            </a:pPr>
-            <a:r>
-              <a:t>The country field records where a sample was collected, not who sequenced it. A Kenyan sample sequenced in the UK appears as Kenya.</a:t>
+              <a:t>The Cali Fund allocation methodology should be a matter for Parties to negotiate, informed by evidence but not determined by it.</a:t>
             </a:r>
           </a:p>
         </p:txBody>
@@ -11435,7 +12034,7 @@
 </p:sld>
 </file>
 
-<file path=ppt/slides/slide21.xml><?xml version="1.0" encoding="utf-8"?>
+<file path=ppt/slides/slide24.xml><?xml version="1.0" encoding="utf-8"?>
 <p:sld xmlns:a="http://schemas.openxmlformats.org/drawingml/2006/main" xmlns:r="http://schemas.openxmlformats.org/officeDocument/2006/relationships" xmlns:p="http://schemas.openxmlformats.org/presentationml/2006/main">
   <p:cSld>
     <p:spTree>
@@ -11482,7 +12081,7 @@
               </a:defRPr>
             </a:pPr>
             <a:r>
-              <a:t>Conclusion and policy implications</a:t>
+              <a:t>Limitations</a:t>
             </a:r>
           </a:p>
         </p:txBody>
@@ -11540,274 +12139,6 @@
         <p:spPr>
           <a:xfrm>
             <a:off x="731520" y="1554480"/>
-            <a:ext cx="10515600" cy="3927485"/>
-          </a:xfrm>
-          <a:prstGeom prst="rect">
-            <a:avLst/>
-          </a:prstGeom>
-          <a:noFill/>
-        </p:spPr>
-        <p:txBody>
-          <a:bodyPr wrap="square">
-            <a:spAutoFit/>
-          </a:bodyPr>
-          <a:lstStyle/>
-          <a:p>
-            <a:pPr>
-              <a:lnSpc>
-                <a:spcPct val="130000"/>
-              </a:lnSpc>
-              <a:spcBef>
-                <a:spcPts val="800"/>
-              </a:spcBef>
-              <a:defRPr sz="2000" b="1">
-                <a:solidFill>
-                  <a:srgbClr val="1F4E79"/>
-                </a:solidFill>
-              </a:defRPr>
-            </a:pPr>
-            <a:r>
-              <a:rPr dirty="0"/>
-              <a:t>INSDC provenance data should inform, but not determine, Cali Fund allocation decisions.</a:t>
-            </a:r>
-          </a:p>
-          <a:p>
-            <a:pPr>
-              <a:lnSpc>
-                <a:spcPct val="130000"/>
-              </a:lnSpc>
-              <a:spcBef>
-                <a:spcPts val="800"/>
-              </a:spcBef>
-              <a:defRPr sz="1700" b="0">
-                <a:solidFill>
-                  <a:srgbClr val="1A1A1A"/>
-                </a:solidFill>
-              </a:defRPr>
-            </a:pPr>
-            <a:r>
-              <a:rPr dirty="0"/>
-              <a:t>The data are useful for identifying broad patterns of inequality, for monitoring trends over time, and for highlighting the specific needs of regions and country groups. They are not suitable as a direct input to an allocation formula because they are too incomplete, too concentrated, and too distorted by external events.</a:t>
-            </a:r>
-          </a:p>
-          <a:p>
-            <a:pPr>
-              <a:lnSpc>
-                <a:spcPct val="130000"/>
-              </a:lnSpc>
-              <a:spcBef>
-                <a:spcPts val="800"/>
-              </a:spcBef>
-              <a:defRPr sz="1700" b="1">
-                <a:solidFill>
-                  <a:srgbClr val="1A1A1A"/>
-                </a:solidFill>
-              </a:defRPr>
-            </a:pPr>
-            <a:r>
-              <a:rPr dirty="0"/>
-              <a:t>A more robust approach might combine INSDC data with other indicators:</a:t>
-            </a:r>
-          </a:p>
-          <a:p>
-            <a:pPr lvl="1">
-              <a:lnSpc>
-                <a:spcPct val="130000"/>
-              </a:lnSpc>
-              <a:spcBef>
-                <a:spcPts val="400"/>
-              </a:spcBef>
-              <a:defRPr sz="1600" b="0">
-                <a:solidFill>
-                  <a:srgbClr val="666666"/>
-                </a:solidFill>
-              </a:defRPr>
-            </a:pPr>
-            <a:r>
-              <a:rPr dirty="0"/>
-              <a:t>Biodiversity richness (for example, species counts from GBIF)</a:t>
-            </a:r>
-          </a:p>
-          <a:p>
-            <a:pPr lvl="1">
-              <a:lnSpc>
-                <a:spcPct val="130000"/>
-              </a:lnSpc>
-              <a:spcBef>
-                <a:spcPts val="400"/>
-              </a:spcBef>
-              <a:defRPr sz="1600" b="0">
-                <a:solidFill>
-                  <a:srgbClr val="666666"/>
-                </a:solidFill>
-              </a:defRPr>
-            </a:pPr>
-            <a:r>
-              <a:rPr dirty="0"/>
-              <a:t>Sequencing capacity (for example, number of sequencing facilities per country)</a:t>
-            </a:r>
-          </a:p>
-          <a:p>
-            <a:pPr lvl="1">
-              <a:lnSpc>
-                <a:spcPct val="130000"/>
-              </a:lnSpc>
-              <a:spcBef>
-                <a:spcPts val="400"/>
-              </a:spcBef>
-              <a:defRPr sz="1600" b="0">
-                <a:solidFill>
-                  <a:srgbClr val="666666"/>
-                </a:solidFill>
-              </a:defRPr>
-            </a:pPr>
-            <a:r>
-              <a:rPr dirty="0"/>
-              <a:t>Economic need (for example, </a:t>
-            </a:r>
-            <a:r>
-              <a:rPr lang="en-GB" dirty="0"/>
-              <a:t>inverted UN Scale of Assessment, inverted GNI</a:t>
-            </a:r>
-            <a:r>
-              <a:rPr dirty="0"/>
-              <a:t> or LDC/SIDS/LLDC status)</a:t>
-            </a:r>
-          </a:p>
-          <a:p>
-            <a:pPr>
-              <a:lnSpc>
-                <a:spcPct val="130000"/>
-              </a:lnSpc>
-              <a:spcBef>
-                <a:spcPts val="800"/>
-              </a:spcBef>
-              <a:defRPr sz="1700" b="1">
-                <a:solidFill>
-                  <a:srgbClr val="1F4E79"/>
-                </a:solidFill>
-              </a:defRPr>
-            </a:pPr>
-            <a:r>
-              <a:rPr dirty="0"/>
-              <a:t>The Cali Fund allocation methodology should be a matter for Parties to negotiate, informed by evidence but not determined by it.</a:t>
-            </a:r>
-          </a:p>
-        </p:txBody>
-      </p:sp>
-    </p:spTree>
-  </p:cSld>
-  <p:clrMapOvr>
-    <a:masterClrMapping/>
-  </p:clrMapOvr>
-</p:sld>
-</file>
-
-<file path=ppt/slides/slide22.xml><?xml version="1.0" encoding="utf-8"?>
-<p:sld xmlns:a="http://schemas.openxmlformats.org/drawingml/2006/main" xmlns:r="http://schemas.openxmlformats.org/officeDocument/2006/relationships" xmlns:p="http://schemas.openxmlformats.org/presentationml/2006/main">
-  <p:cSld>
-    <p:spTree>
-      <p:nvGrpSpPr>
-        <p:cNvPr id="1" name=""/>
-        <p:cNvGrpSpPr/>
-        <p:nvPr/>
-      </p:nvGrpSpPr>
-      <p:grpSpPr>
-        <a:xfrm>
-          <a:off x="0" y="0"/>
-          <a:ext cx="0" cy="0"/>
-          <a:chOff x="0" y="0"/>
-          <a:chExt cx="0" cy="0"/>
-        </a:xfrm>
-      </p:grpSpPr>
-      <p:sp>
-        <p:nvSpPr>
-          <p:cNvPr id="2" name="TextBox 1"/>
-          <p:cNvSpPr txBox="1"/>
-          <p:nvPr/>
-        </p:nvSpPr>
-        <p:spPr>
-          <a:xfrm>
-            <a:off x="731520" y="365760"/>
-            <a:ext cx="10515600" cy="822960"/>
-          </a:xfrm>
-          <a:prstGeom prst="rect">
-            <a:avLst/>
-          </a:prstGeom>
-          <a:noFill/>
-        </p:spPr>
-        <p:txBody>
-          <a:bodyPr wrap="square">
-            <a:spAutoFit/>
-          </a:bodyPr>
-          <a:lstStyle/>
-          <a:p>
-            <a:pPr>
-              <a:defRPr sz="2800" b="1">
-                <a:solidFill>
-                  <a:srgbClr val="1F4E79"/>
-                </a:solidFill>
-              </a:defRPr>
-            </a:pPr>
-            <a:r>
-              <a:t>Limitations</a:t>
-            </a:r>
-          </a:p>
-        </p:txBody>
-      </p:sp>
-      <p:sp>
-        <p:nvSpPr>
-          <p:cNvPr id="3" name="Rectangle 2"/>
-          <p:cNvSpPr/>
-          <p:nvPr/>
-        </p:nvSpPr>
-        <p:spPr>
-          <a:xfrm>
-            <a:off x="731520" y="1234440"/>
-            <a:ext cx="731520" cy="50800"/>
-          </a:xfrm>
-          <a:prstGeom prst="rect">
-            <a:avLst/>
-          </a:prstGeom>
-          <a:solidFill>
-            <a:srgbClr val="4E79A7"/>
-          </a:solidFill>
-          <a:ln>
-            <a:noFill/>
-          </a:ln>
-        </p:spPr>
-        <p:style>
-          <a:lnRef idx="1">
-            <a:schemeClr val="accent1"/>
-          </a:lnRef>
-          <a:fillRef idx="3">
-            <a:schemeClr val="accent1"/>
-          </a:fillRef>
-          <a:effectRef idx="2">
-            <a:schemeClr val="accent1"/>
-          </a:effectRef>
-          <a:fontRef idx="minor">
-            <a:schemeClr val="lt1"/>
-          </a:fontRef>
-        </p:style>
-        <p:txBody>
-          <a:bodyPr rtlCol="0" anchor="ctr"/>
-          <a:lstStyle/>
-          <a:p>
-            <a:pPr algn="ctr"/>
-            <a:endParaRPr/>
-          </a:p>
-        </p:txBody>
-      </p:sp>
-      <p:sp>
-        <p:nvSpPr>
-          <p:cNvPr id="4" name="TextBox 3"/>
-          <p:cNvSpPr txBox="1"/>
-          <p:nvPr/>
-        </p:nvSpPr>
-        <p:spPr>
-          <a:xfrm>
-            <a:off x="731520" y="1554480"/>
             <a:ext cx="10515600" cy="4846320"/>
           </a:xfrm>
           <a:prstGeom prst="rect">
@@ -11938,7 +12269,7 @@
 </p:sld>
 </file>
 
-<file path=ppt/slides/slide23.xml><?xml version="1.0" encoding="utf-8"?>
+<file path=ppt/slides/slide25.xml><?xml version="1.0" encoding="utf-8"?>
 <p:sld xmlns:a="http://schemas.openxmlformats.org/drawingml/2006/main" xmlns:r="http://schemas.openxmlformats.org/officeDocument/2006/relationships" xmlns:p="http://schemas.openxmlformats.org/presentationml/2006/main">
   <p:cSld>
     <p:bg>
@@ -12187,7 +12518,6 @@
               </a:defRPr>
             </a:pPr>
             <a:r>
-              <a:rPr dirty="0"/>
               <a:t>All counts were obtained from the European Nucleotide Archive (ENA) Portal API, which provides programmatic access to metadata for biological samples deposited in INSDC databases. ENA is the European partner of INSDC, which also includes DDBJ and NCBI. The three databases exchange data daily, so counts from ENA are representative of global holdings.</a:t>
             </a:r>
           </a:p>
@@ -12206,7 +12536,6 @@
               </a:defRPr>
             </a:pPr>
             <a:r>
-              <a:rPr dirty="0"/>
               <a:t>The analysis uses the sample record type, corresponding to one record per biological sample deposited. This is the appropriate unit for provenance questions because a single sample may generate multiple sequencing runs, and counting runs would inflate the numbers.</a:t>
             </a:r>
           </a:p>
@@ -12225,7 +12554,6 @@
               </a:defRPr>
             </a:pPr>
             <a:r>
-              <a:rPr dirty="0"/>
               <a:t>Three categories of records were excluded:</a:t>
             </a:r>
           </a:p>
@@ -12244,7 +12572,6 @@
               </a:defRPr>
             </a:pPr>
             <a:r>
-              <a:rPr dirty="0"/>
               <a:t>Human organism records, which are not relevant to biodiversity benefit-sharing</a:t>
             </a:r>
           </a:p>
@@ -12263,7 +12590,6 @@
               </a:defRPr>
             </a:pPr>
             <a:r>
-              <a:rPr dirty="0"/>
               <a:t>Human microbiome samples, where the host organism is a human</a:t>
             </a:r>
           </a:p>
@@ -12282,7 +12608,6 @@
               </a:defRPr>
             </a:pPr>
             <a:r>
-              <a:rPr dirty="0"/>
               <a:t>Synthetic constructs, which do not correspond to biological genetic resources</a:t>
             </a:r>
           </a:p>
@@ -12301,7 +12626,6 @@
               </a:defRPr>
             </a:pPr>
             <a:r>
-              <a:rPr dirty="0"/>
               <a:t>After applying these filters, the total record count was 30,313,212. This figure was verified by an independent query to the ENA API on the same date and matches exactly.</a:t>
             </a:r>
           </a:p>
@@ -12864,7 +13188,7 @@
         </p:nvGraphicFramePr>
         <p:xfrm>
           <a:off x="731520" y="1554480"/>
-          <a:ext cx="6858000" cy="2423160"/>
+          <a:ext cx="6858000" cy="1920240"/>
         </p:xfrm>
         <a:graphic>
           <a:graphicData uri="http://schemas.openxmlformats.org/drawingml/2006/table">
@@ -13433,7 +13757,7 @@
               </a:defRPr>
             </a:pPr>
             <a:r>
-              <a:t>Records without a country field over time</a:t>
+              <a:t>Records without usable country information over time</a:t>
             </a:r>
           </a:p>
           <a:p>
@@ -13448,7 +13772,7 @@
               </a:defRPr>
             </a:pPr>
             <a:r>
-              <a:t>Share of annual records with no country recorded, 2018 to 2026</a:t>
+              <a:t>Three measures of missing geographic data, 2018 to 2026</a:t>
             </a:r>
           </a:p>
         </p:txBody>
@@ -13514,7 +13838,7 @@
         <p:spPr>
           <a:xfrm>
             <a:off x="731520" y="1463040"/>
-            <a:ext cx="7315200" cy="3952493"/>
+            <a:ext cx="7315200" cy="3986415"/>
           </a:xfrm>
           <a:prstGeom prst="rect">
             <a:avLst/>
@@ -13568,14 +13892,14 @@
               <a:spcBef>
                 <a:spcPts val="600"/>
               </a:spcBef>
-              <a:defRPr sz="1400" b="0">
+              <a:defRPr sz="1300" b="0">
                 <a:solidFill>
                   <a:srgbClr val="1A1A1A"/>
                 </a:solidFill>
               </a:defRPr>
             </a:pPr>
             <a:r>
-              <a:t>The share of records with no country field has fallen dramatically, from 44.9 per cent in 2018 to 5.2 per cent in 2026.</a:t>
+              <a:t>Blue line: records with no country field at all, falling from 44.9 per cent to 5.2 per cent.</a:t>
             </a:r>
           </a:p>
           <a:p>
@@ -13586,14 +13910,14 @@
               <a:spcBef>
                 <a:spcPts val="600"/>
               </a:spcBef>
-              <a:defRPr sz="1400" b="0">
-                <a:solidFill>
-                  <a:srgbClr val="1A1A1A"/>
-                </a:solidFill>
-              </a:defRPr>
-            </a:pPr>
-            <a:r>
-              <a:t>The sharpest drop occurred in 2021, when COVID-19 surveillance records flooded the database. These records typically included proper country metadata.</a:t>
+              <a:defRPr sz="1300" b="0">
+                <a:solidFill>
+                  <a:srgbClr val="E15759"/>
+                </a:solidFill>
+              </a:defRPr>
+            </a:pPr>
+            <a:r>
+              <a:t>Red line: records where the field exists but contains the placeholder value “missing”, rising from 3.2 per cent to 17.3 per cent.</a:t>
             </a:r>
           </a:p>
           <a:p>
@@ -13604,14 +13928,14 @@
               <a:spcBef>
                 <a:spcPts val="600"/>
               </a:spcBef>
-              <a:defRPr sz="1400" b="0">
-                <a:solidFill>
-                  <a:srgbClr val="1A1A1A"/>
-                </a:solidFill>
-              </a:defRPr>
-            </a:pPr>
-            <a:r>
-              <a:t>The trend suggests improving data submission practices over time, which is encouraging for future use of these data.</a:t>
+              <a:defRPr sz="1300" b="0">
+                <a:solidFill>
+                  <a:srgbClr val="59A14F"/>
+                </a:solidFill>
+              </a:defRPr>
+            </a:pPr>
+            <a:r>
+              <a:t>Green line: the combined total with no usable country, falling from 48.1 per cent to 22.5 per cent.</a:t>
             </a:r>
           </a:p>
           <a:p>
@@ -13622,14 +13946,14 @@
               <a:spcBef>
                 <a:spcPts val="600"/>
               </a:spcBef>
-              <a:defRPr sz="1400" b="1">
+              <a:defRPr sz="1300" b="1">
                 <a:solidFill>
                   <a:srgbClr val="B07AA1"/>
                 </a:solidFill>
               </a:defRPr>
             </a:pPr>
             <a:r>
-              <a:t>However, the overall figure of 38.3 per cent without a country (across all years) reflects the historical backlog of poorly annotated records.</a:t>
+              <a:t>The field became compulsory, so submitters now include it. But many put “missing” as the value.</a:t>
             </a:r>
           </a:p>
         </p:txBody>
@@ -13664,7 +13988,7 @@
               </a:defRPr>
             </a:pPr>
             <a:r>
-              <a:t>Source: ENA Portal API, 13 October 2026. *2026 covers January to October only. Percentage is unattributed records divided by total records for each year.</a:t>
+              <a:t>Source: ENA Portal API, 13 October 2026. *2026 covers January to October only. Percentages are calculated against total records first published in each year.</a:t>
             </a:r>
           </a:p>
         </p:txBody>
@@ -13724,7 +14048,7 @@
               </a:defRPr>
             </a:pPr>
             <a:r>
-              <a:t>All-time sequence records by country</a:t>
+              <a:t>The substitution effect</a:t>
             </a:r>
           </a:p>
           <a:p>
@@ -13739,7 +14063,7 @@
               </a:defRPr>
             </a:pPr>
             <a:r>
-              <a:t>Total non-human records attributed to each country, all years combined</a:t>
+              <a:t>Making the field compulsory reduced absences but created placeholders</a:t>
             </a:r>
           </a:p>
         </p:txBody>
@@ -13788,40 +14112,16 @@
           </a:p>
         </p:txBody>
       </p:sp>
-      <p:pic>
-        <p:nvPicPr>
-          <p:cNvPr id="4" name="Picture 3" descr="heatmap_all_time.png"/>
-          <p:cNvPicPr>
-            <a:picLocks noChangeAspect="1"/>
-          </p:cNvPicPr>
-          <p:nvPr/>
-        </p:nvPicPr>
-        <p:blipFill>
-          <a:blip r:embed="rId2"/>
-          <a:stretch>
-            <a:fillRect/>
-          </a:stretch>
-        </p:blipFill>
-        <p:spPr>
-          <a:xfrm>
-            <a:off x="1371600" y="1463040"/>
-            <a:ext cx="9418320" cy="4709160"/>
-          </a:xfrm>
-          <a:prstGeom prst="rect">
-            <a:avLst/>
-          </a:prstGeom>
-        </p:spPr>
-      </p:pic>
       <p:sp>
         <p:nvSpPr>
-          <p:cNvPr id="5" name="TextBox 4"/>
+          <p:cNvPr id="4" name="TextBox 3"/>
           <p:cNvSpPr txBox="1"/>
           <p:nvPr/>
         </p:nvSpPr>
         <p:spPr>
           <a:xfrm>
-            <a:off x="2455695" y="6061353"/>
-            <a:ext cx="6337785" cy="430887"/>
+            <a:off x="731520" y="1554480"/>
+            <a:ext cx="10515600" cy="4846320"/>
           </a:xfrm>
           <a:prstGeom prst="rect">
             <a:avLst/>
@@ -13835,19 +14135,92 @@
           <a:lstStyle/>
           <a:p>
             <a:pPr>
-              <a:defRPr sz="1100" i="1">
-                <a:solidFill>
-                  <a:srgbClr val="999999"/>
-                </a:solidFill>
-              </a:defRPr>
-            </a:pPr>
-            <a:r>
-              <a:rPr lang="en-GB" dirty="0"/>
-              <a:t>A logarithmic scale</a:t>
-            </a:r>
-            <a:r>
-              <a:rPr dirty="0"/>
-              <a:t>: dark blue indicates the fewest records (around 2), white indicates approximately 4,000 records (the median country), and dark red indicates the most records (over 4 million). </a:t>
+              <a:lnSpc>
+                <a:spcPct val="130000"/>
+              </a:lnSpc>
+              <a:spcBef>
+                <a:spcPts val="800"/>
+              </a:spcBef>
+              <a:defRPr sz="1700" b="0">
+                <a:solidFill>
+                  <a:srgbClr val="1A1A1A"/>
+                </a:solidFill>
+              </a:defRPr>
+            </a:pPr>
+            <a:r>
+              <a:t>The country field is now compulsory in ENA submissions. This has worked: the share of records with no country field at all fell from 44.9 per cent in 2018 to 5.2 per cent in 2026.</a:t>
+            </a:r>
+          </a:p>
+          <a:p>
+            <a:pPr>
+              <a:lnSpc>
+                <a:spcPct val="130000"/>
+              </a:lnSpc>
+              <a:spcBef>
+                <a:spcPts val="800"/>
+              </a:spcBef>
+              <a:defRPr sz="1700" b="0">
+                <a:solidFill>
+                  <a:srgbClr val="1A1A1A"/>
+                </a:solidFill>
+              </a:defRPr>
+            </a:pPr>
+            <a:r>
+              <a:t>However, a new problem has emerged in its place. The share of records where the field is present but contains the placeholder value “missing” rose from 3.2 per cent in 2018 to 17.3 per cent in 2026. The surge began in 2023 and has stabilised at around 17 per cent.</a:t>
+            </a:r>
+          </a:p>
+          <a:p>
+            <a:pPr>
+              <a:lnSpc>
+                <a:spcPct val="130000"/>
+              </a:lnSpc>
+              <a:spcBef>
+                <a:spcPts val="800"/>
+              </a:spcBef>
+              <a:defRPr sz="1700" b="0">
+                <a:solidFill>
+                  <a:srgbClr val="1A1A1A"/>
+                </a:solidFill>
+              </a:defRPr>
+            </a:pPr>
+            <a:r>
+              <a:t>Taken together, the share of records with no usable country information has improved from 48.1 per cent to 22.5 per cent. This is genuine progress, but far less dramatic than the decline in field absences alone would suggest.</a:t>
+            </a:r>
+          </a:p>
+          <a:p>
+            <a:pPr>
+              <a:lnSpc>
+                <a:spcPct val="130000"/>
+              </a:lnSpc>
+              <a:spcBef>
+                <a:spcPts val="800"/>
+              </a:spcBef>
+              <a:defRPr sz="1600" b="0">
+                <a:solidFill>
+                  <a:srgbClr val="666666"/>
+                </a:solidFill>
+              </a:defRPr>
+            </a:pPr>
+            <a:r>
+              <a:t>The remaining 5.2 per cent with no field at all likely reflects submission pipelines that bypass the validation requirement, including bulk imports, legacy system migrations, and submissions made without a structured checklist.</a:t>
+            </a:r>
+          </a:p>
+          <a:p>
+            <a:pPr>
+              <a:lnSpc>
+                <a:spcPct val="130000"/>
+              </a:lnSpc>
+              <a:spcBef>
+                <a:spcPts val="800"/>
+              </a:spcBef>
+              <a:defRPr sz="1700" b="1">
+                <a:solidFill>
+                  <a:srgbClr val="1F4E79"/>
+                </a:solidFill>
+              </a:defRPr>
+            </a:pPr>
+            <a:r>
+              <a:t>Implication for allocation: any formula based on country-level counts must decide how to handle the 22.5 per cent of recent records with no usable country. Distributing them proportionally would inflate already-dominant countries; excluding them would undercount countries with poor metadata compliance.</a:t>
             </a:r>
           </a:p>
         </p:txBody>
@@ -13907,7 +14280,7 @@
               </a:defRPr>
             </a:pPr>
             <a:r>
-              <a:t>Sequence records since 2023 by country</a:t>
+              <a:t>Controlled vocabulary in theory, free text in practice</a:t>
             </a:r>
           </a:p>
           <a:p>
@@ -13922,7 +14295,7 @@
               </a:defRPr>
             </a:pPr>
             <a:r>
-              <a:t>Records with a first public release date in 2024, 2025, or 2026 (January to October)</a:t>
+              <a:t>The country field specification is not adequately enforced</a:t>
             </a:r>
           </a:p>
         </p:txBody>
@@ -13971,30 +14344,194 @@
           </a:p>
         </p:txBody>
       </p:sp>
-      <p:pic>
-        <p:nvPicPr>
-          <p:cNvPr id="4" name="Picture 3" descr="heatmap_post_2023.png"/>
-          <p:cNvPicPr>
-            <a:picLocks noChangeAspect="1"/>
-          </p:cNvPicPr>
+      <p:sp>
+        <p:nvSpPr>
+          <p:cNvPr id="4" name="TextBox 3"/>
+          <p:cNvSpPr txBox="1"/>
           <p:nvPr/>
-        </p:nvPicPr>
-        <p:blipFill>
-          <a:blip r:embed="rId2"/>
-          <a:stretch>
-            <a:fillRect/>
-          </a:stretch>
-        </p:blipFill>
+        </p:nvSpPr>
         <p:spPr>
           <a:xfrm>
-            <a:off x="1371600" y="1463040"/>
-            <a:ext cx="9418320" cy="4709160"/>
+            <a:off x="731520" y="1554480"/>
+            <a:ext cx="10515600" cy="4846320"/>
           </a:xfrm>
           <a:prstGeom prst="rect">
             <a:avLst/>
           </a:prstGeom>
+          <a:noFill/>
         </p:spPr>
-      </p:pic>
+        <p:txBody>
+          <a:bodyPr wrap="square">
+            <a:spAutoFit/>
+          </a:bodyPr>
+          <a:lstStyle/>
+          <a:p>
+            <a:pPr>
+              <a:lnSpc>
+                <a:spcPct val="130000"/>
+              </a:lnSpc>
+              <a:spcBef>
+                <a:spcPts val="800"/>
+              </a:spcBef>
+              <a:defRPr sz="1600" b="0">
+                <a:solidFill>
+                  <a:srgbClr val="1A1A1A"/>
+                </a:solidFill>
+              </a:defRPr>
+            </a:pPr>
+            <a:r>
+              <a:rPr dirty="0"/>
+              <a:t>The INSDC specification defines the country field (</a:t>
+            </a:r>
+            <a:r>
+              <a:rPr dirty="0" err="1"/>
+              <a:t>geo_loc_name</a:t>
+            </a:r>
+            <a:r>
+              <a:rPr dirty="0"/>
+              <a:t>) as a controlled vocabulary. The country portion must be one of approximately 296 approved values, with an optional free-text region and locality after a colon, for example “</a:t>
+            </a:r>
+            <a:r>
+              <a:rPr dirty="0" err="1"/>
+              <a:t>Canada:Vancouver</a:t>
+            </a:r>
+            <a:r>
+              <a:rPr dirty="0"/>
+              <a:t>”.</a:t>
+            </a:r>
+          </a:p>
+          <a:p>
+            <a:pPr>
+              <a:lnSpc>
+                <a:spcPct val="130000"/>
+              </a:lnSpc>
+              <a:spcBef>
+                <a:spcPts val="800"/>
+              </a:spcBef>
+              <a:defRPr sz="1600" b="1">
+                <a:solidFill>
+                  <a:srgbClr val="1A1A1A"/>
+                </a:solidFill>
+              </a:defRPr>
+            </a:pPr>
+            <a:r>
+              <a:rPr dirty="0"/>
+              <a:t>In practice, enforcement is weak:</a:t>
+            </a:r>
+          </a:p>
+          <a:p>
+            <a:pPr lvl="1">
+              <a:lnSpc>
+                <a:spcPct val="130000"/>
+              </a:lnSpc>
+              <a:spcBef>
+                <a:spcPts val="400"/>
+              </a:spcBef>
+              <a:defRPr sz="1500" b="0">
+                <a:solidFill>
+                  <a:srgbClr val="666666"/>
+                </a:solidFill>
+              </a:defRPr>
+            </a:pPr>
+            <a:r>
+              <a:rPr dirty="0"/>
+              <a:t>82 non-vocabulary values were found in the database, including alternative names (“UK” instead of “United Kingdom”), misspellings (“Columbia” instead of “Colombia”), and locality names entered without a country prefix.</a:t>
+            </a:r>
+          </a:p>
+          <a:p>
+            <a:pPr lvl="1">
+              <a:lnSpc>
+                <a:spcPct val="130000"/>
+              </a:lnSpc>
+              <a:spcBef>
+                <a:spcPts val="400"/>
+              </a:spcBef>
+              <a:defRPr sz="1500" b="0">
+                <a:solidFill>
+                  <a:srgbClr val="666666"/>
+                </a:solidFill>
+              </a:defRPr>
+            </a:pPr>
+            <a:r>
+              <a:rPr dirty="0"/>
+              <a:t>The placeholder “missing” is not an INSDC-approved null term, yet 17.3 per cent of 2026 records use it. INSDC maintains a separate list of approved null terms, but submitters are not using them.</a:t>
+            </a:r>
+          </a:p>
+          <a:p>
+            <a:pPr lvl="1">
+              <a:lnSpc>
+                <a:spcPct val="130000"/>
+              </a:lnSpc>
+              <a:spcBef>
+                <a:spcPts val="400"/>
+              </a:spcBef>
+              <a:defRPr sz="1500" b="0">
+                <a:solidFill>
+                  <a:srgbClr val="666666"/>
+                </a:solidFill>
+              </a:defRPr>
+            </a:pPr>
+            <a:r>
+              <a:rPr dirty="0"/>
+              <a:t>5.2 per cent of 2026 records have no country field at all, despite the field being compulsory since 2021.</a:t>
+            </a:r>
+          </a:p>
+          <a:p>
+            <a:pPr lvl="1">
+              <a:lnSpc>
+                <a:spcPct val="130000"/>
+              </a:lnSpc>
+              <a:spcBef>
+                <a:spcPts val="400"/>
+              </a:spcBef>
+              <a:defRPr sz="1500" b="0">
+                <a:solidFill>
+                  <a:srgbClr val="666666"/>
+                </a:solidFill>
+              </a:defRPr>
+            </a:pPr>
+            <a:r>
+              <a:rPr dirty="0"/>
+              <a:t>The free-text region and locality portion causes token-matching collisions, for example “USA: New Mexico” matching a query for “Mexico”.</a:t>
+            </a:r>
+          </a:p>
+          <a:p>
+            <a:pPr>
+              <a:lnSpc>
+                <a:spcPct val="130000"/>
+              </a:lnSpc>
+              <a:spcBef>
+                <a:spcPts val="800"/>
+              </a:spcBef>
+              <a:defRPr sz="1600" b="1">
+                <a:solidFill>
+                  <a:srgbClr val="1F4E79"/>
+                </a:solidFill>
+              </a:defRPr>
+            </a:pPr>
+            <a:r>
+              <a:rPr dirty="0"/>
+              <a:t>Recommendation: </a:t>
+            </a:r>
+            <a:r>
+              <a:rPr lang="en-GB" dirty="0"/>
+              <a:t>Enforcing </a:t>
+            </a:r>
+            <a:r>
+              <a:rPr dirty="0"/>
+              <a:t>the controlled vocabulary at submission time, rejecting records where the country portion is not from the approved list or where approved null terms are not used. This would improve data quality for all downstream uses, including </a:t>
+            </a:r>
+            <a:r>
+              <a:rPr lang="en-GB" dirty="0"/>
+              <a:t>identifying provenance and </a:t>
+            </a:r>
+            <a:r>
+              <a:rPr dirty="0"/>
+              <a:t>any future allocation methodology under the Cali Fund.</a:t>
+            </a:r>
+          </a:p>
+        </p:txBody>
+      </p:sp>
       <p:sp>
         <p:nvSpPr>
           <p:cNvPr id="5" name="TextBox 4"/>
@@ -14003,8 +14540,8 @@
         </p:nvSpPr>
         <p:spPr>
           <a:xfrm>
-            <a:off x="2181375" y="6015633"/>
-            <a:ext cx="6782626" cy="430887"/>
+            <a:off x="731520" y="6400800"/>
+            <a:ext cx="10515600" cy="365760"/>
           </a:xfrm>
           <a:prstGeom prst="rect">
             <a:avLst/>
@@ -14025,21 +14562,7 @@
               </a:defRPr>
             </a:pPr>
             <a:r>
-              <a:rPr lang="en-GB" dirty="0"/>
-              <a:t>A logarithmic scale: dark blue indicates the fewest records (around 2), white indicates approximately 4,000 records, </a:t>
-            </a:r>
-          </a:p>
-          <a:p>
-            <a:pPr>
-              <a:defRPr sz="1100" i="1">
-                <a:solidFill>
-                  <a:srgbClr val="999999"/>
-                </a:solidFill>
-              </a:defRPr>
-            </a:pPr>
-            <a:r>
-              <a:rPr lang="en-GB" dirty="0"/>
-              <a:t>and dark red indicates the most records (over 4 million). Colour scales used are identical for both maps. </a:t>
+              <a:t>Source: INSDC geo_loc_name qualifier specification (insdc.org), ENA Portal API verification (13 October 2026).</a:t>
             </a:r>
           </a:p>
         </p:txBody>

</xml_diff>

<commit_message>
Correct INSDC missing value reporting in presentation
- Correct slide 9: "missing" IS an approved INSDC term, not unapproved as previously stated
- INSDC requires "missing:" followed by a reporting-level reason (lab stock, not collected, restricted access, etc.)
- Bare "missing" and "missing:missing" are non-compliant uses
- Nuance slide 8: some "missing" values are legitimate (model organisms, endangered species, privacy)
- Updated enforcement recommendation to require valid reporting-level terms
- Backup of previous version saved

Co-authored-by: factory-droid[bot] <138933559+factory-droid[bot]@users.noreply.github.com>
</commit_message>
<xml_diff>
--- a/pipeline/output/DRAFT_global_sequence_accessions.pptx
+++ b/pipeline/output/DRAFT_global_sequence_accessions.pptx
@@ -5,33 +5,33 @@
     <p:sldMasterId id="2147483648" r:id="rId1"/>
   </p:sldMasterIdLst>
   <p:sldIdLst>
-    <p:sldId id="256" r:id="rId2"/>
-    <p:sldId id="257" r:id="rId3"/>
-    <p:sldId id="258" r:id="rId4"/>
-    <p:sldId id="259" r:id="rId5"/>
-    <p:sldId id="260" r:id="rId6"/>
-    <p:sldId id="261" r:id="rId7"/>
-    <p:sldId id="262" r:id="rId8"/>
-    <p:sldId id="263" r:id="rId9"/>
-    <p:sldId id="264" r:id="rId10"/>
-    <p:sldId id="265" r:id="rId11"/>
-    <p:sldId id="266" r:id="rId12"/>
-    <p:sldId id="267" r:id="rId13"/>
-    <p:sldId id="268" r:id="rId14"/>
-    <p:sldId id="269" r:id="rId15"/>
-    <p:sldId id="270" r:id="rId16"/>
-    <p:sldId id="271" r:id="rId17"/>
-    <p:sldId id="272" r:id="rId18"/>
-    <p:sldId id="273" r:id="rId19"/>
-    <p:sldId id="274" r:id="rId20"/>
-    <p:sldId id="275" r:id="rId21"/>
-    <p:sldId id="276" r:id="rId22"/>
-    <p:sldId id="277" r:id="rId23"/>
-    <p:sldId id="278" r:id="rId24"/>
-    <p:sldId id="279" r:id="rId25"/>
-    <p:sldId id="280" r:id="rId26"/>
+    <p:sldId id="256" r:id="rId7"/>
+    <p:sldId id="257" r:id="rId8"/>
+    <p:sldId id="258" r:id="rId9"/>
+    <p:sldId id="259" r:id="rId10"/>
+    <p:sldId id="260" r:id="rId11"/>
+    <p:sldId id="261" r:id="rId12"/>
+    <p:sldId id="262" r:id="rId13"/>
+    <p:sldId id="263" r:id="rId14"/>
+    <p:sldId id="264" r:id="rId15"/>
+    <p:sldId id="265" r:id="rId16"/>
+    <p:sldId id="266" r:id="rId17"/>
+    <p:sldId id="267" r:id="rId18"/>
+    <p:sldId id="268" r:id="rId19"/>
+    <p:sldId id="269" r:id="rId20"/>
+    <p:sldId id="270" r:id="rId21"/>
+    <p:sldId id="271" r:id="rId22"/>
+    <p:sldId id="272" r:id="rId23"/>
+    <p:sldId id="273" r:id="rId24"/>
+    <p:sldId id="274" r:id="rId25"/>
+    <p:sldId id="275" r:id="rId26"/>
+    <p:sldId id="276" r:id="rId27"/>
+    <p:sldId id="277" r:id="rId28"/>
+    <p:sldId id="278" r:id="rId29"/>
+    <p:sldId id="279" r:id="rId30"/>
+    <p:sldId id="280" r:id="rId31"/>
   </p:sldIdLst>
-  <p:sldSz cx="12192000" cy="6858000"/>
+  <p:sldSz cx="12191695" cy="6858000" type="screen4x3"/>
   <p:notesSz cx="6858000" cy="9144000"/>
   <p:defaultTextStyle>
     <a:defPPr>
@@ -128,22 +128,6 @@
       </a:defRPr>
     </a:lvl9pPr>
   </p:defaultTextStyle>
-  <p:extLst>
-    <p:ext uri="{EFAFB233-063F-42B5-8137-9DF3F51BA10A}">
-      <p15:sldGuideLst xmlns:p15="http://schemas.microsoft.com/office/powerpoint/2012/main">
-        <p15:guide id="1" orient="horz" pos="2160">
-          <p15:clr>
-            <a:srgbClr val="A4A3A4"/>
-          </p15:clr>
-        </p15:guide>
-        <p15:guide id="2" pos="2880">
-          <p15:clr>
-            <a:srgbClr val="A4A3A4"/>
-          </p15:clr>
-        </p15:guide>
-      </p15:sldGuideLst>
-    </p:ext>
-  </p:extLst>
 </p:presentation>
 </file>
 
@@ -185,9 +169,10 @@
           <a:lstStyle/>
           <a:p>
             <a:r>
-              <a:rPr lang="en-US"/>
+              <a:rPr lang="en-US" smtClean="0"/>
               <a:t>Click to edit Master title style</a:t>
             </a:r>
+            <a:endParaRPr lang="en-US"/>
           </a:p>
         </p:txBody>
       </p:sp>
@@ -303,9 +288,10 @@
           </a:lstStyle>
           <a:p>
             <a:r>
-              <a:rPr lang="en-US"/>
+              <a:rPr lang="en-US" smtClean="0"/>
               <a:t>Click to edit Master subtitle style</a:t>
             </a:r>
+            <a:endParaRPr lang="en-US"/>
           </a:p>
         </p:txBody>
       </p:sp>
@@ -326,7 +312,7 @@
           <a:p>
             <a:fld id="{5BCAD085-E8A6-8845-BD4E-CB4CCA059FC4}" type="datetimeFigureOut">
               <a:rPr lang="en-US" smtClean="0"/>
-              <a:t>10/14/26</a:t>
+              <a:t>1/27/13</a:t>
             </a:fld>
             <a:endParaRPr lang="en-US"/>
           </a:p>
@@ -420,9 +406,10 @@
           <a:lstStyle/>
           <a:p>
             <a:r>
-              <a:rPr lang="en-US"/>
+              <a:rPr lang="en-US" smtClean="0"/>
               <a:t>Click to edit Master title style</a:t>
             </a:r>
+            <a:endParaRPr lang="en-US"/>
           </a:p>
         </p:txBody>
       </p:sp>
@@ -443,37 +430,38 @@
           <a:p>
             <a:pPr lvl="0"/>
             <a:r>
-              <a:rPr lang="en-US"/>
+              <a:rPr lang="en-US" smtClean="0"/>
               <a:t>Click to edit Master text styles</a:t>
             </a:r>
           </a:p>
           <a:p>
             <a:pPr lvl="1"/>
             <a:r>
-              <a:rPr lang="en-US"/>
+              <a:rPr lang="en-US" smtClean="0"/>
               <a:t>Second level</a:t>
             </a:r>
           </a:p>
           <a:p>
             <a:pPr lvl="2"/>
             <a:r>
-              <a:rPr lang="en-US"/>
+              <a:rPr lang="en-US" smtClean="0"/>
               <a:t>Third level</a:t>
             </a:r>
           </a:p>
           <a:p>
             <a:pPr lvl="3"/>
             <a:r>
-              <a:rPr lang="en-US"/>
+              <a:rPr lang="en-US" smtClean="0"/>
               <a:t>Fourth level</a:t>
             </a:r>
           </a:p>
           <a:p>
             <a:pPr lvl="4"/>
             <a:r>
-              <a:rPr lang="en-US"/>
+              <a:rPr lang="en-US" smtClean="0"/>
               <a:t>Fifth level</a:t>
             </a:r>
+            <a:endParaRPr lang="en-US"/>
           </a:p>
         </p:txBody>
       </p:sp>
@@ -494,7 +482,7 @@
           <a:p>
             <a:fld id="{5BCAD085-E8A6-8845-BD4E-CB4CCA059FC4}" type="datetimeFigureOut">
               <a:rPr lang="en-US" smtClean="0"/>
-              <a:t>10/14/26</a:t>
+              <a:t>1/27/13</a:t>
             </a:fld>
             <a:endParaRPr lang="en-US"/>
           </a:p>
@@ -593,9 +581,10 @@
           <a:lstStyle/>
           <a:p>
             <a:r>
-              <a:rPr lang="en-US"/>
+              <a:rPr lang="en-US" smtClean="0"/>
               <a:t>Click to edit Master title style</a:t>
             </a:r>
+            <a:endParaRPr lang="en-US"/>
           </a:p>
         </p:txBody>
       </p:sp>
@@ -621,37 +610,38 @@
           <a:p>
             <a:pPr lvl="0"/>
             <a:r>
-              <a:rPr lang="en-US"/>
+              <a:rPr lang="en-US" smtClean="0"/>
               <a:t>Click to edit Master text styles</a:t>
             </a:r>
           </a:p>
           <a:p>
             <a:pPr lvl="1"/>
             <a:r>
-              <a:rPr lang="en-US"/>
+              <a:rPr lang="en-US" smtClean="0"/>
               <a:t>Second level</a:t>
             </a:r>
           </a:p>
           <a:p>
             <a:pPr lvl="2"/>
             <a:r>
-              <a:rPr lang="en-US"/>
+              <a:rPr lang="en-US" smtClean="0"/>
               <a:t>Third level</a:t>
             </a:r>
           </a:p>
           <a:p>
             <a:pPr lvl="3"/>
             <a:r>
-              <a:rPr lang="en-US"/>
+              <a:rPr lang="en-US" smtClean="0"/>
               <a:t>Fourth level</a:t>
             </a:r>
           </a:p>
           <a:p>
             <a:pPr lvl="4"/>
             <a:r>
-              <a:rPr lang="en-US"/>
+              <a:rPr lang="en-US" smtClean="0"/>
               <a:t>Fifth level</a:t>
             </a:r>
+            <a:endParaRPr lang="en-US"/>
           </a:p>
         </p:txBody>
       </p:sp>
@@ -672,7 +662,7 @@
           <a:p>
             <a:fld id="{5BCAD085-E8A6-8845-BD4E-CB4CCA059FC4}" type="datetimeFigureOut">
               <a:rPr lang="en-US" smtClean="0"/>
-              <a:t>10/14/26</a:t>
+              <a:t>1/27/13</a:t>
             </a:fld>
             <a:endParaRPr lang="en-US"/>
           </a:p>
@@ -766,9 +756,10 @@
           <a:lstStyle/>
           <a:p>
             <a:r>
-              <a:rPr lang="en-US"/>
+              <a:rPr lang="en-US" smtClean="0"/>
               <a:t>Click to edit Master title style</a:t>
             </a:r>
+            <a:endParaRPr lang="en-US"/>
           </a:p>
         </p:txBody>
       </p:sp>
@@ -789,37 +780,38 @@
           <a:p>
             <a:pPr lvl="0"/>
             <a:r>
-              <a:rPr lang="en-US"/>
+              <a:rPr lang="en-US" smtClean="0"/>
               <a:t>Click to edit Master text styles</a:t>
             </a:r>
           </a:p>
           <a:p>
             <a:pPr lvl="1"/>
             <a:r>
-              <a:rPr lang="en-US"/>
+              <a:rPr lang="en-US" smtClean="0"/>
               <a:t>Second level</a:t>
             </a:r>
           </a:p>
           <a:p>
             <a:pPr lvl="2"/>
             <a:r>
-              <a:rPr lang="en-US"/>
+              <a:rPr lang="en-US" smtClean="0"/>
               <a:t>Third level</a:t>
             </a:r>
           </a:p>
           <a:p>
             <a:pPr lvl="3"/>
             <a:r>
-              <a:rPr lang="en-US"/>
+              <a:rPr lang="en-US" smtClean="0"/>
               <a:t>Fourth level</a:t>
             </a:r>
           </a:p>
           <a:p>
             <a:pPr lvl="4"/>
             <a:r>
-              <a:rPr lang="en-US"/>
+              <a:rPr lang="en-US" smtClean="0"/>
               <a:t>Fifth level</a:t>
             </a:r>
+            <a:endParaRPr lang="en-US"/>
           </a:p>
         </p:txBody>
       </p:sp>
@@ -840,7 +832,7 @@
           <a:p>
             <a:fld id="{5BCAD085-E8A6-8845-BD4E-CB4CCA059FC4}" type="datetimeFigureOut">
               <a:rPr lang="en-US" smtClean="0"/>
-              <a:t>10/14/26</a:t>
+              <a:t>1/27/13</a:t>
             </a:fld>
             <a:endParaRPr lang="en-US"/>
           </a:p>
@@ -943,9 +935,10 @@
           </a:lstStyle>
           <a:p>
             <a:r>
-              <a:rPr lang="en-US"/>
+              <a:rPr lang="en-US" smtClean="0"/>
               <a:t>Click to edit Master title style</a:t>
             </a:r>
+            <a:endParaRPr lang="en-US"/>
           </a:p>
         </p:txBody>
       </p:sp>
@@ -1062,7 +1055,7 @@
           <a:p>
             <a:pPr lvl="0"/>
             <a:r>
-              <a:rPr lang="en-US"/>
+              <a:rPr lang="en-US" smtClean="0"/>
               <a:t>Click to edit Master text styles</a:t>
             </a:r>
           </a:p>
@@ -1085,7 +1078,7 @@
           <a:p>
             <a:fld id="{5BCAD085-E8A6-8845-BD4E-CB4CCA059FC4}" type="datetimeFigureOut">
               <a:rPr lang="en-US" smtClean="0"/>
-              <a:t>10/14/26</a:t>
+              <a:t>1/27/13</a:t>
             </a:fld>
             <a:endParaRPr lang="en-US"/>
           </a:p>
@@ -1179,9 +1172,10 @@
           <a:lstStyle/>
           <a:p>
             <a:r>
-              <a:rPr lang="en-US"/>
+              <a:rPr lang="en-US" smtClean="0"/>
               <a:t>Click to edit Master title style</a:t>
             </a:r>
+            <a:endParaRPr lang="en-US"/>
           </a:p>
         </p:txBody>
       </p:sp>
@@ -1235,37 +1229,38 @@
           <a:p>
             <a:pPr lvl="0"/>
             <a:r>
-              <a:rPr lang="en-US"/>
+              <a:rPr lang="en-US" smtClean="0"/>
               <a:t>Click to edit Master text styles</a:t>
             </a:r>
           </a:p>
           <a:p>
             <a:pPr lvl="1"/>
             <a:r>
-              <a:rPr lang="en-US"/>
+              <a:rPr lang="en-US" smtClean="0"/>
               <a:t>Second level</a:t>
             </a:r>
           </a:p>
           <a:p>
             <a:pPr lvl="2"/>
             <a:r>
-              <a:rPr lang="en-US"/>
+              <a:rPr lang="en-US" smtClean="0"/>
               <a:t>Third level</a:t>
             </a:r>
           </a:p>
           <a:p>
             <a:pPr lvl="3"/>
             <a:r>
-              <a:rPr lang="en-US"/>
+              <a:rPr lang="en-US" smtClean="0"/>
               <a:t>Fourth level</a:t>
             </a:r>
           </a:p>
           <a:p>
             <a:pPr lvl="4"/>
             <a:r>
-              <a:rPr lang="en-US"/>
+              <a:rPr lang="en-US" smtClean="0"/>
               <a:t>Fifth level</a:t>
             </a:r>
+            <a:endParaRPr lang="en-US"/>
           </a:p>
         </p:txBody>
       </p:sp>
@@ -1319,37 +1314,38 @@
           <a:p>
             <a:pPr lvl="0"/>
             <a:r>
-              <a:rPr lang="en-US"/>
+              <a:rPr lang="en-US" smtClean="0"/>
               <a:t>Click to edit Master text styles</a:t>
             </a:r>
           </a:p>
           <a:p>
             <a:pPr lvl="1"/>
             <a:r>
-              <a:rPr lang="en-US"/>
+              <a:rPr lang="en-US" smtClean="0"/>
               <a:t>Second level</a:t>
             </a:r>
           </a:p>
           <a:p>
             <a:pPr lvl="2"/>
             <a:r>
-              <a:rPr lang="en-US"/>
+              <a:rPr lang="en-US" smtClean="0"/>
               <a:t>Third level</a:t>
             </a:r>
           </a:p>
           <a:p>
             <a:pPr lvl="3"/>
             <a:r>
-              <a:rPr lang="en-US"/>
+              <a:rPr lang="en-US" smtClean="0"/>
               <a:t>Fourth level</a:t>
             </a:r>
           </a:p>
           <a:p>
             <a:pPr lvl="4"/>
             <a:r>
-              <a:rPr lang="en-US"/>
+              <a:rPr lang="en-US" smtClean="0"/>
               <a:t>Fifth level</a:t>
             </a:r>
+            <a:endParaRPr lang="en-US"/>
           </a:p>
         </p:txBody>
       </p:sp>
@@ -1370,7 +1366,7 @@
           <a:p>
             <a:fld id="{5BCAD085-E8A6-8845-BD4E-CB4CCA059FC4}" type="datetimeFigureOut">
               <a:rPr lang="en-US" smtClean="0"/>
-              <a:t>10/14/26</a:t>
+              <a:t>1/27/13</a:t>
             </a:fld>
             <a:endParaRPr lang="en-US"/>
           </a:p>
@@ -1468,9 +1464,10 @@
           </a:lstStyle>
           <a:p>
             <a:r>
-              <a:rPr lang="en-US"/>
+              <a:rPr lang="en-US" smtClean="0"/>
               <a:t>Click to edit Master title style</a:t>
             </a:r>
+            <a:endParaRPr lang="en-US"/>
           </a:p>
         </p:txBody>
       </p:sp>
@@ -1533,7 +1530,7 @@
           <a:p>
             <a:pPr lvl="0"/>
             <a:r>
-              <a:rPr lang="en-US"/>
+              <a:rPr lang="en-US" smtClean="0"/>
               <a:t>Click to edit Master text styles</a:t>
             </a:r>
           </a:p>
@@ -1589,37 +1586,38 @@
           <a:p>
             <a:pPr lvl="0"/>
             <a:r>
-              <a:rPr lang="en-US"/>
+              <a:rPr lang="en-US" smtClean="0"/>
               <a:t>Click to edit Master text styles</a:t>
             </a:r>
           </a:p>
           <a:p>
             <a:pPr lvl="1"/>
             <a:r>
-              <a:rPr lang="en-US"/>
+              <a:rPr lang="en-US" smtClean="0"/>
               <a:t>Second level</a:t>
             </a:r>
           </a:p>
           <a:p>
             <a:pPr lvl="2"/>
             <a:r>
-              <a:rPr lang="en-US"/>
+              <a:rPr lang="en-US" smtClean="0"/>
               <a:t>Third level</a:t>
             </a:r>
           </a:p>
           <a:p>
             <a:pPr lvl="3"/>
             <a:r>
-              <a:rPr lang="en-US"/>
+              <a:rPr lang="en-US" smtClean="0"/>
               <a:t>Fourth level</a:t>
             </a:r>
           </a:p>
           <a:p>
             <a:pPr lvl="4"/>
             <a:r>
-              <a:rPr lang="en-US"/>
+              <a:rPr lang="en-US" smtClean="0"/>
               <a:t>Fifth level</a:t>
             </a:r>
+            <a:endParaRPr lang="en-US"/>
           </a:p>
         </p:txBody>
       </p:sp>
@@ -1682,7 +1680,7 @@
           <a:p>
             <a:pPr lvl="0"/>
             <a:r>
-              <a:rPr lang="en-US"/>
+              <a:rPr lang="en-US" smtClean="0"/>
               <a:t>Click to edit Master text styles</a:t>
             </a:r>
           </a:p>
@@ -1738,37 +1736,38 @@
           <a:p>
             <a:pPr lvl="0"/>
             <a:r>
-              <a:rPr lang="en-US"/>
+              <a:rPr lang="en-US" smtClean="0"/>
               <a:t>Click to edit Master text styles</a:t>
             </a:r>
           </a:p>
           <a:p>
             <a:pPr lvl="1"/>
             <a:r>
-              <a:rPr lang="en-US"/>
+              <a:rPr lang="en-US" smtClean="0"/>
               <a:t>Second level</a:t>
             </a:r>
           </a:p>
           <a:p>
             <a:pPr lvl="2"/>
             <a:r>
-              <a:rPr lang="en-US"/>
+              <a:rPr lang="en-US" smtClean="0"/>
               <a:t>Third level</a:t>
             </a:r>
           </a:p>
           <a:p>
             <a:pPr lvl="3"/>
             <a:r>
-              <a:rPr lang="en-US"/>
+              <a:rPr lang="en-US" smtClean="0"/>
               <a:t>Fourth level</a:t>
             </a:r>
           </a:p>
           <a:p>
             <a:pPr lvl="4"/>
             <a:r>
-              <a:rPr lang="en-US"/>
+              <a:rPr lang="en-US" smtClean="0"/>
               <a:t>Fifth level</a:t>
             </a:r>
+            <a:endParaRPr lang="en-US"/>
           </a:p>
         </p:txBody>
       </p:sp>
@@ -1789,7 +1788,7 @@
           <a:p>
             <a:fld id="{5BCAD085-E8A6-8845-BD4E-CB4CCA059FC4}" type="datetimeFigureOut">
               <a:rPr lang="en-US" smtClean="0"/>
-              <a:t>10/14/26</a:t>
+              <a:t>1/27/13</a:t>
             </a:fld>
             <a:endParaRPr lang="en-US"/>
           </a:p>
@@ -1883,9 +1882,10 @@
           <a:lstStyle/>
           <a:p>
             <a:r>
-              <a:rPr lang="en-US"/>
+              <a:rPr lang="en-US" smtClean="0"/>
               <a:t>Click to edit Master title style</a:t>
             </a:r>
+            <a:endParaRPr lang="en-US"/>
           </a:p>
         </p:txBody>
       </p:sp>
@@ -1906,7 +1906,7 @@
           <a:p>
             <a:fld id="{5BCAD085-E8A6-8845-BD4E-CB4CCA059FC4}" type="datetimeFigureOut">
               <a:rPr lang="en-US" smtClean="0"/>
-              <a:t>10/14/26</a:t>
+              <a:t>1/27/13</a:t>
             </a:fld>
             <a:endParaRPr lang="en-US"/>
           </a:p>
@@ -2001,7 +2001,7 @@
           <a:p>
             <a:fld id="{5BCAD085-E8A6-8845-BD4E-CB4CCA059FC4}" type="datetimeFigureOut">
               <a:rPr lang="en-US" smtClean="0"/>
-              <a:t>10/14/26</a:t>
+              <a:t>1/27/13</a:t>
             </a:fld>
             <a:endParaRPr lang="en-US"/>
           </a:p>
@@ -2104,9 +2104,10 @@
           </a:lstStyle>
           <a:p>
             <a:r>
-              <a:rPr lang="en-US"/>
+              <a:rPr lang="en-US" smtClean="0"/>
               <a:t>Click to edit Master title style</a:t>
             </a:r>
+            <a:endParaRPr lang="en-US"/>
           </a:p>
         </p:txBody>
       </p:sp>
@@ -2160,37 +2161,38 @@
           <a:p>
             <a:pPr lvl="0"/>
             <a:r>
-              <a:rPr lang="en-US"/>
+              <a:rPr lang="en-US" smtClean="0"/>
               <a:t>Click to edit Master text styles</a:t>
             </a:r>
           </a:p>
           <a:p>
             <a:pPr lvl="1"/>
             <a:r>
-              <a:rPr lang="en-US"/>
+              <a:rPr lang="en-US" smtClean="0"/>
               <a:t>Second level</a:t>
             </a:r>
           </a:p>
           <a:p>
             <a:pPr lvl="2"/>
             <a:r>
-              <a:rPr lang="en-US"/>
+              <a:rPr lang="en-US" smtClean="0"/>
               <a:t>Third level</a:t>
             </a:r>
           </a:p>
           <a:p>
             <a:pPr lvl="3"/>
             <a:r>
-              <a:rPr lang="en-US"/>
+              <a:rPr lang="en-US" smtClean="0"/>
               <a:t>Fourth level</a:t>
             </a:r>
           </a:p>
           <a:p>
             <a:pPr lvl="4"/>
             <a:r>
-              <a:rPr lang="en-US"/>
+              <a:rPr lang="en-US" smtClean="0"/>
               <a:t>Fifth level</a:t>
             </a:r>
+            <a:endParaRPr lang="en-US"/>
           </a:p>
         </p:txBody>
       </p:sp>
@@ -2253,7 +2255,7 @@
           <a:p>
             <a:pPr lvl="0"/>
             <a:r>
-              <a:rPr lang="en-US"/>
+              <a:rPr lang="en-US" smtClean="0"/>
               <a:t>Click to edit Master text styles</a:t>
             </a:r>
           </a:p>
@@ -2276,7 +2278,7 @@
           <a:p>
             <a:fld id="{5BCAD085-E8A6-8845-BD4E-CB4CCA059FC4}" type="datetimeFigureOut">
               <a:rPr lang="en-US" smtClean="0"/>
-              <a:t>10/14/26</a:t>
+              <a:t>1/27/13</a:t>
             </a:fld>
             <a:endParaRPr lang="en-US"/>
           </a:p>
@@ -2379,9 +2381,10 @@
           </a:lstStyle>
           <a:p>
             <a:r>
-              <a:rPr lang="en-US"/>
+              <a:rPr lang="en-US" smtClean="0"/>
               <a:t>Click to edit Master title style</a:t>
             </a:r>
+            <a:endParaRPr lang="en-US"/>
           </a:p>
         </p:txBody>
       </p:sp>
@@ -2505,7 +2508,7 @@
           <a:p>
             <a:pPr lvl="0"/>
             <a:r>
-              <a:rPr lang="en-US"/>
+              <a:rPr lang="en-US" smtClean="0"/>
               <a:t>Click to edit Master text styles</a:t>
             </a:r>
           </a:p>
@@ -2528,7 +2531,7 @@
           <a:p>
             <a:fld id="{5BCAD085-E8A6-8845-BD4E-CB4CCA059FC4}" type="datetimeFigureOut">
               <a:rPr lang="en-US" smtClean="0"/>
-              <a:t>10/14/26</a:t>
+              <a:t>1/27/13</a:t>
             </a:fld>
             <a:endParaRPr lang="en-US"/>
           </a:p>
@@ -2637,9 +2640,10 @@
           <a:lstStyle/>
           <a:p>
             <a:r>
-              <a:rPr lang="en-US"/>
+              <a:rPr lang="en-US" smtClean="0"/>
               <a:t>Click to edit Master title style</a:t>
             </a:r>
+            <a:endParaRPr lang="en-US"/>
           </a:p>
         </p:txBody>
       </p:sp>
@@ -2670,37 +2674,38 @@
           <a:p>
             <a:pPr lvl="0"/>
             <a:r>
-              <a:rPr lang="en-US"/>
+              <a:rPr lang="en-US" smtClean="0"/>
               <a:t>Click to edit Master text styles</a:t>
             </a:r>
           </a:p>
           <a:p>
             <a:pPr lvl="1"/>
             <a:r>
-              <a:rPr lang="en-US"/>
+              <a:rPr lang="en-US" smtClean="0"/>
               <a:t>Second level</a:t>
             </a:r>
           </a:p>
           <a:p>
             <a:pPr lvl="2"/>
             <a:r>
-              <a:rPr lang="en-US"/>
+              <a:rPr lang="en-US" smtClean="0"/>
               <a:t>Third level</a:t>
             </a:r>
           </a:p>
           <a:p>
             <a:pPr lvl="3"/>
             <a:r>
-              <a:rPr lang="en-US"/>
+              <a:rPr lang="en-US" smtClean="0"/>
               <a:t>Fourth level</a:t>
             </a:r>
           </a:p>
           <a:p>
             <a:pPr lvl="4"/>
             <a:r>
-              <a:rPr lang="en-US"/>
+              <a:rPr lang="en-US" smtClean="0"/>
               <a:t>Fifth level</a:t>
             </a:r>
+            <a:endParaRPr lang="en-US"/>
           </a:p>
         </p:txBody>
       </p:sp>
@@ -2739,7 +2744,7 @@
           <a:p>
             <a:fld id="{5BCAD085-E8A6-8845-BD4E-CB4CCA059FC4}" type="datetimeFigureOut">
               <a:rPr lang="en-US" smtClean="0"/>
-              <a:t>10/14/26</a:t>
+              <a:t>1/27/13</a:t>
             </a:fld>
             <a:endParaRPr lang="en-US"/>
           </a:p>
@@ -3098,7 +3103,7 @@
 </file>
 
 <file path=ppt/slides/slide1.xml><?xml version="1.0" encoding="utf-8"?>
-<p:sld xmlns:a="http://schemas.openxmlformats.org/drawingml/2006/main" xmlns:r="http://schemas.openxmlformats.org/officeDocument/2006/relationships" xmlns:p="http://schemas.openxmlformats.org/presentationml/2006/main">
+<p:sld xmlns:a="http://schemas.openxmlformats.org/drawingml/2006/main" xmlns:p="http://schemas.openxmlformats.org/presentationml/2006/main" xmlns:r="http://schemas.openxmlformats.org/officeDocument/2006/relationships">
   <p:cSld>
     <p:bg>
       <p:bgPr>
@@ -3114,14 +3119,7 @@
         <p:cNvGrpSpPr/>
         <p:nvPr/>
       </p:nvGrpSpPr>
-      <p:grpSpPr>
-        <a:xfrm>
-          <a:off x="0" y="0"/>
-          <a:ext cx="0" cy="0"/>
-          <a:chOff x="0" y="0"/>
-          <a:chExt cx="0" cy="0"/>
-        </a:xfrm>
-      </p:grpSpPr>
+      <p:grpSpPr/>
       <p:sp>
         <p:nvSpPr>
           <p:cNvPr id="2" name="TextBox 1"/>
@@ -3131,7 +3129,7 @@
         <p:spPr>
           <a:xfrm>
             <a:off x="914400" y="1828800"/>
-            <a:ext cx="10058400" cy="2913618"/>
+            <a:ext cx="10058400" cy="3200400"/>
           </a:xfrm>
           <a:prstGeom prst="rect">
             <a:avLst/>
@@ -3152,14 +3150,8 @@
               </a:defRPr>
             </a:pPr>
             <a:r>
-              <a:rPr dirty="0"/>
               <a:t>Global Variation in Sequence Accessions Over Time</a:t>
             </a:r>
-            <a:r>
-              <a:rPr lang="en-GB"/>
-              <a:t>: A Rapid Analysis</a:t>
-            </a:r>
-            <a:endParaRPr dirty="0"/>
           </a:p>
           <a:p>
             <a:pPr>
@@ -3173,7 +3165,6 @@
               </a:defRPr>
             </a:pPr>
             <a:r>
-              <a:rPr dirty="0"/>
               <a:t>Implications for the Cali Fund and DSI Benefit-Sharing</a:t>
             </a:r>
           </a:p>
@@ -3189,23 +3180,6 @@
               </a:defRPr>
             </a:pPr>
             <a:r>
-              <a:rPr lang="en-GB" dirty="0"/>
-              <a:t>Jasmine Kindness</a:t>
-            </a:r>
-          </a:p>
-          <a:p>
-            <a:pPr>
-              <a:spcBef>
-                <a:spcPts val="2400"/>
-              </a:spcBef>
-              <a:defRPr sz="1800">
-                <a:solidFill>
-                  <a:srgbClr val="7BA8D4"/>
-                </a:solidFill>
-              </a:defRPr>
-            </a:pPr>
-            <a:r>
-              <a:rPr dirty="0"/>
               <a:t>13 October 2026</a:t>
             </a:r>
           </a:p>
@@ -3220,7 +3194,7 @@
 </file>
 
 <file path=ppt/slides/slide10.xml><?xml version="1.0" encoding="utf-8"?>
-<p:sld xmlns:a="http://schemas.openxmlformats.org/drawingml/2006/main" xmlns:r="http://schemas.openxmlformats.org/officeDocument/2006/relationships" xmlns:p="http://schemas.openxmlformats.org/presentationml/2006/main">
+<p:sld xmlns:a="http://schemas.openxmlformats.org/drawingml/2006/main" xmlns:p="http://schemas.openxmlformats.org/presentationml/2006/main" xmlns:r="http://schemas.openxmlformats.org/officeDocument/2006/relationships">
   <p:cSld>
     <p:spTree>
       <p:nvGrpSpPr>
@@ -3228,14 +3202,7 @@
         <p:cNvGrpSpPr/>
         <p:nvPr/>
       </p:nvGrpSpPr>
-      <p:grpSpPr>
-        <a:xfrm>
-          <a:off x="0" y="0"/>
-          <a:ext cx="0" cy="0"/>
-          <a:chOff x="0" y="0"/>
-          <a:chExt cx="0" cy="0"/>
-        </a:xfrm>
-      </p:grpSpPr>
+      <p:grpSpPr/>
       <p:sp>
         <p:nvSpPr>
           <p:cNvPr id="2" name="TextBox 1"/>
@@ -3326,7 +3293,6 @@
           <a:lstStyle/>
           <a:p>
             <a:pPr algn="ctr"/>
-            <a:endParaRPr/>
           </a:p>
         </p:txBody>
       </p:sp>
@@ -3398,7 +3364,7 @@
 </file>
 
 <file path=ppt/slides/slide11.xml><?xml version="1.0" encoding="utf-8"?>
-<p:sld xmlns:a="http://schemas.openxmlformats.org/drawingml/2006/main" xmlns:r="http://schemas.openxmlformats.org/officeDocument/2006/relationships" xmlns:p="http://schemas.openxmlformats.org/presentationml/2006/main">
+<p:sld xmlns:a="http://schemas.openxmlformats.org/drawingml/2006/main" xmlns:p="http://schemas.openxmlformats.org/presentationml/2006/main" xmlns:r="http://schemas.openxmlformats.org/officeDocument/2006/relationships">
   <p:cSld>
     <p:spTree>
       <p:nvGrpSpPr>
@@ -3406,14 +3372,7 @@
         <p:cNvGrpSpPr/>
         <p:nvPr/>
       </p:nvGrpSpPr>
-      <p:grpSpPr>
-        <a:xfrm>
-          <a:off x="0" y="0"/>
-          <a:ext cx="0" cy="0"/>
-          <a:chOff x="0" y="0"/>
-          <a:chExt cx="0" cy="0"/>
-        </a:xfrm>
-      </p:grpSpPr>
+      <p:grpSpPr/>
       <p:sp>
         <p:nvSpPr>
           <p:cNvPr id="2" name="TextBox 1"/>
@@ -3504,7 +3463,6 @@
           <a:lstStyle/>
           <a:p>
             <a:pPr algn="ctr"/>
-            <a:endParaRPr/>
           </a:p>
         </p:txBody>
       </p:sp>
@@ -3576,7 +3534,7 @@
 </file>
 
 <file path=ppt/slides/slide12.xml><?xml version="1.0" encoding="utf-8"?>
-<p:sld xmlns:a="http://schemas.openxmlformats.org/drawingml/2006/main" xmlns:r="http://schemas.openxmlformats.org/officeDocument/2006/relationships" xmlns:p="http://schemas.openxmlformats.org/presentationml/2006/main">
+<p:sld xmlns:a="http://schemas.openxmlformats.org/drawingml/2006/main" xmlns:p="http://schemas.openxmlformats.org/presentationml/2006/main" xmlns:r="http://schemas.openxmlformats.org/officeDocument/2006/relationships">
   <p:cSld>
     <p:spTree>
       <p:nvGrpSpPr>
@@ -3584,14 +3542,7 @@
         <p:cNvGrpSpPr/>
         <p:nvPr/>
       </p:nvGrpSpPr>
-      <p:grpSpPr>
-        <a:xfrm>
-          <a:off x="0" y="0"/>
-          <a:ext cx="0" cy="0"/>
-          <a:chOff x="0" y="0"/>
-          <a:chExt cx="0" cy="0"/>
-        </a:xfrm>
-      </p:grpSpPr>
+      <p:grpSpPr/>
       <p:sp>
         <p:nvSpPr>
           <p:cNvPr id="2" name="TextBox 1"/>
@@ -3682,7 +3633,6 @@
           <a:lstStyle/>
           <a:p>
             <a:pPr algn="ctr"/>
-            <a:endParaRPr/>
           </a:p>
         </p:txBody>
       </p:sp>
@@ -3705,34 +3655,10 @@
                 <a:tableStyleId>{5C22544A-7EE6-4342-B048-85BDC9FD1C3A}</a:tableStyleId>
               </a:tblPr>
               <a:tblGrid>
-                <a:gridCol w="1485900">
-                  <a:extLst>
-                    <a:ext uri="{9D8B030D-6E8A-4147-A177-3AD203B41FA5}">
-                      <a16:colId xmlns:a16="http://schemas.microsoft.com/office/drawing/2014/main" val="20000"/>
-                    </a:ext>
-                  </a:extLst>
-                </a:gridCol>
-                <a:gridCol w="1485900">
-                  <a:extLst>
-                    <a:ext uri="{9D8B030D-6E8A-4147-A177-3AD203B41FA5}">
-                      <a16:colId xmlns:a16="http://schemas.microsoft.com/office/drawing/2014/main" val="20001"/>
-                    </a:ext>
-                  </a:extLst>
-                </a:gridCol>
-                <a:gridCol w="1485900">
-                  <a:extLst>
-                    <a:ext uri="{9D8B030D-6E8A-4147-A177-3AD203B41FA5}">
-                      <a16:colId xmlns:a16="http://schemas.microsoft.com/office/drawing/2014/main" val="20002"/>
-                    </a:ext>
-                  </a:extLst>
-                </a:gridCol>
-                <a:gridCol w="1485900">
-                  <a:extLst>
-                    <a:ext uri="{9D8B030D-6E8A-4147-A177-3AD203B41FA5}">
-                      <a16:colId xmlns:a16="http://schemas.microsoft.com/office/drawing/2014/main" val="20003"/>
-                    </a:ext>
-                  </a:extLst>
-                </a:gridCol>
+                <a:gridCol w="1485900"/>
+                <a:gridCol w="1485900"/>
+                <a:gridCol w="1485900"/>
+                <a:gridCol w="1485900"/>
               </a:tblGrid>
               <a:tr h="320040">
                 <a:tc>
@@ -3827,11 +3753,6 @@
                     </a:solidFill>
                   </a:tcPr>
                 </a:tc>
-                <a:extLst>
-                  <a:ext uri="{0D108BD9-81ED-4DB2-BD59-A6C34878D82A}">
-                    <a16:rowId xmlns:a16="http://schemas.microsoft.com/office/drawing/2014/main" val="10000"/>
-                  </a:ext>
-                </a:extLst>
               </a:tr>
               <a:tr h="320040">
                 <a:tc>
@@ -3910,11 +3831,6 @@
                   </a:txBody>
                   <a:tcPr/>
                 </a:tc>
-                <a:extLst>
-                  <a:ext uri="{0D108BD9-81ED-4DB2-BD59-A6C34878D82A}">
-                    <a16:rowId xmlns:a16="http://schemas.microsoft.com/office/drawing/2014/main" val="10001"/>
-                  </a:ext>
-                </a:extLst>
               </a:tr>
               <a:tr h="320040">
                 <a:tc>
@@ -4009,11 +3925,6 @@
                     </a:solidFill>
                   </a:tcPr>
                 </a:tc>
-                <a:extLst>
-                  <a:ext uri="{0D108BD9-81ED-4DB2-BD59-A6C34878D82A}">
-                    <a16:rowId xmlns:a16="http://schemas.microsoft.com/office/drawing/2014/main" val="10002"/>
-                  </a:ext>
-                </a:extLst>
               </a:tr>
               <a:tr h="320040">
                 <a:tc>
@@ -4092,11 +4003,6 @@
                   </a:txBody>
                   <a:tcPr/>
                 </a:tc>
-                <a:extLst>
-                  <a:ext uri="{0D108BD9-81ED-4DB2-BD59-A6C34878D82A}">
-                    <a16:rowId xmlns:a16="http://schemas.microsoft.com/office/drawing/2014/main" val="10003"/>
-                  </a:ext>
-                </a:extLst>
               </a:tr>
               <a:tr h="320040">
                 <a:tc>
@@ -4191,11 +4097,6 @@
                     </a:solidFill>
                   </a:tcPr>
                 </a:tc>
-                <a:extLst>
-                  <a:ext uri="{0D108BD9-81ED-4DB2-BD59-A6C34878D82A}">
-                    <a16:rowId xmlns:a16="http://schemas.microsoft.com/office/drawing/2014/main" val="10004"/>
-                  </a:ext>
-                </a:extLst>
               </a:tr>
               <a:tr h="320040">
                 <a:tc>
@@ -4274,11 +4175,6 @@
                   </a:txBody>
                   <a:tcPr/>
                 </a:tc>
-                <a:extLst>
-                  <a:ext uri="{0D108BD9-81ED-4DB2-BD59-A6C34878D82A}">
-                    <a16:rowId xmlns:a16="http://schemas.microsoft.com/office/drawing/2014/main" val="10005"/>
-                  </a:ext>
-                </a:extLst>
               </a:tr>
             </a:tbl>
           </a:graphicData>
@@ -4388,7 +4284,7 @@
 </file>
 
 <file path=ppt/slides/slide13.xml><?xml version="1.0" encoding="utf-8"?>
-<p:sld xmlns:a="http://schemas.openxmlformats.org/drawingml/2006/main" xmlns:r="http://schemas.openxmlformats.org/officeDocument/2006/relationships" xmlns:p="http://schemas.openxmlformats.org/presentationml/2006/main">
+<p:sld xmlns:a="http://schemas.openxmlformats.org/drawingml/2006/main" xmlns:p="http://schemas.openxmlformats.org/presentationml/2006/main" xmlns:r="http://schemas.openxmlformats.org/officeDocument/2006/relationships">
   <p:cSld>
     <p:spTree>
       <p:nvGrpSpPr>
@@ -4396,14 +4292,7 @@
         <p:cNvGrpSpPr/>
         <p:nvPr/>
       </p:nvGrpSpPr>
-      <p:grpSpPr>
-        <a:xfrm>
-          <a:off x="0" y="0"/>
-          <a:ext cx="0" cy="0"/>
-          <a:chOff x="0" y="0"/>
-          <a:chExt cx="0" cy="0"/>
-        </a:xfrm>
-      </p:grpSpPr>
+      <p:grpSpPr/>
       <p:sp>
         <p:nvSpPr>
           <p:cNvPr id="2" name="TextBox 1"/>
@@ -4494,7 +4383,6 @@
           <a:lstStyle/>
           <a:p>
             <a:pPr algn="ctr"/>
-            <a:endParaRPr/>
           </a:p>
         </p:txBody>
       </p:sp>
@@ -4679,7 +4567,7 @@
 </file>
 
 <file path=ppt/slides/slide14.xml><?xml version="1.0" encoding="utf-8"?>
-<p:sld xmlns:a="http://schemas.openxmlformats.org/drawingml/2006/main" xmlns:r="http://schemas.openxmlformats.org/officeDocument/2006/relationships" xmlns:p="http://schemas.openxmlformats.org/presentationml/2006/main">
+<p:sld xmlns:a="http://schemas.openxmlformats.org/drawingml/2006/main" xmlns:p="http://schemas.openxmlformats.org/presentationml/2006/main" xmlns:r="http://schemas.openxmlformats.org/officeDocument/2006/relationships">
   <p:cSld>
     <p:spTree>
       <p:nvGrpSpPr>
@@ -4687,14 +4575,7 @@
         <p:cNvGrpSpPr/>
         <p:nvPr/>
       </p:nvGrpSpPr>
-      <p:grpSpPr>
-        <a:xfrm>
-          <a:off x="0" y="0"/>
-          <a:ext cx="0" cy="0"/>
-          <a:chOff x="0" y="0"/>
-          <a:chExt cx="0" cy="0"/>
-        </a:xfrm>
-      </p:grpSpPr>
+      <p:grpSpPr/>
       <p:sp>
         <p:nvSpPr>
           <p:cNvPr id="2" name="TextBox 1"/>
@@ -4785,7 +4666,6 @@
           <a:lstStyle/>
           <a:p>
             <a:pPr algn="ctr"/>
-            <a:endParaRPr/>
           </a:p>
         </p:txBody>
       </p:sp>
@@ -4970,7 +4850,7 @@
 </file>
 
 <file path=ppt/slides/slide15.xml><?xml version="1.0" encoding="utf-8"?>
-<p:sld xmlns:a="http://schemas.openxmlformats.org/drawingml/2006/main" xmlns:r="http://schemas.openxmlformats.org/officeDocument/2006/relationships" xmlns:p="http://schemas.openxmlformats.org/presentationml/2006/main">
+<p:sld xmlns:a="http://schemas.openxmlformats.org/drawingml/2006/main" xmlns:p="http://schemas.openxmlformats.org/presentationml/2006/main" xmlns:r="http://schemas.openxmlformats.org/officeDocument/2006/relationships">
   <p:cSld>
     <p:spTree>
       <p:nvGrpSpPr>
@@ -4978,14 +4858,7 @@
         <p:cNvGrpSpPr/>
         <p:nvPr/>
       </p:nvGrpSpPr>
-      <p:grpSpPr>
-        <a:xfrm>
-          <a:off x="0" y="0"/>
-          <a:ext cx="0" cy="0"/>
-          <a:chOff x="0" y="0"/>
-          <a:chExt cx="0" cy="0"/>
-        </a:xfrm>
-      </p:grpSpPr>
+      <p:grpSpPr/>
       <p:sp>
         <p:nvSpPr>
           <p:cNvPr id="2" name="TextBox 1"/>
@@ -5076,7 +4949,6 @@
           <a:lstStyle/>
           <a:p>
             <a:pPr algn="ctr"/>
-            <a:endParaRPr/>
           </a:p>
         </p:txBody>
       </p:sp>
@@ -5090,7 +4962,7 @@
         </p:nvGraphicFramePr>
         <p:xfrm>
           <a:off x="731520" y="1554480"/>
-          <a:ext cx="5943600" cy="1935480"/>
+          <a:ext cx="5943600" cy="1600200"/>
         </p:xfrm>
         <a:graphic>
           <a:graphicData uri="http://schemas.openxmlformats.org/drawingml/2006/table">
@@ -5099,34 +4971,10 @@
                 <a:tableStyleId>{5C22544A-7EE6-4342-B048-85BDC9FD1C3A}</a:tableStyleId>
               </a:tblPr>
               <a:tblGrid>
-                <a:gridCol w="1485900">
-                  <a:extLst>
-                    <a:ext uri="{9D8B030D-6E8A-4147-A177-3AD203B41FA5}">
-                      <a16:colId xmlns:a16="http://schemas.microsoft.com/office/drawing/2014/main" val="20000"/>
-                    </a:ext>
-                  </a:extLst>
-                </a:gridCol>
-                <a:gridCol w="1485900">
-                  <a:extLst>
-                    <a:ext uri="{9D8B030D-6E8A-4147-A177-3AD203B41FA5}">
-                      <a16:colId xmlns:a16="http://schemas.microsoft.com/office/drawing/2014/main" val="20001"/>
-                    </a:ext>
-                  </a:extLst>
-                </a:gridCol>
-                <a:gridCol w="1485900">
-                  <a:extLst>
-                    <a:ext uri="{9D8B030D-6E8A-4147-A177-3AD203B41FA5}">
-                      <a16:colId xmlns:a16="http://schemas.microsoft.com/office/drawing/2014/main" val="20002"/>
-                    </a:ext>
-                  </a:extLst>
-                </a:gridCol>
-                <a:gridCol w="1485900">
-                  <a:extLst>
-                    <a:ext uri="{9D8B030D-6E8A-4147-A177-3AD203B41FA5}">
-                      <a16:colId xmlns:a16="http://schemas.microsoft.com/office/drawing/2014/main" val="20003"/>
-                    </a:ext>
-                  </a:extLst>
-                </a:gridCol>
+                <a:gridCol w="1485900"/>
+                <a:gridCol w="1485900"/>
+                <a:gridCol w="1485900"/>
+                <a:gridCol w="1485900"/>
               </a:tblGrid>
               <a:tr h="320040">
                 <a:tc>
@@ -5221,11 +5069,6 @@
                     </a:solidFill>
                   </a:tcPr>
                 </a:tc>
-                <a:extLst>
-                  <a:ext uri="{0D108BD9-81ED-4DB2-BD59-A6C34878D82A}">
-                    <a16:rowId xmlns:a16="http://schemas.microsoft.com/office/drawing/2014/main" val="10000"/>
-                  </a:ext>
-                </a:extLst>
               </a:tr>
               <a:tr h="320040">
                 <a:tc>
@@ -5304,11 +5147,6 @@
                   </a:txBody>
                   <a:tcPr/>
                 </a:tc>
-                <a:extLst>
-                  <a:ext uri="{0D108BD9-81ED-4DB2-BD59-A6C34878D82A}">
-                    <a16:rowId xmlns:a16="http://schemas.microsoft.com/office/drawing/2014/main" val="10001"/>
-                  </a:ext>
-                </a:extLst>
               </a:tr>
               <a:tr h="320040">
                 <a:tc>
@@ -5403,11 +5241,6 @@
                     </a:solidFill>
                   </a:tcPr>
                 </a:tc>
-                <a:extLst>
-                  <a:ext uri="{0D108BD9-81ED-4DB2-BD59-A6C34878D82A}">
-                    <a16:rowId xmlns:a16="http://schemas.microsoft.com/office/drawing/2014/main" val="10002"/>
-                  </a:ext>
-                </a:extLst>
               </a:tr>
               <a:tr h="320040">
                 <a:tc>
@@ -5486,11 +5319,6 @@
                   </a:txBody>
                   <a:tcPr/>
                 </a:tc>
-                <a:extLst>
-                  <a:ext uri="{0D108BD9-81ED-4DB2-BD59-A6C34878D82A}">
-                    <a16:rowId xmlns:a16="http://schemas.microsoft.com/office/drawing/2014/main" val="10003"/>
-                  </a:ext>
-                </a:extLst>
               </a:tr>
               <a:tr h="320040">
                 <a:tc>
@@ -5585,11 +5413,6 @@
                     </a:solidFill>
                   </a:tcPr>
                 </a:tc>
-                <a:extLst>
-                  <a:ext uri="{0D108BD9-81ED-4DB2-BD59-A6C34878D82A}">
-                    <a16:rowId xmlns:a16="http://schemas.microsoft.com/office/drawing/2014/main" val="10004"/>
-                  </a:ext>
-                </a:extLst>
               </a:tr>
             </a:tbl>
           </a:graphicData>
@@ -5663,7 +5486,7 @@
 </file>
 
 <file path=ppt/slides/slide16.xml><?xml version="1.0" encoding="utf-8"?>
-<p:sld xmlns:a="http://schemas.openxmlformats.org/drawingml/2006/main" xmlns:r="http://schemas.openxmlformats.org/officeDocument/2006/relationships" xmlns:p="http://schemas.openxmlformats.org/presentationml/2006/main">
+<p:sld xmlns:a="http://schemas.openxmlformats.org/drawingml/2006/main" xmlns:p="http://schemas.openxmlformats.org/presentationml/2006/main" xmlns:r="http://schemas.openxmlformats.org/officeDocument/2006/relationships">
   <p:cSld>
     <p:spTree>
       <p:nvGrpSpPr>
@@ -5671,14 +5494,7 @@
         <p:cNvGrpSpPr/>
         <p:nvPr/>
       </p:nvGrpSpPr>
-      <p:grpSpPr>
-        <a:xfrm>
-          <a:off x="0" y="0"/>
-          <a:ext cx="0" cy="0"/>
-          <a:chOff x="0" y="0"/>
-          <a:chExt cx="0" cy="0"/>
-        </a:xfrm>
-      </p:grpSpPr>
+      <p:grpSpPr/>
       <p:sp>
         <p:nvSpPr>
           <p:cNvPr id="2" name="TextBox 1"/>
@@ -5769,7 +5585,6 @@
           <a:lstStyle/>
           <a:p>
             <a:pPr algn="ctr"/>
-            <a:endParaRPr/>
           </a:p>
         </p:txBody>
       </p:sp>
@@ -5792,48 +5607,12 @@
                 <a:tableStyleId>{5C22544A-7EE6-4342-B048-85BDC9FD1C3A}</a:tableStyleId>
               </a:tblPr>
               <a:tblGrid>
-                <a:gridCol w="1097280">
-                  <a:extLst>
-                    <a:ext uri="{9D8B030D-6E8A-4147-A177-3AD203B41FA5}">
-                      <a16:colId xmlns:a16="http://schemas.microsoft.com/office/drawing/2014/main" val="20000"/>
-                    </a:ext>
-                  </a:extLst>
-                </a:gridCol>
-                <a:gridCol w="1828800">
-                  <a:extLst>
-                    <a:ext uri="{9D8B030D-6E8A-4147-A177-3AD203B41FA5}">
-                      <a16:colId xmlns:a16="http://schemas.microsoft.com/office/drawing/2014/main" val="20001"/>
-                    </a:ext>
-                  </a:extLst>
-                </a:gridCol>
-                <a:gridCol w="2011680">
-                  <a:extLst>
-                    <a:ext uri="{9D8B030D-6E8A-4147-A177-3AD203B41FA5}">
-                      <a16:colId xmlns:a16="http://schemas.microsoft.com/office/drawing/2014/main" val="20002"/>
-                    </a:ext>
-                  </a:extLst>
-                </a:gridCol>
-                <a:gridCol w="2011680">
-                  <a:extLst>
-                    <a:ext uri="{9D8B030D-6E8A-4147-A177-3AD203B41FA5}">
-                      <a16:colId xmlns:a16="http://schemas.microsoft.com/office/drawing/2014/main" val="20003"/>
-                    </a:ext>
-                  </a:extLst>
-                </a:gridCol>
-                <a:gridCol w="1645920">
-                  <a:extLst>
-                    <a:ext uri="{9D8B030D-6E8A-4147-A177-3AD203B41FA5}">
-                      <a16:colId xmlns:a16="http://schemas.microsoft.com/office/drawing/2014/main" val="20004"/>
-                    </a:ext>
-                  </a:extLst>
-                </a:gridCol>
-                <a:gridCol w="1920240">
-                  <a:extLst>
-                    <a:ext uri="{9D8B030D-6E8A-4147-A177-3AD203B41FA5}">
-                      <a16:colId xmlns:a16="http://schemas.microsoft.com/office/drawing/2014/main" val="20005"/>
-                    </a:ext>
-                  </a:extLst>
-                </a:gridCol>
+                <a:gridCol w="1097280"/>
+                <a:gridCol w="1828800"/>
+                <a:gridCol w="2011680"/>
+                <a:gridCol w="2011680"/>
+                <a:gridCol w="1645920"/>
+                <a:gridCol w="1920240"/>
               </a:tblGrid>
               <a:tr h="320040">
                 <a:tc>
@@ -5974,11 +5753,6 @@
                     </a:solidFill>
                   </a:tcPr>
                 </a:tc>
-                <a:extLst>
-                  <a:ext uri="{0D108BD9-81ED-4DB2-BD59-A6C34878D82A}">
-                    <a16:rowId xmlns:a16="http://schemas.microsoft.com/office/drawing/2014/main" val="10000"/>
-                  </a:ext>
-                </a:extLst>
               </a:tr>
               <a:tr h="320040">
                 <a:tc>
@@ -6095,11 +5869,6 @@
                   </a:txBody>
                   <a:tcPr/>
                 </a:tc>
-                <a:extLst>
-                  <a:ext uri="{0D108BD9-81ED-4DB2-BD59-A6C34878D82A}">
-                    <a16:rowId xmlns:a16="http://schemas.microsoft.com/office/drawing/2014/main" val="10001"/>
-                  </a:ext>
-                </a:extLst>
               </a:tr>
               <a:tr h="320040">
                 <a:tc>
@@ -6240,11 +6009,6 @@
                     </a:solidFill>
                   </a:tcPr>
                 </a:tc>
-                <a:extLst>
-                  <a:ext uri="{0D108BD9-81ED-4DB2-BD59-A6C34878D82A}">
-                    <a16:rowId xmlns:a16="http://schemas.microsoft.com/office/drawing/2014/main" val="10002"/>
-                  </a:ext>
-                </a:extLst>
               </a:tr>
               <a:tr h="320040">
                 <a:tc>
@@ -6361,11 +6125,6 @@
                   </a:txBody>
                   <a:tcPr/>
                 </a:tc>
-                <a:extLst>
-                  <a:ext uri="{0D108BD9-81ED-4DB2-BD59-A6C34878D82A}">
-                    <a16:rowId xmlns:a16="http://schemas.microsoft.com/office/drawing/2014/main" val="10003"/>
-                  </a:ext>
-                </a:extLst>
               </a:tr>
               <a:tr h="320040">
                 <a:tc>
@@ -6506,11 +6265,6 @@
                     </a:solidFill>
                   </a:tcPr>
                 </a:tc>
-                <a:extLst>
-                  <a:ext uri="{0D108BD9-81ED-4DB2-BD59-A6C34878D82A}">
-                    <a16:rowId xmlns:a16="http://schemas.microsoft.com/office/drawing/2014/main" val="10004"/>
-                  </a:ext>
-                </a:extLst>
               </a:tr>
               <a:tr h="320040">
                 <a:tc>
@@ -6627,11 +6381,6 @@
                   </a:txBody>
                   <a:tcPr/>
                 </a:tc>
-                <a:extLst>
-                  <a:ext uri="{0D108BD9-81ED-4DB2-BD59-A6C34878D82A}">
-                    <a16:rowId xmlns:a16="http://schemas.microsoft.com/office/drawing/2014/main" val="10005"/>
-                  </a:ext>
-                </a:extLst>
               </a:tr>
               <a:tr h="320040">
                 <a:tc>
@@ -6772,11 +6521,6 @@
                     </a:solidFill>
                   </a:tcPr>
                 </a:tc>
-                <a:extLst>
-                  <a:ext uri="{0D108BD9-81ED-4DB2-BD59-A6C34878D82A}">
-                    <a16:rowId xmlns:a16="http://schemas.microsoft.com/office/drawing/2014/main" val="10006"/>
-                  </a:ext>
-                </a:extLst>
               </a:tr>
               <a:tr h="320040">
                 <a:tc>
@@ -6893,11 +6637,6 @@
                   </a:txBody>
                   <a:tcPr/>
                 </a:tc>
-                <a:extLst>
-                  <a:ext uri="{0D108BD9-81ED-4DB2-BD59-A6C34878D82A}">
-                    <a16:rowId xmlns:a16="http://schemas.microsoft.com/office/drawing/2014/main" val="10007"/>
-                  </a:ext>
-                </a:extLst>
               </a:tr>
               <a:tr h="320040">
                 <a:tc>
@@ -7038,11 +6777,6 @@
                     </a:solidFill>
                   </a:tcPr>
                 </a:tc>
-                <a:extLst>
-                  <a:ext uri="{0D108BD9-81ED-4DB2-BD59-A6C34878D82A}">
-                    <a16:rowId xmlns:a16="http://schemas.microsoft.com/office/drawing/2014/main" val="10008"/>
-                  </a:ext>
-                </a:extLst>
               </a:tr>
               <a:tr h="320040">
                 <a:tc>
@@ -7159,11 +6893,6 @@
                   </a:txBody>
                   <a:tcPr/>
                 </a:tc>
-                <a:extLst>
-                  <a:ext uri="{0D108BD9-81ED-4DB2-BD59-A6C34878D82A}">
-                    <a16:rowId xmlns:a16="http://schemas.microsoft.com/office/drawing/2014/main" val="10009"/>
-                  </a:ext>
-                </a:extLst>
               </a:tr>
             </a:tbl>
           </a:graphicData>
@@ -7290,7 +7019,7 @@
 </file>
 
 <file path=ppt/slides/slide17.xml><?xml version="1.0" encoding="utf-8"?>
-<p:sld xmlns:a="http://schemas.openxmlformats.org/drawingml/2006/main" xmlns:r="http://schemas.openxmlformats.org/officeDocument/2006/relationships" xmlns:p="http://schemas.openxmlformats.org/presentationml/2006/main">
+<p:sld xmlns:a="http://schemas.openxmlformats.org/drawingml/2006/main" xmlns:p="http://schemas.openxmlformats.org/presentationml/2006/main" xmlns:r="http://schemas.openxmlformats.org/officeDocument/2006/relationships">
   <p:cSld>
     <p:spTree>
       <p:nvGrpSpPr>
@@ -7298,14 +7027,7 @@
         <p:cNvGrpSpPr/>
         <p:nvPr/>
       </p:nvGrpSpPr>
-      <p:grpSpPr>
-        <a:xfrm>
-          <a:off x="0" y="0"/>
-          <a:ext cx="0" cy="0"/>
-          <a:chOff x="0" y="0"/>
-          <a:chExt cx="0" cy="0"/>
-        </a:xfrm>
-      </p:grpSpPr>
+      <p:grpSpPr/>
       <p:sp>
         <p:nvSpPr>
           <p:cNvPr id="2" name="TextBox 1"/>
@@ -7396,7 +7118,6 @@
           <a:lstStyle/>
           <a:p>
             <a:pPr algn="ctr"/>
-            <a:endParaRPr/>
           </a:p>
         </p:txBody>
       </p:sp>
@@ -7419,34 +7140,10 @@
                 <a:tableStyleId>{5C22544A-7EE6-4342-B048-85BDC9FD1C3A}</a:tableStyleId>
               </a:tblPr>
               <a:tblGrid>
-                <a:gridCol w="1257300">
-                  <a:extLst>
-                    <a:ext uri="{9D8B030D-6E8A-4147-A177-3AD203B41FA5}">
-                      <a16:colId xmlns:a16="http://schemas.microsoft.com/office/drawing/2014/main" val="20000"/>
-                    </a:ext>
-                  </a:extLst>
-                </a:gridCol>
-                <a:gridCol w="1257300">
-                  <a:extLst>
-                    <a:ext uri="{9D8B030D-6E8A-4147-A177-3AD203B41FA5}">
-                      <a16:colId xmlns:a16="http://schemas.microsoft.com/office/drawing/2014/main" val="20001"/>
-                    </a:ext>
-                  </a:extLst>
-                </a:gridCol>
-                <a:gridCol w="1257300">
-                  <a:extLst>
-                    <a:ext uri="{9D8B030D-6E8A-4147-A177-3AD203B41FA5}">
-                      <a16:colId xmlns:a16="http://schemas.microsoft.com/office/drawing/2014/main" val="20002"/>
-                    </a:ext>
-                  </a:extLst>
-                </a:gridCol>
-                <a:gridCol w="1257300">
-                  <a:extLst>
-                    <a:ext uri="{9D8B030D-6E8A-4147-A177-3AD203B41FA5}">
-                      <a16:colId xmlns:a16="http://schemas.microsoft.com/office/drawing/2014/main" val="20003"/>
-                    </a:ext>
-                  </a:extLst>
-                </a:gridCol>
+                <a:gridCol w="1257300"/>
+                <a:gridCol w="1257300"/>
+                <a:gridCol w="1257300"/>
+                <a:gridCol w="1257300"/>
               </a:tblGrid>
               <a:tr h="320040">
                 <a:tc>
@@ -7541,11 +7238,6 @@
                     </a:solidFill>
                   </a:tcPr>
                 </a:tc>
-                <a:extLst>
-                  <a:ext uri="{0D108BD9-81ED-4DB2-BD59-A6C34878D82A}">
-                    <a16:rowId xmlns:a16="http://schemas.microsoft.com/office/drawing/2014/main" val="10000"/>
-                  </a:ext>
-                </a:extLst>
               </a:tr>
               <a:tr h="320040">
                 <a:tc>
@@ -7624,11 +7316,6 @@
                   </a:txBody>
                   <a:tcPr/>
                 </a:tc>
-                <a:extLst>
-                  <a:ext uri="{0D108BD9-81ED-4DB2-BD59-A6C34878D82A}">
-                    <a16:rowId xmlns:a16="http://schemas.microsoft.com/office/drawing/2014/main" val="10001"/>
-                  </a:ext>
-                </a:extLst>
               </a:tr>
               <a:tr h="320040">
                 <a:tc>
@@ -7723,11 +7410,6 @@
                     </a:solidFill>
                   </a:tcPr>
                 </a:tc>
-                <a:extLst>
-                  <a:ext uri="{0D108BD9-81ED-4DB2-BD59-A6C34878D82A}">
-                    <a16:rowId xmlns:a16="http://schemas.microsoft.com/office/drawing/2014/main" val="10002"/>
-                  </a:ext>
-                </a:extLst>
               </a:tr>
               <a:tr h="320040">
                 <a:tc>
@@ -7806,11 +7488,6 @@
                   </a:txBody>
                   <a:tcPr/>
                 </a:tc>
-                <a:extLst>
-                  <a:ext uri="{0D108BD9-81ED-4DB2-BD59-A6C34878D82A}">
-                    <a16:rowId xmlns:a16="http://schemas.microsoft.com/office/drawing/2014/main" val="10003"/>
-                  </a:ext>
-                </a:extLst>
               </a:tr>
             </a:tbl>
           </a:graphicData>
@@ -7949,7 +7626,7 @@
 </file>
 
 <file path=ppt/slides/slide18.xml><?xml version="1.0" encoding="utf-8"?>
-<p:sld xmlns:a="http://schemas.openxmlformats.org/drawingml/2006/main" xmlns:r="http://schemas.openxmlformats.org/officeDocument/2006/relationships" xmlns:p="http://schemas.openxmlformats.org/presentationml/2006/main">
+<p:sld xmlns:a="http://schemas.openxmlformats.org/drawingml/2006/main" xmlns:p="http://schemas.openxmlformats.org/presentationml/2006/main" xmlns:r="http://schemas.openxmlformats.org/officeDocument/2006/relationships">
   <p:cSld>
     <p:spTree>
       <p:nvGrpSpPr>
@@ -7957,14 +7634,7 @@
         <p:cNvGrpSpPr/>
         <p:nvPr/>
       </p:nvGrpSpPr>
-      <p:grpSpPr>
-        <a:xfrm>
-          <a:off x="0" y="0"/>
-          <a:ext cx="0" cy="0"/>
-          <a:chOff x="0" y="0"/>
-          <a:chExt cx="0" cy="0"/>
-        </a:xfrm>
-      </p:grpSpPr>
+      <p:grpSpPr/>
       <p:sp>
         <p:nvSpPr>
           <p:cNvPr id="2" name="TextBox 1"/>
@@ -8055,7 +7725,6 @@
           <a:lstStyle/>
           <a:p>
             <a:pPr algn="ctr"/>
-            <a:endParaRPr/>
           </a:p>
         </p:txBody>
       </p:sp>
@@ -8078,34 +7747,10 @@
                 <a:tableStyleId>{5C22544A-7EE6-4342-B048-85BDC9FD1C3A}</a:tableStyleId>
               </a:tblPr>
               <a:tblGrid>
-                <a:gridCol w="1371600">
-                  <a:extLst>
-                    <a:ext uri="{9D8B030D-6E8A-4147-A177-3AD203B41FA5}">
-                      <a16:colId xmlns:a16="http://schemas.microsoft.com/office/drawing/2014/main" val="20000"/>
-                    </a:ext>
-                  </a:extLst>
-                </a:gridCol>
-                <a:gridCol w="1371600">
-                  <a:extLst>
-                    <a:ext uri="{9D8B030D-6E8A-4147-A177-3AD203B41FA5}">
-                      <a16:colId xmlns:a16="http://schemas.microsoft.com/office/drawing/2014/main" val="20001"/>
-                    </a:ext>
-                  </a:extLst>
-                </a:gridCol>
-                <a:gridCol w="1371600">
-                  <a:extLst>
-                    <a:ext uri="{9D8B030D-6E8A-4147-A177-3AD203B41FA5}">
-                      <a16:colId xmlns:a16="http://schemas.microsoft.com/office/drawing/2014/main" val="20002"/>
-                    </a:ext>
-                  </a:extLst>
-                </a:gridCol>
-                <a:gridCol w="1371600">
-                  <a:extLst>
-                    <a:ext uri="{9D8B030D-6E8A-4147-A177-3AD203B41FA5}">
-                      <a16:colId xmlns:a16="http://schemas.microsoft.com/office/drawing/2014/main" val="20003"/>
-                    </a:ext>
-                  </a:extLst>
-                </a:gridCol>
+                <a:gridCol w="1371600"/>
+                <a:gridCol w="1371600"/>
+                <a:gridCol w="1371600"/>
+                <a:gridCol w="1371600"/>
               </a:tblGrid>
               <a:tr h="320040">
                 <a:tc>
@@ -8200,11 +7845,6 @@
                     </a:solidFill>
                   </a:tcPr>
                 </a:tc>
-                <a:extLst>
-                  <a:ext uri="{0D108BD9-81ED-4DB2-BD59-A6C34878D82A}">
-                    <a16:rowId xmlns:a16="http://schemas.microsoft.com/office/drawing/2014/main" val="10000"/>
-                  </a:ext>
-                </a:extLst>
               </a:tr>
               <a:tr h="320040">
                 <a:tc>
@@ -8283,11 +7923,6 @@
                   </a:txBody>
                   <a:tcPr/>
                 </a:tc>
-                <a:extLst>
-                  <a:ext uri="{0D108BD9-81ED-4DB2-BD59-A6C34878D82A}">
-                    <a16:rowId xmlns:a16="http://schemas.microsoft.com/office/drawing/2014/main" val="10001"/>
-                  </a:ext>
-                </a:extLst>
               </a:tr>
               <a:tr h="320040">
                 <a:tc>
@@ -8382,11 +8017,6 @@
                     </a:solidFill>
                   </a:tcPr>
                 </a:tc>
-                <a:extLst>
-                  <a:ext uri="{0D108BD9-81ED-4DB2-BD59-A6C34878D82A}">
-                    <a16:rowId xmlns:a16="http://schemas.microsoft.com/office/drawing/2014/main" val="10002"/>
-                  </a:ext>
-                </a:extLst>
               </a:tr>
               <a:tr h="320040">
                 <a:tc>
@@ -8465,11 +8095,6 @@
                   </a:txBody>
                   <a:tcPr/>
                 </a:tc>
-                <a:extLst>
-                  <a:ext uri="{0D108BD9-81ED-4DB2-BD59-A6C34878D82A}">
-                    <a16:rowId xmlns:a16="http://schemas.microsoft.com/office/drawing/2014/main" val="10003"/>
-                  </a:ext>
-                </a:extLst>
               </a:tr>
               <a:tr h="320040">
                 <a:tc>
@@ -8564,11 +8189,6 @@
                     </a:solidFill>
                   </a:tcPr>
                 </a:tc>
-                <a:extLst>
-                  <a:ext uri="{0D108BD9-81ED-4DB2-BD59-A6C34878D82A}">
-                    <a16:rowId xmlns:a16="http://schemas.microsoft.com/office/drawing/2014/main" val="10004"/>
-                  </a:ext>
-                </a:extLst>
               </a:tr>
               <a:tr h="320040">
                 <a:tc>
@@ -8647,11 +8267,6 @@
                   </a:txBody>
                   <a:tcPr/>
                 </a:tc>
-                <a:extLst>
-                  <a:ext uri="{0D108BD9-81ED-4DB2-BD59-A6C34878D82A}">
-                    <a16:rowId xmlns:a16="http://schemas.microsoft.com/office/drawing/2014/main" val="10005"/>
-                  </a:ext>
-                </a:extLst>
               </a:tr>
             </a:tbl>
           </a:graphicData>
@@ -8761,7 +8376,7 @@
 </file>
 
 <file path=ppt/slides/slide19.xml><?xml version="1.0" encoding="utf-8"?>
-<p:sld xmlns:a="http://schemas.openxmlformats.org/drawingml/2006/main" xmlns:r="http://schemas.openxmlformats.org/officeDocument/2006/relationships" xmlns:p="http://schemas.openxmlformats.org/presentationml/2006/main">
+<p:sld xmlns:a="http://schemas.openxmlformats.org/drawingml/2006/main" xmlns:p="http://schemas.openxmlformats.org/presentationml/2006/main" xmlns:r="http://schemas.openxmlformats.org/officeDocument/2006/relationships">
   <p:cSld>
     <p:spTree>
       <p:nvGrpSpPr>
@@ -8769,14 +8384,7 @@
         <p:cNvGrpSpPr/>
         <p:nvPr/>
       </p:nvGrpSpPr>
-      <p:grpSpPr>
-        <a:xfrm>
-          <a:off x="0" y="0"/>
-          <a:ext cx="0" cy="0"/>
-          <a:chOff x="0" y="0"/>
-          <a:chExt cx="0" cy="0"/>
-        </a:xfrm>
-      </p:grpSpPr>
+      <p:grpSpPr/>
       <p:sp>
         <p:nvSpPr>
           <p:cNvPr id="2" name="TextBox 1"/>
@@ -8867,7 +8475,6 @@
           <a:lstStyle/>
           <a:p>
             <a:pPr algn="ctr"/>
-            <a:endParaRPr/>
           </a:p>
         </p:txBody>
       </p:sp>
@@ -8890,34 +8497,10 @@
                 <a:tableStyleId>{5C22544A-7EE6-4342-B048-85BDC9FD1C3A}</a:tableStyleId>
               </a:tblPr>
               <a:tblGrid>
-                <a:gridCol w="1371600">
-                  <a:extLst>
-                    <a:ext uri="{9D8B030D-6E8A-4147-A177-3AD203B41FA5}">
-                      <a16:colId xmlns:a16="http://schemas.microsoft.com/office/drawing/2014/main" val="20000"/>
-                    </a:ext>
-                  </a:extLst>
-                </a:gridCol>
-                <a:gridCol w="1371600">
-                  <a:extLst>
-                    <a:ext uri="{9D8B030D-6E8A-4147-A177-3AD203B41FA5}">
-                      <a16:colId xmlns:a16="http://schemas.microsoft.com/office/drawing/2014/main" val="20001"/>
-                    </a:ext>
-                  </a:extLst>
-                </a:gridCol>
-                <a:gridCol w="1371600">
-                  <a:extLst>
-                    <a:ext uri="{9D8B030D-6E8A-4147-A177-3AD203B41FA5}">
-                      <a16:colId xmlns:a16="http://schemas.microsoft.com/office/drawing/2014/main" val="20002"/>
-                    </a:ext>
-                  </a:extLst>
-                </a:gridCol>
-                <a:gridCol w="1371600">
-                  <a:extLst>
-                    <a:ext uri="{9D8B030D-6E8A-4147-A177-3AD203B41FA5}">
-                      <a16:colId xmlns:a16="http://schemas.microsoft.com/office/drawing/2014/main" val="20003"/>
-                    </a:ext>
-                  </a:extLst>
-                </a:gridCol>
+                <a:gridCol w="1371600"/>
+                <a:gridCol w="1371600"/>
+                <a:gridCol w="1371600"/>
+                <a:gridCol w="1371600"/>
               </a:tblGrid>
               <a:tr h="320040">
                 <a:tc>
@@ -9012,11 +8595,6 @@
                     </a:solidFill>
                   </a:tcPr>
                 </a:tc>
-                <a:extLst>
-                  <a:ext uri="{0D108BD9-81ED-4DB2-BD59-A6C34878D82A}">
-                    <a16:rowId xmlns:a16="http://schemas.microsoft.com/office/drawing/2014/main" val="10000"/>
-                  </a:ext>
-                </a:extLst>
               </a:tr>
               <a:tr h="320040">
                 <a:tc>
@@ -9095,11 +8673,6 @@
                   </a:txBody>
                   <a:tcPr/>
                 </a:tc>
-                <a:extLst>
-                  <a:ext uri="{0D108BD9-81ED-4DB2-BD59-A6C34878D82A}">
-                    <a16:rowId xmlns:a16="http://schemas.microsoft.com/office/drawing/2014/main" val="10001"/>
-                  </a:ext>
-                </a:extLst>
               </a:tr>
               <a:tr h="320040">
                 <a:tc>
@@ -9194,11 +8767,6 @@
                     </a:solidFill>
                   </a:tcPr>
                 </a:tc>
-                <a:extLst>
-                  <a:ext uri="{0D108BD9-81ED-4DB2-BD59-A6C34878D82A}">
-                    <a16:rowId xmlns:a16="http://schemas.microsoft.com/office/drawing/2014/main" val="10002"/>
-                  </a:ext>
-                </a:extLst>
               </a:tr>
               <a:tr h="320040">
                 <a:tc>
@@ -9277,11 +8845,6 @@
                   </a:txBody>
                   <a:tcPr/>
                 </a:tc>
-                <a:extLst>
-                  <a:ext uri="{0D108BD9-81ED-4DB2-BD59-A6C34878D82A}">
-                    <a16:rowId xmlns:a16="http://schemas.microsoft.com/office/drawing/2014/main" val="10003"/>
-                  </a:ext>
-                </a:extLst>
               </a:tr>
               <a:tr h="320040">
                 <a:tc>
@@ -9376,11 +8939,6 @@
                     </a:solidFill>
                   </a:tcPr>
                 </a:tc>
-                <a:extLst>
-                  <a:ext uri="{0D108BD9-81ED-4DB2-BD59-A6C34878D82A}">
-                    <a16:rowId xmlns:a16="http://schemas.microsoft.com/office/drawing/2014/main" val="10004"/>
-                  </a:ext>
-                </a:extLst>
               </a:tr>
               <a:tr h="320040">
                 <a:tc>
@@ -9459,11 +9017,6 @@
                   </a:txBody>
                   <a:tcPr/>
                 </a:tc>
-                <a:extLst>
-                  <a:ext uri="{0D108BD9-81ED-4DB2-BD59-A6C34878D82A}">
-                    <a16:rowId xmlns:a16="http://schemas.microsoft.com/office/drawing/2014/main" val="10005"/>
-                  </a:ext>
-                </a:extLst>
               </a:tr>
               <a:tr h="320040">
                 <a:tc>
@@ -9558,11 +9111,6 @@
                     </a:solidFill>
                   </a:tcPr>
                 </a:tc>
-                <a:extLst>
-                  <a:ext uri="{0D108BD9-81ED-4DB2-BD59-A6C34878D82A}">
-                    <a16:rowId xmlns:a16="http://schemas.microsoft.com/office/drawing/2014/main" val="10006"/>
-                  </a:ext>
-                </a:extLst>
               </a:tr>
               <a:tr h="320040">
                 <a:tc>
@@ -9641,11 +9189,6 @@
                   </a:txBody>
                   <a:tcPr/>
                 </a:tc>
-                <a:extLst>
-                  <a:ext uri="{0D108BD9-81ED-4DB2-BD59-A6C34878D82A}">
-                    <a16:rowId xmlns:a16="http://schemas.microsoft.com/office/drawing/2014/main" val="10007"/>
-                  </a:ext>
-                </a:extLst>
               </a:tr>
               <a:tr h="320040">
                 <a:tc>
@@ -9740,11 +9283,6 @@
                     </a:solidFill>
                   </a:tcPr>
                 </a:tc>
-                <a:extLst>
-                  <a:ext uri="{0D108BD9-81ED-4DB2-BD59-A6C34878D82A}">
-                    <a16:rowId xmlns:a16="http://schemas.microsoft.com/office/drawing/2014/main" val="10008"/>
-                  </a:ext>
-                </a:extLst>
               </a:tr>
               <a:tr h="320040">
                 <a:tc>
@@ -9823,11 +9361,6 @@
                   </a:txBody>
                   <a:tcPr/>
                 </a:tc>
-                <a:extLst>
-                  <a:ext uri="{0D108BD9-81ED-4DB2-BD59-A6C34878D82A}">
-                    <a16:rowId xmlns:a16="http://schemas.microsoft.com/office/drawing/2014/main" val="10009"/>
-                  </a:ext>
-                </a:extLst>
               </a:tr>
               <a:tr h="320040">
                 <a:tc>
@@ -9922,11 +9455,6 @@
                     </a:solidFill>
                   </a:tcPr>
                 </a:tc>
-                <a:extLst>
-                  <a:ext uri="{0D108BD9-81ED-4DB2-BD59-A6C34878D82A}">
-                    <a16:rowId xmlns:a16="http://schemas.microsoft.com/office/drawing/2014/main" val="10010"/>
-                  </a:ext>
-                </a:extLst>
               </a:tr>
             </a:tbl>
           </a:graphicData>
@@ -10018,7 +9546,7 @@
 </file>
 
 <file path=ppt/slides/slide2.xml><?xml version="1.0" encoding="utf-8"?>
-<p:sld xmlns:a="http://schemas.openxmlformats.org/drawingml/2006/main" xmlns:r="http://schemas.openxmlformats.org/officeDocument/2006/relationships" xmlns:p="http://schemas.openxmlformats.org/presentationml/2006/main">
+<p:sld xmlns:a="http://schemas.openxmlformats.org/drawingml/2006/main" xmlns:p="http://schemas.openxmlformats.org/presentationml/2006/main" xmlns:r="http://schemas.openxmlformats.org/officeDocument/2006/relationships">
   <p:cSld>
     <p:spTree>
       <p:nvGrpSpPr>
@@ -10026,14 +9554,7 @@
         <p:cNvGrpSpPr/>
         <p:nvPr/>
       </p:nvGrpSpPr>
-      <p:grpSpPr>
-        <a:xfrm>
-          <a:off x="0" y="0"/>
-          <a:ext cx="0" cy="0"/>
-          <a:chOff x="0" y="0"/>
-          <a:chExt cx="0" cy="0"/>
-        </a:xfrm>
-      </p:grpSpPr>
+      <p:grpSpPr/>
       <p:sp>
         <p:nvSpPr>
           <p:cNvPr id="2" name="TextBox 1"/>
@@ -10109,7 +9630,6 @@
           <a:lstStyle/>
           <a:p>
             <a:pPr algn="ctr"/>
-            <a:endParaRPr/>
           </a:p>
         </p:txBody>
       </p:sp>
@@ -10217,7 +9737,7 @@
 </file>
 
 <file path=ppt/slides/slide20.xml><?xml version="1.0" encoding="utf-8"?>
-<p:sld xmlns:a="http://schemas.openxmlformats.org/drawingml/2006/main" xmlns:r="http://schemas.openxmlformats.org/officeDocument/2006/relationships" xmlns:p="http://schemas.openxmlformats.org/presentationml/2006/main">
+<p:sld xmlns:a="http://schemas.openxmlformats.org/drawingml/2006/main" xmlns:p="http://schemas.openxmlformats.org/presentationml/2006/main" xmlns:r="http://schemas.openxmlformats.org/officeDocument/2006/relationships">
   <p:cSld>
     <p:spTree>
       <p:nvGrpSpPr>
@@ -10225,14 +9745,7 @@
         <p:cNvGrpSpPr/>
         <p:nvPr/>
       </p:nvGrpSpPr>
-      <p:grpSpPr>
-        <a:xfrm>
-          <a:off x="0" y="0"/>
-          <a:ext cx="0" cy="0"/>
-          <a:chOff x="0" y="0"/>
-          <a:chExt cx="0" cy="0"/>
-        </a:xfrm>
-      </p:grpSpPr>
+      <p:grpSpPr/>
       <p:sp>
         <p:nvSpPr>
           <p:cNvPr id="2" name="TextBox 1"/>
@@ -10263,8 +9776,7 @@
               </a:defRPr>
             </a:pPr>
             <a:r>
-              <a:rPr dirty="0"/>
-              <a:t>COVID-19 distortion</a:t>
+              <a:t>The COVID-19 distortion</a:t>
             </a:r>
           </a:p>
           <a:p>
@@ -10279,7 +9791,6 @@
               </a:defRPr>
             </a:pPr>
             <a:r>
-              <a:rPr dirty="0"/>
               <a:t>Pandemic surveillance severely distorts temporal trends</a:t>
             </a:r>
           </a:p>
@@ -10325,7 +9836,6 @@
           <a:lstStyle/>
           <a:p>
             <a:pPr algn="ctr"/>
-            <a:endParaRPr/>
           </a:p>
         </p:txBody>
       </p:sp>
@@ -10433,7 +9943,7 @@
 </file>
 
 <file path=ppt/slides/slide21.xml><?xml version="1.0" encoding="utf-8"?>
-<p:sld xmlns:a="http://schemas.openxmlformats.org/drawingml/2006/main" xmlns:r="http://schemas.openxmlformats.org/officeDocument/2006/relationships" xmlns:p="http://schemas.openxmlformats.org/presentationml/2006/main">
+<p:sld xmlns:a="http://schemas.openxmlformats.org/drawingml/2006/main" xmlns:p="http://schemas.openxmlformats.org/presentationml/2006/main" xmlns:r="http://schemas.openxmlformats.org/officeDocument/2006/relationships">
   <p:cSld>
     <p:spTree>
       <p:nvGrpSpPr>
@@ -10441,14 +9951,7 @@
         <p:cNvGrpSpPr/>
         <p:nvPr/>
       </p:nvGrpSpPr>
-      <p:grpSpPr>
-        <a:xfrm>
-          <a:off x="0" y="0"/>
-          <a:ext cx="0" cy="0"/>
-          <a:chOff x="0" y="0"/>
-          <a:chExt cx="0" cy="0"/>
-        </a:xfrm>
-      </p:grpSpPr>
+      <p:grpSpPr/>
       <p:sp>
         <p:nvSpPr>
           <p:cNvPr id="2" name="TextBox 1"/>
@@ -10539,7 +10042,6 @@
           <a:lstStyle/>
           <a:p>
             <a:pPr algn="ctr"/>
-            <a:endParaRPr/>
           </a:p>
         </p:txBody>
       </p:sp>
@@ -10562,48 +10064,12 @@
                 <a:tableStyleId>{5C22544A-7EE6-4342-B048-85BDC9FD1C3A}</a:tableStyleId>
               </a:tblPr>
               <a:tblGrid>
-                <a:gridCol w="1645920">
-                  <a:extLst>
-                    <a:ext uri="{9D8B030D-6E8A-4147-A177-3AD203B41FA5}">
-                      <a16:colId xmlns:a16="http://schemas.microsoft.com/office/drawing/2014/main" val="20000"/>
-                    </a:ext>
-                  </a:extLst>
-                </a:gridCol>
-                <a:gridCol w="1828800">
-                  <a:extLst>
-                    <a:ext uri="{9D8B030D-6E8A-4147-A177-3AD203B41FA5}">
-                      <a16:colId xmlns:a16="http://schemas.microsoft.com/office/drawing/2014/main" val="20001"/>
-                    </a:ext>
-                  </a:extLst>
-                </a:gridCol>
-                <a:gridCol w="2011680">
-                  <a:extLst>
-                    <a:ext uri="{9D8B030D-6E8A-4147-A177-3AD203B41FA5}">
-                      <a16:colId xmlns:a16="http://schemas.microsoft.com/office/drawing/2014/main" val="20002"/>
-                    </a:ext>
-                  </a:extLst>
-                </a:gridCol>
-                <a:gridCol w="1371600">
-                  <a:extLst>
-                    <a:ext uri="{9D8B030D-6E8A-4147-A177-3AD203B41FA5}">
-                      <a16:colId xmlns:a16="http://schemas.microsoft.com/office/drawing/2014/main" val="20003"/>
-                    </a:ext>
-                  </a:extLst>
-                </a:gridCol>
-                <a:gridCol w="2011680">
-                  <a:extLst>
-                    <a:ext uri="{9D8B030D-6E8A-4147-A177-3AD203B41FA5}">
-                      <a16:colId xmlns:a16="http://schemas.microsoft.com/office/drawing/2014/main" val="20004"/>
-                    </a:ext>
-                  </a:extLst>
-                </a:gridCol>
-                <a:gridCol w="1371600">
-                  <a:extLst>
-                    <a:ext uri="{9D8B030D-6E8A-4147-A177-3AD203B41FA5}">
-                      <a16:colId xmlns:a16="http://schemas.microsoft.com/office/drawing/2014/main" val="20005"/>
-                    </a:ext>
-                  </a:extLst>
-                </a:gridCol>
+                <a:gridCol w="1645920"/>
+                <a:gridCol w="1828800"/>
+                <a:gridCol w="2011680"/>
+                <a:gridCol w="1371600"/>
+                <a:gridCol w="2011680"/>
+                <a:gridCol w="1371600"/>
               </a:tblGrid>
               <a:tr h="320040">
                 <a:tc>
@@ -10744,11 +10210,6 @@
                     </a:solidFill>
                   </a:tcPr>
                 </a:tc>
-                <a:extLst>
-                  <a:ext uri="{0D108BD9-81ED-4DB2-BD59-A6C34878D82A}">
-                    <a16:rowId xmlns:a16="http://schemas.microsoft.com/office/drawing/2014/main" val="10000"/>
-                  </a:ext>
-                </a:extLst>
               </a:tr>
               <a:tr h="320040">
                 <a:tc>
@@ -10865,11 +10326,6 @@
                   </a:txBody>
                   <a:tcPr/>
                 </a:tc>
-                <a:extLst>
-                  <a:ext uri="{0D108BD9-81ED-4DB2-BD59-A6C34878D82A}">
-                    <a16:rowId xmlns:a16="http://schemas.microsoft.com/office/drawing/2014/main" val="10001"/>
-                  </a:ext>
-                </a:extLst>
               </a:tr>
               <a:tr h="320040">
                 <a:tc>
@@ -11010,11 +10466,6 @@
                     </a:solidFill>
                   </a:tcPr>
                 </a:tc>
-                <a:extLst>
-                  <a:ext uri="{0D108BD9-81ED-4DB2-BD59-A6C34878D82A}">
-                    <a16:rowId xmlns:a16="http://schemas.microsoft.com/office/drawing/2014/main" val="10002"/>
-                  </a:ext>
-                </a:extLst>
               </a:tr>
               <a:tr h="320040">
                 <a:tc>
@@ -11131,11 +10582,6 @@
                   </a:txBody>
                   <a:tcPr/>
                 </a:tc>
-                <a:extLst>
-                  <a:ext uri="{0D108BD9-81ED-4DB2-BD59-A6C34878D82A}">
-                    <a16:rowId xmlns:a16="http://schemas.microsoft.com/office/drawing/2014/main" val="10003"/>
-                  </a:ext>
-                </a:extLst>
               </a:tr>
               <a:tr h="320040">
                 <a:tc>
@@ -11276,11 +10722,6 @@
                     </a:solidFill>
                   </a:tcPr>
                 </a:tc>
-                <a:extLst>
-                  <a:ext uri="{0D108BD9-81ED-4DB2-BD59-A6C34878D82A}">
-                    <a16:rowId xmlns:a16="http://schemas.microsoft.com/office/drawing/2014/main" val="10004"/>
-                  </a:ext>
-                </a:extLst>
               </a:tr>
               <a:tr h="320040">
                 <a:tc>
@@ -11397,11 +10838,6 @@
                   </a:txBody>
                   <a:tcPr/>
                 </a:tc>
-                <a:extLst>
-                  <a:ext uri="{0D108BD9-81ED-4DB2-BD59-A6C34878D82A}">
-                    <a16:rowId xmlns:a16="http://schemas.microsoft.com/office/drawing/2014/main" val="10005"/>
-                  </a:ext>
-                </a:extLst>
               </a:tr>
             </a:tbl>
           </a:graphicData>
@@ -11415,7 +10851,7 @@
         </p:nvSpPr>
         <p:spPr>
           <a:xfrm>
-            <a:off x="731520" y="3840480"/>
+            <a:off x="731520" y="4389120"/>
             <a:ext cx="10515600" cy="2011680"/>
           </a:xfrm>
           <a:prstGeom prst="rect">
@@ -11443,7 +10879,6 @@
               </a:defRPr>
             </a:pPr>
             <a:r>
-              <a:rPr dirty="0"/>
               <a:t>The pandemic period saw dramatic growth across all groups, but the growth was far larger for developed countries (+244 per cent) than for developing countries (+143 per cent). This widened the absolute gap even as it temporarily increased the developed-country share.</a:t>
             </a:r>
           </a:p>
@@ -11462,7 +10897,6 @@
               </a:defRPr>
             </a:pPr>
             <a:r>
-              <a:rPr dirty="0"/>
               <a:t>In the post-pandemic period, developed-country records declined by 56 per cent from their pandemic peak, while developing-country records continued to grow, by 27 per cent. For the first time in the period studied, developing countries are generating more records per year than developed countries, though the 2026 figure is based on partial-year data.</a:t>
             </a:r>
           </a:p>
@@ -11481,7 +10915,6 @@
               </a:defRPr>
             </a:pPr>
             <a:r>
-              <a:rPr dirty="0"/>
               <a:t>All vulnerable country groups saw their records decline from pandemic peaks, suggesting that pandemic-era growth was project-specific and temporary.</a:t>
             </a:r>
           </a:p>
@@ -11496,7 +10929,7 @@
 </file>
 
 <file path=ppt/slides/slide22.xml><?xml version="1.0" encoding="utf-8"?>
-<p:sld xmlns:a="http://schemas.openxmlformats.org/drawingml/2006/main" xmlns:r="http://schemas.openxmlformats.org/officeDocument/2006/relationships" xmlns:p="http://schemas.openxmlformats.org/presentationml/2006/main">
+<p:sld xmlns:a="http://schemas.openxmlformats.org/drawingml/2006/main" xmlns:p="http://schemas.openxmlformats.org/presentationml/2006/main" xmlns:r="http://schemas.openxmlformats.org/officeDocument/2006/relationships">
   <p:cSld>
     <p:spTree>
       <p:nvGrpSpPr>
@@ -11504,14 +10937,7 @@
         <p:cNvGrpSpPr/>
         <p:nvPr/>
       </p:nvGrpSpPr>
-      <p:grpSpPr>
-        <a:xfrm>
-          <a:off x="0" y="0"/>
-          <a:ext cx="0" cy="0"/>
-          <a:chOff x="0" y="0"/>
-          <a:chExt cx="0" cy="0"/>
-        </a:xfrm>
-      </p:grpSpPr>
+      <p:grpSpPr/>
       <p:sp>
         <p:nvSpPr>
           <p:cNvPr id="2" name="TextBox 1"/>
@@ -11602,7 +11028,6 @@
           <a:lstStyle/>
           <a:p>
             <a:pPr algn="ctr"/>
-            <a:endParaRPr/>
           </a:p>
         </p:txBody>
       </p:sp>
@@ -11782,7 +11207,7 @@
 </file>
 
 <file path=ppt/slides/slide23.xml><?xml version="1.0" encoding="utf-8"?>
-<p:sld xmlns:a="http://schemas.openxmlformats.org/drawingml/2006/main" xmlns:r="http://schemas.openxmlformats.org/officeDocument/2006/relationships" xmlns:p="http://schemas.openxmlformats.org/presentationml/2006/main">
+<p:sld xmlns:a="http://schemas.openxmlformats.org/drawingml/2006/main" xmlns:p="http://schemas.openxmlformats.org/presentationml/2006/main" xmlns:r="http://schemas.openxmlformats.org/officeDocument/2006/relationships">
   <p:cSld>
     <p:spTree>
       <p:nvGrpSpPr>
@@ -11790,14 +11215,7 @@
         <p:cNvGrpSpPr/>
         <p:nvPr/>
       </p:nvGrpSpPr>
-      <p:grpSpPr>
-        <a:xfrm>
-          <a:off x="0" y="0"/>
-          <a:ext cx="0" cy="0"/>
-          <a:chOff x="0" y="0"/>
-          <a:chExt cx="0" cy="0"/>
-        </a:xfrm>
-      </p:grpSpPr>
+      <p:grpSpPr/>
       <p:sp>
         <p:nvSpPr>
           <p:cNvPr id="2" name="TextBox 1"/>
@@ -11873,7 +11291,6 @@
           <a:lstStyle/>
           <a:p>
             <a:pPr algn="ctr"/>
-            <a:endParaRPr/>
           </a:p>
         </p:txBody>
       </p:sp>
@@ -12035,7 +11452,7 @@
 </file>
 
 <file path=ppt/slides/slide24.xml><?xml version="1.0" encoding="utf-8"?>
-<p:sld xmlns:a="http://schemas.openxmlformats.org/drawingml/2006/main" xmlns:r="http://schemas.openxmlformats.org/officeDocument/2006/relationships" xmlns:p="http://schemas.openxmlformats.org/presentationml/2006/main">
+<p:sld xmlns:a="http://schemas.openxmlformats.org/drawingml/2006/main" xmlns:p="http://schemas.openxmlformats.org/presentationml/2006/main" xmlns:r="http://schemas.openxmlformats.org/officeDocument/2006/relationships">
   <p:cSld>
     <p:spTree>
       <p:nvGrpSpPr>
@@ -12043,14 +11460,7 @@
         <p:cNvGrpSpPr/>
         <p:nvPr/>
       </p:nvGrpSpPr>
-      <p:grpSpPr>
-        <a:xfrm>
-          <a:off x="0" y="0"/>
-          <a:ext cx="0" cy="0"/>
-          <a:chOff x="0" y="0"/>
-          <a:chExt cx="0" cy="0"/>
-        </a:xfrm>
-      </p:grpSpPr>
+      <p:grpSpPr/>
       <p:sp>
         <p:nvSpPr>
           <p:cNvPr id="2" name="TextBox 1"/>
@@ -12126,7 +11536,6 @@
           <a:lstStyle/>
           <a:p>
             <a:pPr algn="ctr"/>
-            <a:endParaRPr/>
           </a:p>
         </p:txBody>
       </p:sp>
@@ -12270,7 +11679,7 @@
 </file>
 
 <file path=ppt/slides/slide25.xml><?xml version="1.0" encoding="utf-8"?>
-<p:sld xmlns:a="http://schemas.openxmlformats.org/drawingml/2006/main" xmlns:r="http://schemas.openxmlformats.org/officeDocument/2006/relationships" xmlns:p="http://schemas.openxmlformats.org/presentationml/2006/main">
+<p:sld xmlns:a="http://schemas.openxmlformats.org/drawingml/2006/main" xmlns:p="http://schemas.openxmlformats.org/presentationml/2006/main" xmlns:r="http://schemas.openxmlformats.org/officeDocument/2006/relationships">
   <p:cSld>
     <p:bg>
       <p:bgPr>
@@ -12286,14 +11695,7 @@
         <p:cNvGrpSpPr/>
         <p:nvPr/>
       </p:nvGrpSpPr>
-      <p:grpSpPr>
-        <a:xfrm>
-          <a:off x="0" y="0"/>
-          <a:ext cx="0" cy="0"/>
-          <a:chOff x="0" y="0"/>
-          <a:chExt cx="0" cy="0"/>
-        </a:xfrm>
-      </p:grpSpPr>
+      <p:grpSpPr/>
       <p:sp>
         <p:nvSpPr>
           <p:cNvPr id="2" name="TextBox 1"/>
@@ -12372,7 +11774,7 @@
 </file>
 
 <file path=ppt/slides/slide3.xml><?xml version="1.0" encoding="utf-8"?>
-<p:sld xmlns:a="http://schemas.openxmlformats.org/drawingml/2006/main" xmlns:r="http://schemas.openxmlformats.org/officeDocument/2006/relationships" xmlns:p="http://schemas.openxmlformats.org/presentationml/2006/main">
+<p:sld xmlns:a="http://schemas.openxmlformats.org/drawingml/2006/main" xmlns:p="http://schemas.openxmlformats.org/presentationml/2006/main" xmlns:r="http://schemas.openxmlformats.org/officeDocument/2006/relationships">
   <p:cSld>
     <p:spTree>
       <p:nvGrpSpPr>
@@ -12380,14 +11782,7 @@
         <p:cNvGrpSpPr/>
         <p:nvPr/>
       </p:nvGrpSpPr>
-      <p:grpSpPr>
-        <a:xfrm>
-          <a:off x="0" y="0"/>
-          <a:ext cx="0" cy="0"/>
-          <a:chOff x="0" y="0"/>
-          <a:chExt cx="0" cy="0"/>
-        </a:xfrm>
-      </p:grpSpPr>
+      <p:grpSpPr/>
       <p:sp>
         <p:nvSpPr>
           <p:cNvPr id="2" name="TextBox 1"/>
@@ -12478,7 +11873,6 @@
           <a:lstStyle/>
           <a:p>
             <a:pPr algn="ctr"/>
-            <a:endParaRPr/>
           </a:p>
         </p:txBody>
       </p:sp>
@@ -12640,7 +12034,7 @@
 </file>
 
 <file path=ppt/slides/slide4.xml><?xml version="1.0" encoding="utf-8"?>
-<p:sld xmlns:a="http://schemas.openxmlformats.org/drawingml/2006/main" xmlns:r="http://schemas.openxmlformats.org/officeDocument/2006/relationships" xmlns:p="http://schemas.openxmlformats.org/presentationml/2006/main">
+<p:sld xmlns:a="http://schemas.openxmlformats.org/drawingml/2006/main" xmlns:p="http://schemas.openxmlformats.org/presentationml/2006/main" xmlns:r="http://schemas.openxmlformats.org/officeDocument/2006/relationships">
   <p:cSld>
     <p:spTree>
       <p:nvGrpSpPr>
@@ -12648,14 +12042,7 @@
         <p:cNvGrpSpPr/>
         <p:nvPr/>
       </p:nvGrpSpPr>
-      <p:grpSpPr>
-        <a:xfrm>
-          <a:off x="0" y="0"/>
-          <a:ext cx="0" cy="0"/>
-          <a:chOff x="0" y="0"/>
-          <a:chExt cx="0" cy="0"/>
-        </a:xfrm>
-      </p:grpSpPr>
+      <p:grpSpPr/>
       <p:sp>
         <p:nvSpPr>
           <p:cNvPr id="2" name="TextBox 1"/>
@@ -12746,7 +12133,6 @@
           <a:lstStyle/>
           <a:p>
             <a:pPr algn="ctr"/>
-            <a:endParaRPr/>
           </a:p>
         </p:txBody>
       </p:sp>
@@ -12854,7 +12240,7 @@
 </file>
 
 <file path=ppt/slides/slide5.xml><?xml version="1.0" encoding="utf-8"?>
-<p:sld xmlns:a="http://schemas.openxmlformats.org/drawingml/2006/main" xmlns:r="http://schemas.openxmlformats.org/officeDocument/2006/relationships" xmlns:p="http://schemas.openxmlformats.org/presentationml/2006/main">
+<p:sld xmlns:a="http://schemas.openxmlformats.org/drawingml/2006/main" xmlns:p="http://schemas.openxmlformats.org/presentationml/2006/main" xmlns:r="http://schemas.openxmlformats.org/officeDocument/2006/relationships">
   <p:cSld>
     <p:spTree>
       <p:nvGrpSpPr>
@@ -12862,14 +12248,7 @@
         <p:cNvGrpSpPr/>
         <p:nvPr/>
       </p:nvGrpSpPr>
-      <p:grpSpPr>
-        <a:xfrm>
-          <a:off x="0" y="0"/>
-          <a:ext cx="0" cy="0"/>
-          <a:chOff x="0" y="0"/>
-          <a:chExt cx="0" cy="0"/>
-        </a:xfrm>
-      </p:grpSpPr>
+      <p:grpSpPr/>
       <p:sp>
         <p:nvSpPr>
           <p:cNvPr id="2" name="TextBox 1"/>
@@ -12960,7 +12339,6 @@
           <a:lstStyle/>
           <a:p>
             <a:pPr algn="ctr"/>
-            <a:endParaRPr/>
           </a:p>
         </p:txBody>
       </p:sp>
@@ -13068,7 +12446,7 @@
 </file>
 
 <file path=ppt/slides/slide6.xml><?xml version="1.0" encoding="utf-8"?>
-<p:sld xmlns:a="http://schemas.openxmlformats.org/drawingml/2006/main" xmlns:r="http://schemas.openxmlformats.org/officeDocument/2006/relationships" xmlns:p="http://schemas.openxmlformats.org/presentationml/2006/main">
+<p:sld xmlns:a="http://schemas.openxmlformats.org/drawingml/2006/main" xmlns:p="http://schemas.openxmlformats.org/presentationml/2006/main" xmlns:r="http://schemas.openxmlformats.org/officeDocument/2006/relationships">
   <p:cSld>
     <p:spTree>
       <p:nvGrpSpPr>
@@ -13076,14 +12454,7 @@
         <p:cNvGrpSpPr/>
         <p:nvPr/>
       </p:nvGrpSpPr>
-      <p:grpSpPr>
-        <a:xfrm>
-          <a:off x="0" y="0"/>
-          <a:ext cx="0" cy="0"/>
-          <a:chOff x="0" y="0"/>
-          <a:chExt cx="0" cy="0"/>
-        </a:xfrm>
-      </p:grpSpPr>
+      <p:grpSpPr/>
       <p:sp>
         <p:nvSpPr>
           <p:cNvPr id="2" name="TextBox 1"/>
@@ -13174,7 +12545,6 @@
           <a:lstStyle/>
           <a:p>
             <a:pPr algn="ctr"/>
-            <a:endParaRPr/>
           </a:p>
         </p:txBody>
       </p:sp>
@@ -13197,27 +12567,9 @@
                 <a:tableStyleId>{5C22544A-7EE6-4342-B048-85BDC9FD1C3A}</a:tableStyleId>
               </a:tblPr>
               <a:tblGrid>
-                <a:gridCol w="2286000">
-                  <a:extLst>
-                    <a:ext uri="{9D8B030D-6E8A-4147-A177-3AD203B41FA5}">
-                      <a16:colId xmlns:a16="http://schemas.microsoft.com/office/drawing/2014/main" val="20000"/>
-                    </a:ext>
-                  </a:extLst>
-                </a:gridCol>
-                <a:gridCol w="2286000">
-                  <a:extLst>
-                    <a:ext uri="{9D8B030D-6E8A-4147-A177-3AD203B41FA5}">
-                      <a16:colId xmlns:a16="http://schemas.microsoft.com/office/drawing/2014/main" val="20001"/>
-                    </a:ext>
-                  </a:extLst>
-                </a:gridCol>
-                <a:gridCol w="2286000">
-                  <a:extLst>
-                    <a:ext uri="{9D8B030D-6E8A-4147-A177-3AD203B41FA5}">
-                      <a16:colId xmlns:a16="http://schemas.microsoft.com/office/drawing/2014/main" val="20002"/>
-                    </a:ext>
-                  </a:extLst>
-                </a:gridCol>
+                <a:gridCol w="2286000"/>
+                <a:gridCol w="2286000"/>
+                <a:gridCol w="2286000"/>
               </a:tblGrid>
               <a:tr h="320040">
                 <a:tc>
@@ -13289,11 +12641,6 @@
                     </a:solidFill>
                   </a:tcPr>
                 </a:tc>
-                <a:extLst>
-                  <a:ext uri="{0D108BD9-81ED-4DB2-BD59-A6C34878D82A}">
-                    <a16:rowId xmlns:a16="http://schemas.microsoft.com/office/drawing/2014/main" val="10000"/>
-                  </a:ext>
-                </a:extLst>
               </a:tr>
               <a:tr h="320040">
                 <a:tc>
@@ -13353,11 +12700,6 @@
                   </a:txBody>
                   <a:tcPr/>
                 </a:tc>
-                <a:extLst>
-                  <a:ext uri="{0D108BD9-81ED-4DB2-BD59-A6C34878D82A}">
-                    <a16:rowId xmlns:a16="http://schemas.microsoft.com/office/drawing/2014/main" val="10001"/>
-                  </a:ext>
-                </a:extLst>
               </a:tr>
               <a:tr h="320040">
                 <a:tc>
@@ -13429,11 +12771,6 @@
                     </a:solidFill>
                   </a:tcPr>
                 </a:tc>
-                <a:extLst>
-                  <a:ext uri="{0D108BD9-81ED-4DB2-BD59-A6C34878D82A}">
-                    <a16:rowId xmlns:a16="http://schemas.microsoft.com/office/drawing/2014/main" val="10002"/>
-                  </a:ext>
-                </a:extLst>
               </a:tr>
               <a:tr h="320040">
                 <a:tc>
@@ -13493,11 +12830,6 @@
                   </a:txBody>
                   <a:tcPr/>
                 </a:tc>
-                <a:extLst>
-                  <a:ext uri="{0D108BD9-81ED-4DB2-BD59-A6C34878D82A}">
-                    <a16:rowId xmlns:a16="http://schemas.microsoft.com/office/drawing/2014/main" val="10003"/>
-                  </a:ext>
-                </a:extLst>
               </a:tr>
               <a:tr h="320040">
                 <a:tc>
@@ -13569,11 +12901,6 @@
                     </a:solidFill>
                   </a:tcPr>
                 </a:tc>
-                <a:extLst>
-                  <a:ext uri="{0D108BD9-81ED-4DB2-BD59-A6C34878D82A}">
-                    <a16:rowId xmlns:a16="http://schemas.microsoft.com/office/drawing/2014/main" val="10004"/>
-                  </a:ext>
-                </a:extLst>
               </a:tr>
               <a:tr h="320040">
                 <a:tc>
@@ -13633,11 +12960,6 @@
                   </a:txBody>
                   <a:tcPr/>
                 </a:tc>
-                <a:extLst>
-                  <a:ext uri="{0D108BD9-81ED-4DB2-BD59-A6C34878D82A}">
-                    <a16:rowId xmlns:a16="http://schemas.microsoft.com/office/drawing/2014/main" val="10005"/>
-                  </a:ext>
-                </a:extLst>
               </a:tr>
             </a:tbl>
           </a:graphicData>
@@ -13711,7 +13033,7 @@
 </file>
 
 <file path=ppt/slides/slide7.xml><?xml version="1.0" encoding="utf-8"?>
-<p:sld xmlns:a="http://schemas.openxmlformats.org/drawingml/2006/main" xmlns:r="http://schemas.openxmlformats.org/officeDocument/2006/relationships" xmlns:p="http://schemas.openxmlformats.org/presentationml/2006/main">
+<p:sld xmlns:a="http://schemas.openxmlformats.org/drawingml/2006/main" xmlns:p="http://schemas.openxmlformats.org/presentationml/2006/main" xmlns:r="http://schemas.openxmlformats.org/officeDocument/2006/relationships">
   <p:cSld>
     <p:spTree>
       <p:nvGrpSpPr>
@@ -13719,14 +13041,7 @@
         <p:cNvGrpSpPr/>
         <p:nvPr/>
       </p:nvGrpSpPr>
-      <p:grpSpPr>
-        <a:xfrm>
-          <a:off x="0" y="0"/>
-          <a:ext cx="0" cy="0"/>
-          <a:chOff x="0" y="0"/>
-          <a:chExt cx="0" cy="0"/>
-        </a:xfrm>
-      </p:grpSpPr>
+      <p:grpSpPr/>
       <p:sp>
         <p:nvSpPr>
           <p:cNvPr id="2" name="TextBox 1"/>
@@ -13817,7 +13132,6 @@
           <a:lstStyle/>
           <a:p>
             <a:pPr algn="ctr"/>
-            <a:endParaRPr/>
           </a:p>
         </p:txBody>
       </p:sp>
@@ -14002,7 +13316,7 @@
 </file>
 
 <file path=ppt/slides/slide8.xml><?xml version="1.0" encoding="utf-8"?>
-<p:sld xmlns:a="http://schemas.openxmlformats.org/drawingml/2006/main" xmlns:r="http://schemas.openxmlformats.org/officeDocument/2006/relationships" xmlns:p="http://schemas.openxmlformats.org/presentationml/2006/main">
+<p:sld xmlns:a="http://schemas.openxmlformats.org/drawingml/2006/main" xmlns:p="http://schemas.openxmlformats.org/presentationml/2006/main" xmlns:r="http://schemas.openxmlformats.org/officeDocument/2006/relationships">
   <p:cSld>
     <p:spTree>
       <p:nvGrpSpPr>
@@ -14010,14 +13324,7 @@
         <p:cNvGrpSpPr/>
         <p:nvPr/>
       </p:nvGrpSpPr>
-      <p:grpSpPr>
-        <a:xfrm>
-          <a:off x="0" y="0"/>
-          <a:ext cx="0" cy="0"/>
-          <a:chOff x="0" y="0"/>
-          <a:chExt cx="0" cy="0"/>
-        </a:xfrm>
-      </p:grpSpPr>
+      <p:grpSpPr/>
       <p:sp>
         <p:nvSpPr>
           <p:cNvPr id="2" name="TextBox 1"/>
@@ -14108,7 +13415,6 @@
           <a:lstStyle/>
           <a:p>
             <a:pPr algn="ctr"/>
-            <a:endParaRPr/>
           </a:p>
         </p:txBody>
       </p:sp>
@@ -14166,25 +13472,7 @@
               </a:defRPr>
             </a:pPr>
             <a:r>
-              <a:t>However, a new problem has emerged in its place. The share of records where the field is present but contains the placeholder value “missing” rose from 3.2 per cent in 2018 to 17.3 per cent in 2026. The surge began in 2023 and has stabilised at around 17 per cent.</a:t>
-            </a:r>
-          </a:p>
-          <a:p>
-            <a:pPr>
-              <a:lnSpc>
-                <a:spcPct val="130000"/>
-              </a:lnSpc>
-              <a:spcBef>
-                <a:spcPts val="800"/>
-              </a:spcBef>
-              <a:defRPr sz="1700" b="0">
-                <a:solidFill>
-                  <a:srgbClr val="1A1A1A"/>
-                </a:solidFill>
-              </a:defRPr>
-            </a:pPr>
-            <a:r>
-              <a:t>Taken together, the share of records with no usable country information has improved from 48.1 per cent to 22.5 per cent. This is genuine progress, but far less dramatic than the decline in field absences alone would suggest.</a:t>
+              <a:t>However, a new problem has emerged in its place. The share of records where the field is present but contains the value “missing” rose from 3.2 per cent in 2018 to 17.3 per cent in 2026. The surge began in 2023, coinciding with the introduction of the mandatory requirement.</a:t>
             </a:r>
           </a:p>
           <a:p>
@@ -14197,12 +13485,30 @@
               </a:spcBef>
               <a:defRPr sz="1600" b="0">
                 <a:solidFill>
+                  <a:srgbClr val="1A1A1A"/>
+                </a:solidFill>
+              </a:defRPr>
+            </a:pPr>
+            <a:r>
+              <a:t>INSDC does provide a structured missing-value reporting framework: submitters who genuinely cannot provide a country should use “missing: ” followed by a specific reason, such as “missing: lab stock” for model organisms, “missing: restricted access” for endangered species, or “missing: not collected”. Some “missing” records are therefore legitimate.</a:t>
+            </a:r>
+          </a:p>
+          <a:p>
+            <a:pPr>
+              <a:lnSpc>
+                <a:spcPct val="130000"/>
+              </a:lnSpc>
+              <a:spcBef>
+                <a:spcPts val="800"/>
+              </a:spcBef>
+              <a:defRPr sz="1600" b="0">
+                <a:solidFill>
                   <a:srgbClr val="666666"/>
                 </a:solidFill>
               </a:defRPr>
             </a:pPr>
             <a:r>
-              <a:t>The remaining 5.2 per cent with no field at all likely reflects submission pipelines that bypass the validation requirement, including bulk imports, legacy system migrations, and submissions made without a structured checklist.</a:t>
+              <a:t>However, many submitters use bare “missing” without a reason, or “missing:missing”, both of which are non-compliant. Without granular reporting, we cannot distinguish legitimate omissions from compliance-without-substance.</a:t>
             </a:r>
           </a:p>
           <a:p>
@@ -14220,7 +13526,7 @@
               </a:defRPr>
             </a:pPr>
             <a:r>
-              <a:t>Implication for allocation: any formula based on country-level counts must decide how to handle the 22.5 per cent of recent records with no usable country. Distributing them proportionally would inflate already-dominant countries; excluding them would undercount countries with poor metadata compliance.</a:t>
+              <a:t>Implication for allocation: any formula based on country-level counts must decide how to handle the 22.5 per cent of recent records with no usable country. The inability to distinguish legitimate from non-compliant omissions makes this harder.</a:t>
             </a:r>
           </a:p>
         </p:txBody>
@@ -14234,7 +13540,7 @@
 </file>
 
 <file path=ppt/slides/slide9.xml><?xml version="1.0" encoding="utf-8"?>
-<p:sld xmlns:a="http://schemas.openxmlformats.org/drawingml/2006/main" xmlns:r="http://schemas.openxmlformats.org/officeDocument/2006/relationships" xmlns:p="http://schemas.openxmlformats.org/presentationml/2006/main">
+<p:sld xmlns:a="http://schemas.openxmlformats.org/drawingml/2006/main" xmlns:p="http://schemas.openxmlformats.org/presentationml/2006/main" xmlns:r="http://schemas.openxmlformats.org/officeDocument/2006/relationships">
   <p:cSld>
     <p:spTree>
       <p:nvGrpSpPr>
@@ -14242,14 +13548,7 @@
         <p:cNvGrpSpPr/>
         <p:nvPr/>
       </p:nvGrpSpPr>
-      <p:grpSpPr>
-        <a:xfrm>
-          <a:off x="0" y="0"/>
-          <a:ext cx="0" cy="0"/>
-          <a:chOff x="0" y="0"/>
-          <a:chExt cx="0" cy="0"/>
-        </a:xfrm>
-      </p:grpSpPr>
+      <p:grpSpPr/>
       <p:sp>
         <p:nvSpPr>
           <p:cNvPr id="2" name="TextBox 1"/>
@@ -14340,7 +13639,6 @@
           <a:lstStyle/>
           <a:p>
             <a:pPr algn="ctr"/>
-            <a:endParaRPr/>
           </a:p>
         </p:txBody>
       </p:sp>
@@ -14380,24 +13678,25 @@
               </a:defRPr>
             </a:pPr>
             <a:r>
-              <a:rPr dirty="0"/>
-              <a:t>The INSDC specification defines the country field (</a:t>
-            </a:r>
-            <a:r>
-              <a:rPr dirty="0" err="1"/>
-              <a:t>geo_loc_name</a:t>
-            </a:r>
-            <a:r>
-              <a:rPr dirty="0"/>
-              <a:t>) as a controlled vocabulary. The country portion must be one of approximately 296 approved values, with an optional free-text region and locality after a colon, for example “</a:t>
-            </a:r>
-            <a:r>
-              <a:rPr dirty="0" err="1"/>
-              <a:t>Canada:Vancouver</a:t>
-            </a:r>
-            <a:r>
-              <a:rPr dirty="0"/>
-              <a:t>”.</a:t>
+              <a:t>The INSDC specification defines the country field (geo_loc_name) as a controlled vocabulary. The country portion must be one of approximately 296 approved values, with an optional free-text region and locality after a colon, for example “Canada:Vancouver”.</a:t>
+            </a:r>
+          </a:p>
+          <a:p>
+            <a:pPr>
+              <a:lnSpc>
+                <a:spcPct val="130000"/>
+              </a:lnSpc>
+              <a:spcBef>
+                <a:spcPts val="800"/>
+              </a:spcBef>
+              <a:defRPr sz="1600" b="0">
+                <a:solidFill>
+                  <a:srgbClr val="1A1A1A"/>
+                </a:solidFill>
+              </a:defRPr>
+            </a:pPr>
+            <a:r>
+              <a:t>INSDC also provides a missing-value reporting vocabulary with specific terms: “not applicable” (e.g., for control samples) and “missing” (to be followed by a reason such as “lab stock”, “not collected”, “restricted access”, “human-identifiable”, or “synthetic construct”).</a:t>
             </a:r>
           </a:p>
           <a:p>
@@ -14415,7 +13714,6 @@
               </a:defRPr>
             </a:pPr>
             <a:r>
-              <a:rPr dirty="0"/>
               <a:t>In practice, enforcement is weak:</a:t>
             </a:r>
           </a:p>
@@ -14434,8 +13732,7 @@
               </a:defRPr>
             </a:pPr>
             <a:r>
-              <a:rPr dirty="0"/>
-              <a:t>82 non-vocabulary values were found in the database, including alternative names (“UK” instead of “United Kingdom”), misspellings (“Columbia” instead of “Colombia”), and locality names entered without a country prefix.</a:t>
+              <a:t>82 non-vocabulary country values were found in the database, including alternative names (“UK” instead of “United Kingdom”), misspellings (“Columbia” instead of “Colombia”), and locality names entered without a country prefix.</a:t>
             </a:r>
           </a:p>
           <a:p>
@@ -14453,8 +13750,7 @@
               </a:defRPr>
             </a:pPr>
             <a:r>
-              <a:rPr dirty="0"/>
-              <a:t>The placeholder “missing” is not an INSDC-approved null term, yet 17.3 per cent of 2026 records use it. INSDC maintains a separate list of approved null terms, but submitters are not using them.</a:t>
+              <a:t>The value “missing” is an approved INSDC term, but the specification requires it to be used with a reporting-level reason (e.g., “missing: lab stock”). Many submitters use bare “missing” or the invalid “missing:missing”, both non-compliant.</a:t>
             </a:r>
           </a:p>
           <a:p>
@@ -14472,7 +13768,6 @@
               </a:defRPr>
             </a:pPr>
             <a:r>
-              <a:rPr dirty="0"/>
               <a:t>5.2 per cent of 2026 records have no country field at all, despite the field being compulsory since 2021.</a:t>
             </a:r>
           </a:p>
@@ -14491,7 +13786,6 @@
               </a:defRPr>
             </a:pPr>
             <a:r>
-              <a:rPr dirty="0"/>
               <a:t>The free-text region and locality portion causes token-matching collisions, for example “USA: New Mexico” matching a query for “Mexico”.</a:t>
             </a:r>
           </a:p>
@@ -14510,24 +13804,7 @@
               </a:defRPr>
             </a:pPr>
             <a:r>
-              <a:rPr dirty="0"/>
-              <a:t>Recommendation: </a:t>
-            </a:r>
-            <a:r>
-              <a:rPr lang="en-GB" dirty="0"/>
-              <a:t>Enforcing </a:t>
-            </a:r>
-            <a:r>
-              <a:rPr dirty="0"/>
-              <a:t>the controlled vocabulary at submission time, rejecting records where the country portion is not from the approved list or where approved null terms are not used. This would improve data quality for all downstream uses, including </a:t>
-            </a:r>
-            <a:r>
-              <a:rPr lang="en-GB" dirty="0"/>
-              <a:t>identifying provenance and </a:t>
-            </a:r>
-            <a:r>
-              <a:rPr dirty="0"/>
-              <a:t>any future allocation methodology under the Cali Fund.</a:t>
+              <a:t>Recommendation: INSDC should enforce both the controlled vocabulary for country names and the missing-value reporting format at submission time, rejecting records where the country portion is not from the approved list and where “missing” is used without a valid reporting-level term. This would improve data quality for all downstream uses, including any future allocation methodology under the Cali Fund.</a:t>
             </a:r>
           </a:p>
         </p:txBody>
@@ -14562,7 +13839,7 @@
               </a:defRPr>
             </a:pPr>
             <a:r>
-              <a:t>Source: INSDC geo_loc_name qualifier specification (insdc.org), ENA Portal API verification (13 October 2026).</a:t>
+              <a:t>Source: INSDC geo_loc_name qualifier specification and INSDC missing value reporting terms (insdc.org), ENA Portal API verification (13 October 2026).</a:t>
             </a:r>
           </a:p>
         </p:txBody>

</xml_diff>

<commit_message>
Fix slide accuracy: attribution table, percentages, UK COVID numbers, limitations
- Slide 6: Fix attribution table (sovereign 18,934,645 not 18,987,186;
  non-country 3,662,923 not 3,920,292; categories now sum to 30,313,212)
- Change 38.3% to 37.5% throughout (slides 6, 22)
- Slide 20: Update UK COVID numbers (165,918 to 1,593,869, not 162,561 to 1,651,232)
- Slide 24: Add token-matching collision caveat to limitations section
- Remove old backup file

Co-authored-by: factory-droid[bot] <138933559+factory-droid[bot]@users.noreply.github.com>
</commit_message>
<xml_diff>
--- a/pipeline/output/DRAFT_global_sequence_accessions.pptx
+++ b/pipeline/output/DRAFT_global_sequence_accessions.pptx
@@ -5,33 +5,33 @@
     <p:sldMasterId id="2147483648" r:id="rId1"/>
   </p:sldMasterIdLst>
   <p:sldIdLst>
-    <p:sldId id="256" r:id="rId7"/>
-    <p:sldId id="257" r:id="rId8"/>
-    <p:sldId id="258" r:id="rId9"/>
-    <p:sldId id="259" r:id="rId10"/>
-    <p:sldId id="260" r:id="rId11"/>
-    <p:sldId id="261" r:id="rId12"/>
-    <p:sldId id="262" r:id="rId13"/>
-    <p:sldId id="263" r:id="rId14"/>
-    <p:sldId id="264" r:id="rId15"/>
-    <p:sldId id="265" r:id="rId16"/>
-    <p:sldId id="266" r:id="rId17"/>
-    <p:sldId id="267" r:id="rId18"/>
-    <p:sldId id="268" r:id="rId19"/>
-    <p:sldId id="269" r:id="rId20"/>
-    <p:sldId id="270" r:id="rId21"/>
-    <p:sldId id="271" r:id="rId22"/>
-    <p:sldId id="272" r:id="rId23"/>
-    <p:sldId id="273" r:id="rId24"/>
-    <p:sldId id="274" r:id="rId25"/>
-    <p:sldId id="275" r:id="rId26"/>
-    <p:sldId id="276" r:id="rId27"/>
-    <p:sldId id="277" r:id="rId28"/>
-    <p:sldId id="278" r:id="rId29"/>
-    <p:sldId id="279" r:id="rId30"/>
-    <p:sldId id="280" r:id="rId31"/>
+    <p:sldId id="256" r:id="rId2"/>
+    <p:sldId id="257" r:id="rId3"/>
+    <p:sldId id="258" r:id="rId4"/>
+    <p:sldId id="259" r:id="rId5"/>
+    <p:sldId id="260" r:id="rId6"/>
+    <p:sldId id="261" r:id="rId7"/>
+    <p:sldId id="262" r:id="rId8"/>
+    <p:sldId id="263" r:id="rId9"/>
+    <p:sldId id="264" r:id="rId10"/>
+    <p:sldId id="265" r:id="rId11"/>
+    <p:sldId id="266" r:id="rId12"/>
+    <p:sldId id="267" r:id="rId13"/>
+    <p:sldId id="268" r:id="rId14"/>
+    <p:sldId id="269" r:id="rId15"/>
+    <p:sldId id="270" r:id="rId16"/>
+    <p:sldId id="271" r:id="rId17"/>
+    <p:sldId id="272" r:id="rId18"/>
+    <p:sldId id="273" r:id="rId19"/>
+    <p:sldId id="274" r:id="rId20"/>
+    <p:sldId id="275" r:id="rId21"/>
+    <p:sldId id="276" r:id="rId22"/>
+    <p:sldId id="277" r:id="rId23"/>
+    <p:sldId id="278" r:id="rId24"/>
+    <p:sldId id="279" r:id="rId25"/>
+    <p:sldId id="280" r:id="rId26"/>
   </p:sldIdLst>
-  <p:sldSz cx="12191695" cy="6858000" type="screen4x3"/>
+  <p:sldSz cx="12192000" cy="6858000"/>
   <p:notesSz cx="6858000" cy="9144000"/>
   <p:defaultTextStyle>
     <a:defPPr>
@@ -128,6 +128,22 @@
       </a:defRPr>
     </a:lvl9pPr>
   </p:defaultTextStyle>
+  <p:extLst>
+    <p:ext uri="{EFAFB233-063F-42B5-8137-9DF3F51BA10A}">
+      <p15:sldGuideLst xmlns:p15="http://schemas.microsoft.com/office/powerpoint/2012/main">
+        <p15:guide id="1" orient="horz" pos="2160">
+          <p15:clr>
+            <a:srgbClr val="A4A3A4"/>
+          </p15:clr>
+        </p15:guide>
+        <p15:guide id="2" pos="2880">
+          <p15:clr>
+            <a:srgbClr val="A4A3A4"/>
+          </p15:clr>
+        </p15:guide>
+      </p15:sldGuideLst>
+    </p:ext>
+  </p:extLst>
 </p:presentation>
 </file>
 
@@ -169,10 +185,9 @@
           <a:lstStyle/>
           <a:p>
             <a:r>
-              <a:rPr lang="en-US" smtClean="0"/>
+              <a:rPr lang="en-US"/>
               <a:t>Click to edit Master title style</a:t>
             </a:r>
-            <a:endParaRPr lang="en-US"/>
           </a:p>
         </p:txBody>
       </p:sp>
@@ -288,10 +303,9 @@
           </a:lstStyle>
           <a:p>
             <a:r>
-              <a:rPr lang="en-US" smtClean="0"/>
+              <a:rPr lang="en-US"/>
               <a:t>Click to edit Master subtitle style</a:t>
             </a:r>
-            <a:endParaRPr lang="en-US"/>
           </a:p>
         </p:txBody>
       </p:sp>
@@ -312,7 +326,7 @@
           <a:p>
             <a:fld id="{5BCAD085-E8A6-8845-BD4E-CB4CCA059FC4}" type="datetimeFigureOut">
               <a:rPr lang="en-US" smtClean="0"/>
-              <a:t>1/27/13</a:t>
+              <a:t>10/16/26</a:t>
             </a:fld>
             <a:endParaRPr lang="en-US"/>
           </a:p>
@@ -406,10 +420,9 @@
           <a:lstStyle/>
           <a:p>
             <a:r>
-              <a:rPr lang="en-US" smtClean="0"/>
+              <a:rPr lang="en-US"/>
               <a:t>Click to edit Master title style</a:t>
             </a:r>
-            <a:endParaRPr lang="en-US"/>
           </a:p>
         </p:txBody>
       </p:sp>
@@ -430,38 +443,37 @@
           <a:p>
             <a:pPr lvl="0"/>
             <a:r>
-              <a:rPr lang="en-US" smtClean="0"/>
+              <a:rPr lang="en-US"/>
               <a:t>Click to edit Master text styles</a:t>
             </a:r>
           </a:p>
           <a:p>
             <a:pPr lvl="1"/>
             <a:r>
-              <a:rPr lang="en-US" smtClean="0"/>
+              <a:rPr lang="en-US"/>
               <a:t>Second level</a:t>
             </a:r>
           </a:p>
           <a:p>
             <a:pPr lvl="2"/>
             <a:r>
-              <a:rPr lang="en-US" smtClean="0"/>
+              <a:rPr lang="en-US"/>
               <a:t>Third level</a:t>
             </a:r>
           </a:p>
           <a:p>
             <a:pPr lvl="3"/>
             <a:r>
-              <a:rPr lang="en-US" smtClean="0"/>
+              <a:rPr lang="en-US"/>
               <a:t>Fourth level</a:t>
             </a:r>
           </a:p>
           <a:p>
             <a:pPr lvl="4"/>
             <a:r>
-              <a:rPr lang="en-US" smtClean="0"/>
+              <a:rPr lang="en-US"/>
               <a:t>Fifth level</a:t>
             </a:r>
-            <a:endParaRPr lang="en-US"/>
           </a:p>
         </p:txBody>
       </p:sp>
@@ -482,7 +494,7 @@
           <a:p>
             <a:fld id="{5BCAD085-E8A6-8845-BD4E-CB4CCA059FC4}" type="datetimeFigureOut">
               <a:rPr lang="en-US" smtClean="0"/>
-              <a:t>1/27/13</a:t>
+              <a:t>10/16/26</a:t>
             </a:fld>
             <a:endParaRPr lang="en-US"/>
           </a:p>
@@ -581,10 +593,9 @@
           <a:lstStyle/>
           <a:p>
             <a:r>
-              <a:rPr lang="en-US" smtClean="0"/>
+              <a:rPr lang="en-US"/>
               <a:t>Click to edit Master title style</a:t>
             </a:r>
-            <a:endParaRPr lang="en-US"/>
           </a:p>
         </p:txBody>
       </p:sp>
@@ -610,38 +621,37 @@
           <a:p>
             <a:pPr lvl="0"/>
             <a:r>
-              <a:rPr lang="en-US" smtClean="0"/>
+              <a:rPr lang="en-US"/>
               <a:t>Click to edit Master text styles</a:t>
             </a:r>
           </a:p>
           <a:p>
             <a:pPr lvl="1"/>
             <a:r>
-              <a:rPr lang="en-US" smtClean="0"/>
+              <a:rPr lang="en-US"/>
               <a:t>Second level</a:t>
             </a:r>
           </a:p>
           <a:p>
             <a:pPr lvl="2"/>
             <a:r>
-              <a:rPr lang="en-US" smtClean="0"/>
+              <a:rPr lang="en-US"/>
               <a:t>Third level</a:t>
             </a:r>
           </a:p>
           <a:p>
             <a:pPr lvl="3"/>
             <a:r>
-              <a:rPr lang="en-US" smtClean="0"/>
+              <a:rPr lang="en-US"/>
               <a:t>Fourth level</a:t>
             </a:r>
           </a:p>
           <a:p>
             <a:pPr lvl="4"/>
             <a:r>
-              <a:rPr lang="en-US" smtClean="0"/>
+              <a:rPr lang="en-US"/>
               <a:t>Fifth level</a:t>
             </a:r>
-            <a:endParaRPr lang="en-US"/>
           </a:p>
         </p:txBody>
       </p:sp>
@@ -662,7 +672,7 @@
           <a:p>
             <a:fld id="{5BCAD085-E8A6-8845-BD4E-CB4CCA059FC4}" type="datetimeFigureOut">
               <a:rPr lang="en-US" smtClean="0"/>
-              <a:t>1/27/13</a:t>
+              <a:t>10/16/26</a:t>
             </a:fld>
             <a:endParaRPr lang="en-US"/>
           </a:p>
@@ -756,10 +766,9 @@
           <a:lstStyle/>
           <a:p>
             <a:r>
-              <a:rPr lang="en-US" smtClean="0"/>
+              <a:rPr lang="en-US"/>
               <a:t>Click to edit Master title style</a:t>
             </a:r>
-            <a:endParaRPr lang="en-US"/>
           </a:p>
         </p:txBody>
       </p:sp>
@@ -780,38 +789,37 @@
           <a:p>
             <a:pPr lvl="0"/>
             <a:r>
-              <a:rPr lang="en-US" smtClean="0"/>
+              <a:rPr lang="en-US"/>
               <a:t>Click to edit Master text styles</a:t>
             </a:r>
           </a:p>
           <a:p>
             <a:pPr lvl="1"/>
             <a:r>
-              <a:rPr lang="en-US" smtClean="0"/>
+              <a:rPr lang="en-US"/>
               <a:t>Second level</a:t>
             </a:r>
           </a:p>
           <a:p>
             <a:pPr lvl="2"/>
             <a:r>
-              <a:rPr lang="en-US" smtClean="0"/>
+              <a:rPr lang="en-US"/>
               <a:t>Third level</a:t>
             </a:r>
           </a:p>
           <a:p>
             <a:pPr lvl="3"/>
             <a:r>
-              <a:rPr lang="en-US" smtClean="0"/>
+              <a:rPr lang="en-US"/>
               <a:t>Fourth level</a:t>
             </a:r>
           </a:p>
           <a:p>
             <a:pPr lvl="4"/>
             <a:r>
-              <a:rPr lang="en-US" smtClean="0"/>
+              <a:rPr lang="en-US"/>
               <a:t>Fifth level</a:t>
             </a:r>
-            <a:endParaRPr lang="en-US"/>
           </a:p>
         </p:txBody>
       </p:sp>
@@ -832,7 +840,7 @@
           <a:p>
             <a:fld id="{5BCAD085-E8A6-8845-BD4E-CB4CCA059FC4}" type="datetimeFigureOut">
               <a:rPr lang="en-US" smtClean="0"/>
-              <a:t>1/27/13</a:t>
+              <a:t>10/16/26</a:t>
             </a:fld>
             <a:endParaRPr lang="en-US"/>
           </a:p>
@@ -935,10 +943,9 @@
           </a:lstStyle>
           <a:p>
             <a:r>
-              <a:rPr lang="en-US" smtClean="0"/>
+              <a:rPr lang="en-US"/>
               <a:t>Click to edit Master title style</a:t>
             </a:r>
-            <a:endParaRPr lang="en-US"/>
           </a:p>
         </p:txBody>
       </p:sp>
@@ -1055,7 +1062,7 @@
           <a:p>
             <a:pPr lvl="0"/>
             <a:r>
-              <a:rPr lang="en-US" smtClean="0"/>
+              <a:rPr lang="en-US"/>
               <a:t>Click to edit Master text styles</a:t>
             </a:r>
           </a:p>
@@ -1078,7 +1085,7 @@
           <a:p>
             <a:fld id="{5BCAD085-E8A6-8845-BD4E-CB4CCA059FC4}" type="datetimeFigureOut">
               <a:rPr lang="en-US" smtClean="0"/>
-              <a:t>1/27/13</a:t>
+              <a:t>10/16/26</a:t>
             </a:fld>
             <a:endParaRPr lang="en-US"/>
           </a:p>
@@ -1172,10 +1179,9 @@
           <a:lstStyle/>
           <a:p>
             <a:r>
-              <a:rPr lang="en-US" smtClean="0"/>
+              <a:rPr lang="en-US"/>
               <a:t>Click to edit Master title style</a:t>
             </a:r>
-            <a:endParaRPr lang="en-US"/>
           </a:p>
         </p:txBody>
       </p:sp>
@@ -1229,38 +1235,37 @@
           <a:p>
             <a:pPr lvl="0"/>
             <a:r>
-              <a:rPr lang="en-US" smtClean="0"/>
+              <a:rPr lang="en-US"/>
               <a:t>Click to edit Master text styles</a:t>
             </a:r>
           </a:p>
           <a:p>
             <a:pPr lvl="1"/>
             <a:r>
-              <a:rPr lang="en-US" smtClean="0"/>
+              <a:rPr lang="en-US"/>
               <a:t>Second level</a:t>
             </a:r>
           </a:p>
           <a:p>
             <a:pPr lvl="2"/>
             <a:r>
-              <a:rPr lang="en-US" smtClean="0"/>
+              <a:rPr lang="en-US"/>
               <a:t>Third level</a:t>
             </a:r>
           </a:p>
           <a:p>
             <a:pPr lvl="3"/>
             <a:r>
-              <a:rPr lang="en-US" smtClean="0"/>
+              <a:rPr lang="en-US"/>
               <a:t>Fourth level</a:t>
             </a:r>
           </a:p>
           <a:p>
             <a:pPr lvl="4"/>
             <a:r>
-              <a:rPr lang="en-US" smtClean="0"/>
+              <a:rPr lang="en-US"/>
               <a:t>Fifth level</a:t>
             </a:r>
-            <a:endParaRPr lang="en-US"/>
           </a:p>
         </p:txBody>
       </p:sp>
@@ -1314,38 +1319,37 @@
           <a:p>
             <a:pPr lvl="0"/>
             <a:r>
-              <a:rPr lang="en-US" smtClean="0"/>
+              <a:rPr lang="en-US"/>
               <a:t>Click to edit Master text styles</a:t>
             </a:r>
           </a:p>
           <a:p>
             <a:pPr lvl="1"/>
             <a:r>
-              <a:rPr lang="en-US" smtClean="0"/>
+              <a:rPr lang="en-US"/>
               <a:t>Second level</a:t>
             </a:r>
           </a:p>
           <a:p>
             <a:pPr lvl="2"/>
             <a:r>
-              <a:rPr lang="en-US" smtClean="0"/>
+              <a:rPr lang="en-US"/>
               <a:t>Third level</a:t>
             </a:r>
           </a:p>
           <a:p>
             <a:pPr lvl="3"/>
             <a:r>
-              <a:rPr lang="en-US" smtClean="0"/>
+              <a:rPr lang="en-US"/>
               <a:t>Fourth level</a:t>
             </a:r>
           </a:p>
           <a:p>
             <a:pPr lvl="4"/>
             <a:r>
-              <a:rPr lang="en-US" smtClean="0"/>
+              <a:rPr lang="en-US"/>
               <a:t>Fifth level</a:t>
             </a:r>
-            <a:endParaRPr lang="en-US"/>
           </a:p>
         </p:txBody>
       </p:sp>
@@ -1366,7 +1370,7 @@
           <a:p>
             <a:fld id="{5BCAD085-E8A6-8845-BD4E-CB4CCA059FC4}" type="datetimeFigureOut">
               <a:rPr lang="en-US" smtClean="0"/>
-              <a:t>1/27/13</a:t>
+              <a:t>10/16/26</a:t>
             </a:fld>
             <a:endParaRPr lang="en-US"/>
           </a:p>
@@ -1464,10 +1468,9 @@
           </a:lstStyle>
           <a:p>
             <a:r>
-              <a:rPr lang="en-US" smtClean="0"/>
+              <a:rPr lang="en-US"/>
               <a:t>Click to edit Master title style</a:t>
             </a:r>
-            <a:endParaRPr lang="en-US"/>
           </a:p>
         </p:txBody>
       </p:sp>
@@ -1530,7 +1533,7 @@
           <a:p>
             <a:pPr lvl="0"/>
             <a:r>
-              <a:rPr lang="en-US" smtClean="0"/>
+              <a:rPr lang="en-US"/>
               <a:t>Click to edit Master text styles</a:t>
             </a:r>
           </a:p>
@@ -1586,38 +1589,37 @@
           <a:p>
             <a:pPr lvl="0"/>
             <a:r>
-              <a:rPr lang="en-US" smtClean="0"/>
+              <a:rPr lang="en-US"/>
               <a:t>Click to edit Master text styles</a:t>
             </a:r>
           </a:p>
           <a:p>
             <a:pPr lvl="1"/>
             <a:r>
-              <a:rPr lang="en-US" smtClean="0"/>
+              <a:rPr lang="en-US"/>
               <a:t>Second level</a:t>
             </a:r>
           </a:p>
           <a:p>
             <a:pPr lvl="2"/>
             <a:r>
-              <a:rPr lang="en-US" smtClean="0"/>
+              <a:rPr lang="en-US"/>
               <a:t>Third level</a:t>
             </a:r>
           </a:p>
           <a:p>
             <a:pPr lvl="3"/>
             <a:r>
-              <a:rPr lang="en-US" smtClean="0"/>
+              <a:rPr lang="en-US"/>
               <a:t>Fourth level</a:t>
             </a:r>
           </a:p>
           <a:p>
             <a:pPr lvl="4"/>
             <a:r>
-              <a:rPr lang="en-US" smtClean="0"/>
+              <a:rPr lang="en-US"/>
               <a:t>Fifth level</a:t>
             </a:r>
-            <a:endParaRPr lang="en-US"/>
           </a:p>
         </p:txBody>
       </p:sp>
@@ -1680,7 +1682,7 @@
           <a:p>
             <a:pPr lvl="0"/>
             <a:r>
-              <a:rPr lang="en-US" smtClean="0"/>
+              <a:rPr lang="en-US"/>
               <a:t>Click to edit Master text styles</a:t>
             </a:r>
           </a:p>
@@ -1736,38 +1738,37 @@
           <a:p>
             <a:pPr lvl="0"/>
             <a:r>
-              <a:rPr lang="en-US" smtClean="0"/>
+              <a:rPr lang="en-US"/>
               <a:t>Click to edit Master text styles</a:t>
             </a:r>
           </a:p>
           <a:p>
             <a:pPr lvl="1"/>
             <a:r>
-              <a:rPr lang="en-US" smtClean="0"/>
+              <a:rPr lang="en-US"/>
               <a:t>Second level</a:t>
             </a:r>
           </a:p>
           <a:p>
             <a:pPr lvl="2"/>
             <a:r>
-              <a:rPr lang="en-US" smtClean="0"/>
+              <a:rPr lang="en-US"/>
               <a:t>Third level</a:t>
             </a:r>
           </a:p>
           <a:p>
             <a:pPr lvl="3"/>
             <a:r>
-              <a:rPr lang="en-US" smtClean="0"/>
+              <a:rPr lang="en-US"/>
               <a:t>Fourth level</a:t>
             </a:r>
           </a:p>
           <a:p>
             <a:pPr lvl="4"/>
             <a:r>
-              <a:rPr lang="en-US" smtClean="0"/>
+              <a:rPr lang="en-US"/>
               <a:t>Fifth level</a:t>
             </a:r>
-            <a:endParaRPr lang="en-US"/>
           </a:p>
         </p:txBody>
       </p:sp>
@@ -1788,7 +1789,7 @@
           <a:p>
             <a:fld id="{5BCAD085-E8A6-8845-BD4E-CB4CCA059FC4}" type="datetimeFigureOut">
               <a:rPr lang="en-US" smtClean="0"/>
-              <a:t>1/27/13</a:t>
+              <a:t>10/16/26</a:t>
             </a:fld>
             <a:endParaRPr lang="en-US"/>
           </a:p>
@@ -1882,10 +1883,9 @@
           <a:lstStyle/>
           <a:p>
             <a:r>
-              <a:rPr lang="en-US" smtClean="0"/>
+              <a:rPr lang="en-US"/>
               <a:t>Click to edit Master title style</a:t>
             </a:r>
-            <a:endParaRPr lang="en-US"/>
           </a:p>
         </p:txBody>
       </p:sp>
@@ -1906,7 +1906,7 @@
           <a:p>
             <a:fld id="{5BCAD085-E8A6-8845-BD4E-CB4CCA059FC4}" type="datetimeFigureOut">
               <a:rPr lang="en-US" smtClean="0"/>
-              <a:t>1/27/13</a:t>
+              <a:t>10/16/26</a:t>
             </a:fld>
             <a:endParaRPr lang="en-US"/>
           </a:p>
@@ -2001,7 +2001,7 @@
           <a:p>
             <a:fld id="{5BCAD085-E8A6-8845-BD4E-CB4CCA059FC4}" type="datetimeFigureOut">
               <a:rPr lang="en-US" smtClean="0"/>
-              <a:t>1/27/13</a:t>
+              <a:t>10/16/26</a:t>
             </a:fld>
             <a:endParaRPr lang="en-US"/>
           </a:p>
@@ -2104,10 +2104,9 @@
           </a:lstStyle>
           <a:p>
             <a:r>
-              <a:rPr lang="en-US" smtClean="0"/>
+              <a:rPr lang="en-US"/>
               <a:t>Click to edit Master title style</a:t>
             </a:r>
-            <a:endParaRPr lang="en-US"/>
           </a:p>
         </p:txBody>
       </p:sp>
@@ -2161,38 +2160,37 @@
           <a:p>
             <a:pPr lvl="0"/>
             <a:r>
-              <a:rPr lang="en-US" smtClean="0"/>
+              <a:rPr lang="en-US"/>
               <a:t>Click to edit Master text styles</a:t>
             </a:r>
           </a:p>
           <a:p>
             <a:pPr lvl="1"/>
             <a:r>
-              <a:rPr lang="en-US" smtClean="0"/>
+              <a:rPr lang="en-US"/>
               <a:t>Second level</a:t>
             </a:r>
           </a:p>
           <a:p>
             <a:pPr lvl="2"/>
             <a:r>
-              <a:rPr lang="en-US" smtClean="0"/>
+              <a:rPr lang="en-US"/>
               <a:t>Third level</a:t>
             </a:r>
           </a:p>
           <a:p>
             <a:pPr lvl="3"/>
             <a:r>
-              <a:rPr lang="en-US" smtClean="0"/>
+              <a:rPr lang="en-US"/>
               <a:t>Fourth level</a:t>
             </a:r>
           </a:p>
           <a:p>
             <a:pPr lvl="4"/>
             <a:r>
-              <a:rPr lang="en-US" smtClean="0"/>
+              <a:rPr lang="en-US"/>
               <a:t>Fifth level</a:t>
             </a:r>
-            <a:endParaRPr lang="en-US"/>
           </a:p>
         </p:txBody>
       </p:sp>
@@ -2255,7 +2253,7 @@
           <a:p>
             <a:pPr lvl="0"/>
             <a:r>
-              <a:rPr lang="en-US" smtClean="0"/>
+              <a:rPr lang="en-US"/>
               <a:t>Click to edit Master text styles</a:t>
             </a:r>
           </a:p>
@@ -2278,7 +2276,7 @@
           <a:p>
             <a:fld id="{5BCAD085-E8A6-8845-BD4E-CB4CCA059FC4}" type="datetimeFigureOut">
               <a:rPr lang="en-US" smtClean="0"/>
-              <a:t>1/27/13</a:t>
+              <a:t>10/16/26</a:t>
             </a:fld>
             <a:endParaRPr lang="en-US"/>
           </a:p>
@@ -2381,10 +2379,9 @@
           </a:lstStyle>
           <a:p>
             <a:r>
-              <a:rPr lang="en-US" smtClean="0"/>
+              <a:rPr lang="en-US"/>
               <a:t>Click to edit Master title style</a:t>
             </a:r>
-            <a:endParaRPr lang="en-US"/>
           </a:p>
         </p:txBody>
       </p:sp>
@@ -2508,7 +2505,7 @@
           <a:p>
             <a:pPr lvl="0"/>
             <a:r>
-              <a:rPr lang="en-US" smtClean="0"/>
+              <a:rPr lang="en-US"/>
               <a:t>Click to edit Master text styles</a:t>
             </a:r>
           </a:p>
@@ -2531,7 +2528,7 @@
           <a:p>
             <a:fld id="{5BCAD085-E8A6-8845-BD4E-CB4CCA059FC4}" type="datetimeFigureOut">
               <a:rPr lang="en-US" smtClean="0"/>
-              <a:t>1/27/13</a:t>
+              <a:t>10/16/26</a:t>
             </a:fld>
             <a:endParaRPr lang="en-US"/>
           </a:p>
@@ -2640,10 +2637,9 @@
           <a:lstStyle/>
           <a:p>
             <a:r>
-              <a:rPr lang="en-US" smtClean="0"/>
+              <a:rPr lang="en-US"/>
               <a:t>Click to edit Master title style</a:t>
             </a:r>
-            <a:endParaRPr lang="en-US"/>
           </a:p>
         </p:txBody>
       </p:sp>
@@ -2674,38 +2670,37 @@
           <a:p>
             <a:pPr lvl="0"/>
             <a:r>
-              <a:rPr lang="en-US" smtClean="0"/>
+              <a:rPr lang="en-US"/>
               <a:t>Click to edit Master text styles</a:t>
             </a:r>
           </a:p>
           <a:p>
             <a:pPr lvl="1"/>
             <a:r>
-              <a:rPr lang="en-US" smtClean="0"/>
+              <a:rPr lang="en-US"/>
               <a:t>Second level</a:t>
             </a:r>
           </a:p>
           <a:p>
             <a:pPr lvl="2"/>
             <a:r>
-              <a:rPr lang="en-US" smtClean="0"/>
+              <a:rPr lang="en-US"/>
               <a:t>Third level</a:t>
             </a:r>
           </a:p>
           <a:p>
             <a:pPr lvl="3"/>
             <a:r>
-              <a:rPr lang="en-US" smtClean="0"/>
+              <a:rPr lang="en-US"/>
               <a:t>Fourth level</a:t>
             </a:r>
           </a:p>
           <a:p>
             <a:pPr lvl="4"/>
             <a:r>
-              <a:rPr lang="en-US" smtClean="0"/>
+              <a:rPr lang="en-US"/>
               <a:t>Fifth level</a:t>
             </a:r>
-            <a:endParaRPr lang="en-US"/>
           </a:p>
         </p:txBody>
       </p:sp>
@@ -2744,7 +2739,7 @@
           <a:p>
             <a:fld id="{5BCAD085-E8A6-8845-BD4E-CB4CCA059FC4}" type="datetimeFigureOut">
               <a:rPr lang="en-US" smtClean="0"/>
-              <a:t>1/27/13</a:t>
+              <a:t>10/16/26</a:t>
             </a:fld>
             <a:endParaRPr lang="en-US"/>
           </a:p>
@@ -3103,7 +3098,7 @@
 </file>
 
 <file path=ppt/slides/slide1.xml><?xml version="1.0" encoding="utf-8"?>
-<p:sld xmlns:a="http://schemas.openxmlformats.org/drawingml/2006/main" xmlns:p="http://schemas.openxmlformats.org/presentationml/2006/main" xmlns:r="http://schemas.openxmlformats.org/officeDocument/2006/relationships">
+<p:sld xmlns:a="http://schemas.openxmlformats.org/drawingml/2006/main" xmlns:r="http://schemas.openxmlformats.org/officeDocument/2006/relationships" xmlns:p="http://schemas.openxmlformats.org/presentationml/2006/main">
   <p:cSld>
     <p:bg>
       <p:bgPr>
@@ -3119,7 +3114,14 @@
         <p:cNvGrpSpPr/>
         <p:nvPr/>
       </p:nvGrpSpPr>
-      <p:grpSpPr/>
+      <p:grpSpPr>
+        <a:xfrm>
+          <a:off x="0" y="0"/>
+          <a:ext cx="0" cy="0"/>
+          <a:chOff x="0" y="0"/>
+          <a:chExt cx="0" cy="0"/>
+        </a:xfrm>
+      </p:grpSpPr>
       <p:sp>
         <p:nvSpPr>
           <p:cNvPr id="2" name="TextBox 1"/>
@@ -3129,7 +3131,7 @@
         <p:spPr>
           <a:xfrm>
             <a:off x="914400" y="1828800"/>
-            <a:ext cx="10058400" cy="3200400"/>
+            <a:ext cx="10058400" cy="2328843"/>
           </a:xfrm>
           <a:prstGeom prst="rect">
             <a:avLst/>
@@ -3150,8 +3152,24 @@
               </a:defRPr>
             </a:pPr>
             <a:r>
+              <a:rPr dirty="0"/>
               <a:t>Global Variation in Sequence Accessions Over Time</a:t>
             </a:r>
+            <a:endParaRPr lang="en-GB" dirty="0"/>
+          </a:p>
+          <a:p>
+            <a:pPr>
+              <a:defRPr sz="3600" b="1">
+                <a:solidFill>
+                  <a:srgbClr val="FFFFFF"/>
+                </a:solidFill>
+              </a:defRPr>
+            </a:pPr>
+            <a:r>
+              <a:rPr lang="en-GB" dirty="0"/>
+              <a:t>[DRAFT]</a:t>
+            </a:r>
+            <a:endParaRPr dirty="0"/>
           </a:p>
           <a:p>
             <a:pPr>
@@ -3165,6 +3183,7 @@
               </a:defRPr>
             </a:pPr>
             <a:r>
+              <a:rPr dirty="0"/>
               <a:t>Implications for the Cali Fund and DSI Benefit-Sharing</a:t>
             </a:r>
           </a:p>
@@ -3180,7 +3199,28 @@
               </a:defRPr>
             </a:pPr>
             <a:r>
-              <a:t>13 October 2026</a:t>
+              <a:rPr lang="en-GB" dirty="0"/>
+              <a:t>Jasmine Kindness, </a:t>
+            </a:r>
+            <a:r>
+              <a:rPr lang="en-GB" dirty="0" err="1"/>
+              <a:t>TierraViva</a:t>
+            </a:r>
+            <a:r>
+              <a:rPr lang="en-GB" dirty="0"/>
+              <a:t> AI, </a:t>
+            </a:r>
+            <a:r>
+              <a:rPr dirty="0"/>
+              <a:t>1</a:t>
+            </a:r>
+            <a:r>
+              <a:rPr lang="en-GB" dirty="0"/>
+              <a:t>6</a:t>
+            </a:r>
+            <a:r>
+              <a:rPr dirty="0"/>
+              <a:t> October 2026</a:t>
             </a:r>
           </a:p>
         </p:txBody>
@@ -3194,7 +3234,7 @@
 </file>
 
 <file path=ppt/slides/slide10.xml><?xml version="1.0" encoding="utf-8"?>
-<p:sld xmlns:a="http://schemas.openxmlformats.org/drawingml/2006/main" xmlns:p="http://schemas.openxmlformats.org/presentationml/2006/main" xmlns:r="http://schemas.openxmlformats.org/officeDocument/2006/relationships">
+<p:sld xmlns:a="http://schemas.openxmlformats.org/drawingml/2006/main" xmlns:r="http://schemas.openxmlformats.org/officeDocument/2006/relationships" xmlns:p="http://schemas.openxmlformats.org/presentationml/2006/main">
   <p:cSld>
     <p:spTree>
       <p:nvGrpSpPr>
@@ -3202,7 +3242,14 @@
         <p:cNvGrpSpPr/>
         <p:nvPr/>
       </p:nvGrpSpPr>
-      <p:grpSpPr/>
+      <p:grpSpPr>
+        <a:xfrm>
+          <a:off x="0" y="0"/>
+          <a:ext cx="0" cy="0"/>
+          <a:chOff x="0" y="0"/>
+          <a:chExt cx="0" cy="0"/>
+        </a:xfrm>
+      </p:grpSpPr>
       <p:sp>
         <p:nvSpPr>
           <p:cNvPr id="2" name="TextBox 1"/>
@@ -3293,6 +3340,7 @@
           <a:lstStyle/>
           <a:p>
             <a:pPr algn="ctr"/>
+            <a:endParaRPr/>
           </a:p>
         </p:txBody>
       </p:sp>
@@ -3328,8 +3376,8 @@
         </p:nvSpPr>
         <p:spPr>
           <a:xfrm>
-            <a:off x="731520" y="6400800"/>
-            <a:ext cx="10515600" cy="365760"/>
+            <a:off x="2149503" y="6061353"/>
+            <a:ext cx="6700873" cy="430887"/>
           </a:xfrm>
           <a:prstGeom prst="rect">
             <a:avLst/>
@@ -3350,7 +3398,26 @@
               </a:defRPr>
             </a:pPr>
             <a:r>
-              <a:t>Colour scale is logarithmic and identical on both maps: dark blue indicates the fewest records (around 2), white indicates approximately 4,000 records (the median country), and dark red indicates the most records (over 4 million). Using the same scale on both maps allows direct visual comparison: a country that appears lighter on the post-2023 map has fewer recent records than its all-time total.</a:t>
+              <a:rPr dirty="0" err="1"/>
+              <a:t>Colour</a:t>
+            </a:r>
+            <a:r>
+              <a:rPr dirty="0"/>
+              <a:t> scale is logarithmic: dark blue indicates the fewest records (around 2), white indicates approximately 4,000 </a:t>
+            </a:r>
+            <a:endParaRPr lang="en-GB" dirty="0"/>
+          </a:p>
+          <a:p>
+            <a:pPr>
+              <a:defRPr sz="1100" i="1">
+                <a:solidFill>
+                  <a:srgbClr val="999999"/>
+                </a:solidFill>
+              </a:defRPr>
+            </a:pPr>
+            <a:r>
+              <a:rPr dirty="0"/>
+              <a:t>records (the median country), and dark red indicates the most records (over 4 million).</a:t>
             </a:r>
           </a:p>
         </p:txBody>
@@ -3364,7 +3431,7 @@
 </file>
 
 <file path=ppt/slides/slide11.xml><?xml version="1.0" encoding="utf-8"?>
-<p:sld xmlns:a="http://schemas.openxmlformats.org/drawingml/2006/main" xmlns:p="http://schemas.openxmlformats.org/presentationml/2006/main" xmlns:r="http://schemas.openxmlformats.org/officeDocument/2006/relationships">
+<p:sld xmlns:a="http://schemas.openxmlformats.org/drawingml/2006/main" xmlns:r="http://schemas.openxmlformats.org/officeDocument/2006/relationships" xmlns:p="http://schemas.openxmlformats.org/presentationml/2006/main">
   <p:cSld>
     <p:spTree>
       <p:nvGrpSpPr>
@@ -3372,7 +3439,14 @@
         <p:cNvGrpSpPr/>
         <p:nvPr/>
       </p:nvGrpSpPr>
-      <p:grpSpPr/>
+      <p:grpSpPr>
+        <a:xfrm>
+          <a:off x="0" y="0"/>
+          <a:ext cx="0" cy="0"/>
+          <a:chOff x="0" y="0"/>
+          <a:chExt cx="0" cy="0"/>
+        </a:xfrm>
+      </p:grpSpPr>
       <p:sp>
         <p:nvSpPr>
           <p:cNvPr id="2" name="TextBox 1"/>
@@ -3463,6 +3537,7 @@
           <a:lstStyle/>
           <a:p>
             <a:pPr algn="ctr"/>
+            <a:endParaRPr/>
           </a:p>
         </p:txBody>
       </p:sp>
@@ -3498,8 +3573,8 @@
         </p:nvSpPr>
         <p:spPr>
           <a:xfrm>
-            <a:off x="731520" y="6400800"/>
-            <a:ext cx="10515600" cy="365760"/>
+            <a:off x="3103659" y="6088390"/>
+            <a:ext cx="5109091" cy="261610"/>
           </a:xfrm>
           <a:prstGeom prst="rect">
             <a:avLst/>
@@ -3520,8 +3595,30 @@
               </a:defRPr>
             </a:pPr>
             <a:r>
-              <a:t>Same colour scale as the all-time map above, allowing direct comparison. Countries that appear lighter on this map have fewer recent records than their all-time total. The dominance of the United Kingdom is greatly reduced because COVID-19 surveillance records were deposited primarily in 2021 to 2023. China and the United States remain dominant, while emerging activity is visible in Brazil, India, and several African countries.</a:t>
-            </a:r>
+              <a:rPr dirty="0"/>
+              <a:t>Same</a:t>
+            </a:r>
+            <a:r>
+              <a:rPr lang="en-GB" dirty="0"/>
+              <a:t> logarithmic </a:t>
+            </a:r>
+            <a:r>
+              <a:rPr dirty="0"/>
+              <a:t> </a:t>
+            </a:r>
+            <a:r>
+              <a:rPr dirty="0" err="1"/>
+              <a:t>colour</a:t>
+            </a:r>
+            <a:r>
+              <a:rPr dirty="0"/>
+              <a:t> scale as the all-time map above, allowing direct</a:t>
+            </a:r>
+            <a:r>
+              <a:rPr lang="en-GB" dirty="0"/>
+              <a:t> comparison. </a:t>
+            </a:r>
+            <a:endParaRPr dirty="0"/>
           </a:p>
         </p:txBody>
       </p:sp>
@@ -3534,7 +3631,7 @@
 </file>
 
 <file path=ppt/slides/slide12.xml><?xml version="1.0" encoding="utf-8"?>
-<p:sld xmlns:a="http://schemas.openxmlformats.org/drawingml/2006/main" xmlns:p="http://schemas.openxmlformats.org/presentationml/2006/main" xmlns:r="http://schemas.openxmlformats.org/officeDocument/2006/relationships">
+<p:sld xmlns:a="http://schemas.openxmlformats.org/drawingml/2006/main" xmlns:r="http://schemas.openxmlformats.org/officeDocument/2006/relationships" xmlns:p="http://schemas.openxmlformats.org/presentationml/2006/main">
   <p:cSld>
     <p:spTree>
       <p:nvGrpSpPr>
@@ -3542,7 +3639,14 @@
         <p:cNvGrpSpPr/>
         <p:nvPr/>
       </p:nvGrpSpPr>
-      <p:grpSpPr/>
+      <p:grpSpPr>
+        <a:xfrm>
+          <a:off x="0" y="0"/>
+          <a:ext cx="0" cy="0"/>
+          <a:chOff x="0" y="0"/>
+          <a:chExt cx="0" cy="0"/>
+        </a:xfrm>
+      </p:grpSpPr>
       <p:sp>
         <p:nvSpPr>
           <p:cNvPr id="2" name="TextBox 1"/>
@@ -3633,6 +3737,7 @@
           <a:lstStyle/>
           <a:p>
             <a:pPr algn="ctr"/>
+            <a:endParaRPr/>
           </a:p>
         </p:txBody>
       </p:sp>
@@ -3655,10 +3760,34 @@
                 <a:tableStyleId>{5C22544A-7EE6-4342-B048-85BDC9FD1C3A}</a:tableStyleId>
               </a:tblPr>
               <a:tblGrid>
-                <a:gridCol w="1485900"/>
-                <a:gridCol w="1485900"/>
-                <a:gridCol w="1485900"/>
-                <a:gridCol w="1485900"/>
+                <a:gridCol w="1485900">
+                  <a:extLst>
+                    <a:ext uri="{9D8B030D-6E8A-4147-A177-3AD203B41FA5}">
+                      <a16:colId xmlns:a16="http://schemas.microsoft.com/office/drawing/2014/main" val="20000"/>
+                    </a:ext>
+                  </a:extLst>
+                </a:gridCol>
+                <a:gridCol w="1485900">
+                  <a:extLst>
+                    <a:ext uri="{9D8B030D-6E8A-4147-A177-3AD203B41FA5}">
+                      <a16:colId xmlns:a16="http://schemas.microsoft.com/office/drawing/2014/main" val="20001"/>
+                    </a:ext>
+                  </a:extLst>
+                </a:gridCol>
+                <a:gridCol w="1485900">
+                  <a:extLst>
+                    <a:ext uri="{9D8B030D-6E8A-4147-A177-3AD203B41FA5}">
+                      <a16:colId xmlns:a16="http://schemas.microsoft.com/office/drawing/2014/main" val="20002"/>
+                    </a:ext>
+                  </a:extLst>
+                </a:gridCol>
+                <a:gridCol w="1485900">
+                  <a:extLst>
+                    <a:ext uri="{9D8B030D-6E8A-4147-A177-3AD203B41FA5}">
+                      <a16:colId xmlns:a16="http://schemas.microsoft.com/office/drawing/2014/main" val="20003"/>
+                    </a:ext>
+                  </a:extLst>
+                </a:gridCol>
               </a:tblGrid>
               <a:tr h="320040">
                 <a:tc>
@@ -3753,6 +3882,11 @@
                     </a:solidFill>
                   </a:tcPr>
                 </a:tc>
+                <a:extLst>
+                  <a:ext uri="{0D108BD9-81ED-4DB2-BD59-A6C34878D82A}">
+                    <a16:rowId xmlns:a16="http://schemas.microsoft.com/office/drawing/2014/main" val="10000"/>
+                  </a:ext>
+                </a:extLst>
               </a:tr>
               <a:tr h="320040">
                 <a:tc>
@@ -3831,6 +3965,11 @@
                   </a:txBody>
                   <a:tcPr/>
                 </a:tc>
+                <a:extLst>
+                  <a:ext uri="{0D108BD9-81ED-4DB2-BD59-A6C34878D82A}">
+                    <a16:rowId xmlns:a16="http://schemas.microsoft.com/office/drawing/2014/main" val="10001"/>
+                  </a:ext>
+                </a:extLst>
               </a:tr>
               <a:tr h="320040">
                 <a:tc>
@@ -3915,7 +4054,7 @@
                         </a:defRPr>
                       </a:pPr>
                       <a:r>
-                        <a:t>69.9%</a:t>
+                        <a:t>70.0%</a:t>
                       </a:r>
                     </a:p>
                   </a:txBody>
@@ -3925,6 +4064,11 @@
                     </a:solidFill>
                   </a:tcPr>
                 </a:tc>
+                <a:extLst>
+                  <a:ext uri="{0D108BD9-81ED-4DB2-BD59-A6C34878D82A}">
+                    <a16:rowId xmlns:a16="http://schemas.microsoft.com/office/drawing/2014/main" val="10002"/>
+                  </a:ext>
+                </a:extLst>
               </a:tr>
               <a:tr h="320040">
                 <a:tc>
@@ -4003,6 +4147,11 @@
                   </a:txBody>
                   <a:tcPr/>
                 </a:tc>
+                <a:extLst>
+                  <a:ext uri="{0D108BD9-81ED-4DB2-BD59-A6C34878D82A}">
+                    <a16:rowId xmlns:a16="http://schemas.microsoft.com/office/drawing/2014/main" val="10003"/>
+                  </a:ext>
+                </a:extLst>
               </a:tr>
               <a:tr h="320040">
                 <a:tc>
@@ -4097,6 +4246,11 @@
                     </a:solidFill>
                   </a:tcPr>
                 </a:tc>
+                <a:extLst>
+                  <a:ext uri="{0D108BD9-81ED-4DB2-BD59-A6C34878D82A}">
+                    <a16:rowId xmlns:a16="http://schemas.microsoft.com/office/drawing/2014/main" val="10004"/>
+                  </a:ext>
+                </a:extLst>
               </a:tr>
               <a:tr h="320040">
                 <a:tc>
@@ -4169,12 +4323,17 @@
                         </a:defRPr>
                       </a:pPr>
                       <a:r>
-                        <a:t>50.9%</a:t>
+                        <a:t>51.0%</a:t>
                       </a:r>
                     </a:p>
                   </a:txBody>
                   <a:tcPr/>
                 </a:tc>
+                <a:extLst>
+                  <a:ext uri="{0D108BD9-81ED-4DB2-BD59-A6C34878D82A}">
+                    <a16:rowId xmlns:a16="http://schemas.microsoft.com/office/drawing/2014/main" val="10005"/>
+                  </a:ext>
+                </a:extLst>
               </a:tr>
             </a:tbl>
           </a:graphicData>
@@ -4216,7 +4375,8 @@
               </a:defRPr>
             </a:pPr>
             <a:r>
-              <a:t>Overall, developed countries hold 70.4 per cent of all country-attributed records and developing countries hold 29.5 per cent.</a:t>
+              <a:rPr dirty="0"/>
+              <a:t>Overall, developed countries hold 70.5 per cent of all country-attributed records and developing countries hold 29.5 per cent.</a:t>
             </a:r>
           </a:p>
           <a:p>
@@ -4234,7 +4394,8 @@
               </a:defRPr>
             </a:pPr>
             <a:r>
-              <a:t>The developed-country share fell from 74.2 per cent in 2018 to 50.9 per cent in the first ten months of 2026. This is a genuine shift, but it is not smooth.</a:t>
+              <a:rPr dirty="0"/>
+              <a:t>The developed-country share fell from 74.2 per cent in 2018 to 51.0 per cent in the first ten months of 2026. This is a genuine shift, but it is not smooth.</a:t>
             </a:r>
           </a:p>
           <a:p>
@@ -4252,7 +4413,16 @@
               </a:defRPr>
             </a:pPr>
             <a:r>
-              <a:t>The 2021 surge to 83.3 per cent was caused by COVID-19 genomic surveillance, particularly the COG-UK consortium in the United Kingdom.</a:t>
+              <a:rPr dirty="0"/>
+              <a:t>The 2021 surge to 83.3 per cent was caused </a:t>
+            </a:r>
+            <a:r>
+              <a:rPr lang="en-GB" dirty="0"/>
+              <a:t>in part </a:t>
+            </a:r>
+            <a:r>
+              <a:rPr dirty="0"/>
+              <a:t>by COVID-19 genomic surveillance, particularly the COG-UK consortium in the United Kingdom.</a:t>
             </a:r>
           </a:p>
           <a:p>
@@ -4270,6 +4440,7 @@
               </a:defRPr>
             </a:pPr>
             <a:r>
+              <a:rPr dirty="0"/>
               <a:t>The convergence visible in 2026 is driven primarily by rapid growth in China and a handful of other upper middle income countries, not by broad-based gains across the developing world.</a:t>
             </a:r>
           </a:p>
@@ -4284,7 +4455,7 @@
 </file>
 
 <file path=ppt/slides/slide13.xml><?xml version="1.0" encoding="utf-8"?>
-<p:sld xmlns:a="http://schemas.openxmlformats.org/drawingml/2006/main" xmlns:p="http://schemas.openxmlformats.org/presentationml/2006/main" xmlns:r="http://schemas.openxmlformats.org/officeDocument/2006/relationships">
+<p:sld xmlns:a="http://schemas.openxmlformats.org/drawingml/2006/main" xmlns:r="http://schemas.openxmlformats.org/officeDocument/2006/relationships" xmlns:p="http://schemas.openxmlformats.org/presentationml/2006/main">
   <p:cSld>
     <p:spTree>
       <p:nvGrpSpPr>
@@ -4292,7 +4463,14 @@
         <p:cNvGrpSpPr/>
         <p:nvPr/>
       </p:nvGrpSpPr>
-      <p:grpSpPr/>
+      <p:grpSpPr>
+        <a:xfrm>
+          <a:off x="0" y="0"/>
+          <a:ext cx="0" cy="0"/>
+          <a:chOff x="0" y="0"/>
+          <a:chExt cx="0" cy="0"/>
+        </a:xfrm>
+      </p:grpSpPr>
       <p:sp>
         <p:nvSpPr>
           <p:cNvPr id="2" name="TextBox 1"/>
@@ -4383,6 +4561,7 @@
           <a:lstStyle/>
           <a:p>
             <a:pPr algn="ctr"/>
+            <a:endParaRPr/>
           </a:p>
         </p:txBody>
       </p:sp>
@@ -4419,7 +4598,7 @@
         <p:spPr>
           <a:xfrm>
             <a:off x="8412480" y="1463040"/>
-            <a:ext cx="3474720" cy="4572000"/>
+            <a:ext cx="3474720" cy="3573286"/>
           </a:xfrm>
           <a:prstGeom prst="rect">
             <a:avLst/>
@@ -4446,6 +4625,7 @@
               </a:defRPr>
             </a:pPr>
             <a:r>
+              <a:rPr dirty="0"/>
               <a:t>What this shows</a:t>
             </a:r>
           </a:p>
@@ -4464,6 +4644,7 @@
               </a:defRPr>
             </a:pPr>
             <a:r>
+              <a:rPr dirty="0"/>
               <a:t>High-income countries (blue) dominate throughout, but their annual output peaked in 2021 during the COVID-19 surge and has since declined sharply.</a:t>
             </a:r>
           </a:p>
@@ -4482,7 +4663,8 @@
               </a:defRPr>
             </a:pPr>
             <a:r>
-              <a:t>Upper middle income countries (green), led by China, have grown steadily and are now approaching parity with high-income countries.</a:t>
+              <a:rPr dirty="0"/>
+              <a:t>Upper middle income countries (green), have grown steadily and are now approaching parity with high-income countries.</a:t>
             </a:r>
           </a:p>
           <a:p>
@@ -4500,25 +4682,8 @@
               </a:defRPr>
             </a:pPr>
             <a:r>
+              <a:rPr dirty="0"/>
               <a:t>Lower middle income and low-income countries (orange and red) remain far behind, together accounting for only 5 per cent of annual records.</a:t>
-            </a:r>
-          </a:p>
-          <a:p>
-            <a:pPr>
-              <a:lnSpc>
-                <a:spcPct val="125000"/>
-              </a:lnSpc>
-              <a:spcBef>
-                <a:spcPts val="600"/>
-              </a:spcBef>
-              <a:defRPr sz="1400" b="1">
-                <a:solidFill>
-                  <a:srgbClr val="E15759"/>
-                </a:solidFill>
-              </a:defRPr>
-            </a:pPr>
-            <a:r>
-              <a:t>The convergence is the clearest structural trend, but it is driven substantially by a single country.</a:t>
             </a:r>
           </a:p>
         </p:txBody>
@@ -4567,7 +4732,7 @@
 </file>
 
 <file path=ppt/slides/slide14.xml><?xml version="1.0" encoding="utf-8"?>
-<p:sld xmlns:a="http://schemas.openxmlformats.org/drawingml/2006/main" xmlns:p="http://schemas.openxmlformats.org/presentationml/2006/main" xmlns:r="http://schemas.openxmlformats.org/officeDocument/2006/relationships">
+<p:sld xmlns:a="http://schemas.openxmlformats.org/drawingml/2006/main" xmlns:r="http://schemas.openxmlformats.org/officeDocument/2006/relationships" xmlns:p="http://schemas.openxmlformats.org/presentationml/2006/main">
   <p:cSld>
     <p:spTree>
       <p:nvGrpSpPr>
@@ -4575,7 +4740,14 @@
         <p:cNvGrpSpPr/>
         <p:nvPr/>
       </p:nvGrpSpPr>
-      <p:grpSpPr/>
+      <p:grpSpPr>
+        <a:xfrm>
+          <a:off x="0" y="0"/>
+          <a:ext cx="0" cy="0"/>
+          <a:chOff x="0" y="0"/>
+          <a:chExt cx="0" cy="0"/>
+        </a:xfrm>
+      </p:grpSpPr>
       <p:sp>
         <p:nvSpPr>
           <p:cNvPr id="2" name="TextBox 1"/>
@@ -4666,6 +4838,7 @@
           <a:lstStyle/>
           <a:p>
             <a:pPr algn="ctr"/>
+            <a:endParaRPr/>
           </a:p>
         </p:txBody>
       </p:sp>
@@ -4702,7 +4875,7 @@
         <p:spPr>
           <a:xfrm>
             <a:off x="8412480" y="1463040"/>
-            <a:ext cx="3474720" cy="4572000"/>
+            <a:ext cx="3474720" cy="4188839"/>
           </a:xfrm>
           <a:prstGeom prst="rect">
             <a:avLst/>
@@ -4729,6 +4902,7 @@
               </a:defRPr>
             </a:pPr>
             <a:r>
+              <a:rPr dirty="0"/>
               <a:t>What this shows</a:t>
             </a:r>
           </a:p>
@@ -4747,6 +4921,7 @@
               </a:defRPr>
             </a:pPr>
             <a:r>
+              <a:rPr dirty="0"/>
               <a:t>With high-income countries removed, the scale differences between the remaining three groups become visible.</a:t>
             </a:r>
           </a:p>
@@ -4765,7 +4940,12 @@
               </a:defRPr>
             </a:pPr>
             <a:r>
-              <a:t>Upper middle income countries (green) dominate this view, reaching over 700,000 records per year by 2025, driven largely by China.</a:t>
+              <a:rPr dirty="0"/>
+              <a:t>Upper middle income countries (green) dominate this view, reaching over 700,000 records per year by 2025</a:t>
+            </a:r>
+            <a:r>
+              <a:rPr lang="en-GB" dirty="0"/>
+              <a:t>.</a:t>
             </a:r>
           </a:p>
           <a:p>
@@ -4783,7 +4963,16 @@
               </a:defRPr>
             </a:pPr>
             <a:r>
-              <a:t>Lower middle income countries (orange) peaked in 2022 at 124,000 records, partly from a single large project, then fell back.</a:t>
+              <a:rPr dirty="0"/>
+              <a:t>Lower middle income countries (orange) peaked in 2022 at 124,000 records</a:t>
+            </a:r>
+            <a:r>
+              <a:rPr lang="en-GB" dirty="0"/>
+              <a:t>, </a:t>
+            </a:r>
+            <a:r>
+              <a:rPr dirty="0"/>
+              <a:t>then fell back.</a:t>
             </a:r>
           </a:p>
           <a:p>
@@ -4801,6 +4990,7 @@
               </a:defRPr>
             </a:pPr>
             <a:r>
+              <a:rPr dirty="0"/>
               <a:t>Low-income countries (red) remain below 25,000 records per year throughout. The gap between upper middle and low income is roughly 30-fold.</a:t>
             </a:r>
           </a:p>
@@ -4850,7 +5040,7 @@
 </file>
 
 <file path=ppt/slides/slide15.xml><?xml version="1.0" encoding="utf-8"?>
-<p:sld xmlns:a="http://schemas.openxmlformats.org/drawingml/2006/main" xmlns:p="http://schemas.openxmlformats.org/presentationml/2006/main" xmlns:r="http://schemas.openxmlformats.org/officeDocument/2006/relationships">
+<p:sld xmlns:a="http://schemas.openxmlformats.org/drawingml/2006/main" xmlns:r="http://schemas.openxmlformats.org/officeDocument/2006/relationships" xmlns:p="http://schemas.openxmlformats.org/presentationml/2006/main">
   <p:cSld>
     <p:spTree>
       <p:nvGrpSpPr>
@@ -4858,7 +5048,14 @@
         <p:cNvGrpSpPr/>
         <p:nvPr/>
       </p:nvGrpSpPr>
-      <p:grpSpPr/>
+      <p:grpSpPr>
+        <a:xfrm>
+          <a:off x="0" y="0"/>
+          <a:ext cx="0" cy="0"/>
+          <a:chOff x="0" y="0"/>
+          <a:chExt cx="0" cy="0"/>
+        </a:xfrm>
+      </p:grpSpPr>
       <p:sp>
         <p:nvSpPr>
           <p:cNvPr id="2" name="TextBox 1"/>
@@ -4949,6 +5146,7 @@
           <a:lstStyle/>
           <a:p>
             <a:pPr algn="ctr"/>
+            <a:endParaRPr/>
           </a:p>
         </p:txBody>
       </p:sp>
@@ -4962,7 +5160,7 @@
         </p:nvGraphicFramePr>
         <p:xfrm>
           <a:off x="731520" y="1554480"/>
-          <a:ext cx="5943600" cy="1600200"/>
+          <a:ext cx="5943600" cy="1935480"/>
         </p:xfrm>
         <a:graphic>
           <a:graphicData uri="http://schemas.openxmlformats.org/drawingml/2006/table">
@@ -4971,10 +5169,34 @@
                 <a:tableStyleId>{5C22544A-7EE6-4342-B048-85BDC9FD1C3A}</a:tableStyleId>
               </a:tblPr>
               <a:tblGrid>
-                <a:gridCol w="1485900"/>
-                <a:gridCol w="1485900"/>
-                <a:gridCol w="1485900"/>
-                <a:gridCol w="1485900"/>
+                <a:gridCol w="1485900">
+                  <a:extLst>
+                    <a:ext uri="{9D8B030D-6E8A-4147-A177-3AD203B41FA5}">
+                      <a16:colId xmlns:a16="http://schemas.microsoft.com/office/drawing/2014/main" val="20000"/>
+                    </a:ext>
+                  </a:extLst>
+                </a:gridCol>
+                <a:gridCol w="1485900">
+                  <a:extLst>
+                    <a:ext uri="{9D8B030D-6E8A-4147-A177-3AD203B41FA5}">
+                      <a16:colId xmlns:a16="http://schemas.microsoft.com/office/drawing/2014/main" val="20001"/>
+                    </a:ext>
+                  </a:extLst>
+                </a:gridCol>
+                <a:gridCol w="1485900">
+                  <a:extLst>
+                    <a:ext uri="{9D8B030D-6E8A-4147-A177-3AD203B41FA5}">
+                      <a16:colId xmlns:a16="http://schemas.microsoft.com/office/drawing/2014/main" val="20002"/>
+                    </a:ext>
+                  </a:extLst>
+                </a:gridCol>
+                <a:gridCol w="1485900">
+                  <a:extLst>
+                    <a:ext uri="{9D8B030D-6E8A-4147-A177-3AD203B41FA5}">
+                      <a16:colId xmlns:a16="http://schemas.microsoft.com/office/drawing/2014/main" val="20003"/>
+                    </a:ext>
+                  </a:extLst>
+                </a:gridCol>
               </a:tblGrid>
               <a:tr h="320040">
                 <a:tc>
@@ -5069,6 +5291,11 @@
                     </a:solidFill>
                   </a:tcPr>
                 </a:tc>
+                <a:extLst>
+                  <a:ext uri="{0D108BD9-81ED-4DB2-BD59-A6C34878D82A}">
+                    <a16:rowId xmlns:a16="http://schemas.microsoft.com/office/drawing/2014/main" val="10000"/>
+                  </a:ext>
+                </a:extLst>
               </a:tr>
               <a:tr h="320040">
                 <a:tc>
@@ -5147,6 +5374,11 @@
                   </a:txBody>
                   <a:tcPr/>
                 </a:tc>
+                <a:extLst>
+                  <a:ext uri="{0D108BD9-81ED-4DB2-BD59-A6C34878D82A}">
+                    <a16:rowId xmlns:a16="http://schemas.microsoft.com/office/drawing/2014/main" val="10001"/>
+                  </a:ext>
+                </a:extLst>
               </a:tr>
               <a:tr h="320040">
                 <a:tc>
@@ -5241,6 +5473,11 @@
                     </a:solidFill>
                   </a:tcPr>
                 </a:tc>
+                <a:extLst>
+                  <a:ext uri="{0D108BD9-81ED-4DB2-BD59-A6C34878D82A}">
+                    <a16:rowId xmlns:a16="http://schemas.microsoft.com/office/drawing/2014/main" val="10002"/>
+                  </a:ext>
+                </a:extLst>
               </a:tr>
               <a:tr h="320040">
                 <a:tc>
@@ -5319,6 +5556,11 @@
                   </a:txBody>
                   <a:tcPr/>
                 </a:tc>
+                <a:extLst>
+                  <a:ext uri="{0D108BD9-81ED-4DB2-BD59-A6C34878D82A}">
+                    <a16:rowId xmlns:a16="http://schemas.microsoft.com/office/drawing/2014/main" val="10003"/>
+                  </a:ext>
+                </a:extLst>
               </a:tr>
               <a:tr h="320040">
                 <a:tc>
@@ -5413,6 +5655,11 @@
                     </a:solidFill>
                   </a:tcPr>
                 </a:tc>
+                <a:extLst>
+                  <a:ext uri="{0D108BD9-81ED-4DB2-BD59-A6C34878D82A}">
+                    <a16:rowId xmlns:a16="http://schemas.microsoft.com/office/drawing/2014/main" val="10004"/>
+                  </a:ext>
+                </a:extLst>
               </a:tr>
             </a:tbl>
           </a:graphicData>
@@ -5427,7 +5674,7 @@
         <p:spPr>
           <a:xfrm>
             <a:off x="7040880" y="1554480"/>
-            <a:ext cx="4846320" cy="4572000"/>
+            <a:ext cx="4846320" cy="3690049"/>
           </a:xfrm>
           <a:prstGeom prst="rect">
             <a:avLst/>
@@ -5454,6 +5701,7 @@
               </a:defRPr>
             </a:pPr>
             <a:r>
+              <a:rPr dirty="0"/>
               <a:t>High-income countries hold nearly three-quarters of all records. Upper middle income countries, led by China, hold just under a quarter. Lower middle income and low-income countries together account for only 5.0 per cent, despite containing 78 countries between them.</a:t>
             </a:r>
           </a:p>
@@ -5472,7 +5720,32 @@
               </a:defRPr>
             </a:pPr>
             <a:r>
-              <a:t>Comparing 2021-2023 with 2024-2026, upper middle income countries grew by 43 per cent on an annualised basis, while high-income countries declined by 55 per cent. This is the strongest evidence of a structural shift, though the decline is partly the natural end of the COVID-19 surge.</a:t>
+              <a:rPr dirty="0"/>
+              <a:t>Comparing 2021-2023 with 2024-2026, upper middle income countries grew by 43 per cent on an </a:t>
+            </a:r>
+            <a:r>
+              <a:rPr dirty="0" err="1"/>
+              <a:t>annualised</a:t>
+            </a:r>
+            <a:r>
+              <a:rPr dirty="0"/>
+              <a:t> basis, while high-income countries declined by 55 per cent. This is the strongest evidence of a structural shift, though the decline </a:t>
+            </a:r>
+            <a:r>
+              <a:rPr lang="en-GB" dirty="0"/>
+              <a:t>may</a:t>
+            </a:r>
+            <a:r>
+              <a:rPr dirty="0"/>
+              <a:t> partly</a:t>
+            </a:r>
+            <a:r>
+              <a:rPr lang="en-GB" dirty="0"/>
+              <a:t> be</a:t>
+            </a:r>
+            <a:r>
+              <a:rPr dirty="0"/>
+              <a:t> the natural end of the COVID-19 surge.</a:t>
             </a:r>
           </a:p>
         </p:txBody>
@@ -5486,7 +5759,7 @@
 </file>
 
 <file path=ppt/slides/slide16.xml><?xml version="1.0" encoding="utf-8"?>
-<p:sld xmlns:a="http://schemas.openxmlformats.org/drawingml/2006/main" xmlns:p="http://schemas.openxmlformats.org/presentationml/2006/main" xmlns:r="http://schemas.openxmlformats.org/officeDocument/2006/relationships">
+<p:sld xmlns:a="http://schemas.openxmlformats.org/drawingml/2006/main" xmlns:r="http://schemas.openxmlformats.org/officeDocument/2006/relationships" xmlns:p="http://schemas.openxmlformats.org/presentationml/2006/main">
   <p:cSld>
     <p:spTree>
       <p:nvGrpSpPr>
@@ -5494,7 +5767,14 @@
         <p:cNvGrpSpPr/>
         <p:nvPr/>
       </p:nvGrpSpPr>
-      <p:grpSpPr/>
+      <p:grpSpPr>
+        <a:xfrm>
+          <a:off x="0" y="0"/>
+          <a:ext cx="0" cy="0"/>
+          <a:chOff x="0" y="0"/>
+          <a:chExt cx="0" cy="0"/>
+        </a:xfrm>
+      </p:grpSpPr>
       <p:sp>
         <p:nvSpPr>
           <p:cNvPr id="2" name="TextBox 1"/>
@@ -5585,6 +5865,7 @@
           <a:lstStyle/>
           <a:p>
             <a:pPr algn="ctr"/>
+            <a:endParaRPr/>
           </a:p>
         </p:txBody>
       </p:sp>
@@ -5607,12 +5888,48 @@
                 <a:tableStyleId>{5C22544A-7EE6-4342-B048-85BDC9FD1C3A}</a:tableStyleId>
               </a:tblPr>
               <a:tblGrid>
-                <a:gridCol w="1097280"/>
-                <a:gridCol w="1828800"/>
-                <a:gridCol w="2011680"/>
-                <a:gridCol w="2011680"/>
-                <a:gridCol w="1645920"/>
-                <a:gridCol w="1920240"/>
+                <a:gridCol w="1097280">
+                  <a:extLst>
+                    <a:ext uri="{9D8B030D-6E8A-4147-A177-3AD203B41FA5}">
+                      <a16:colId xmlns:a16="http://schemas.microsoft.com/office/drawing/2014/main" val="20000"/>
+                    </a:ext>
+                  </a:extLst>
+                </a:gridCol>
+                <a:gridCol w="1828800">
+                  <a:extLst>
+                    <a:ext uri="{9D8B030D-6E8A-4147-A177-3AD203B41FA5}">
+                      <a16:colId xmlns:a16="http://schemas.microsoft.com/office/drawing/2014/main" val="20001"/>
+                    </a:ext>
+                  </a:extLst>
+                </a:gridCol>
+                <a:gridCol w="2011680">
+                  <a:extLst>
+                    <a:ext uri="{9D8B030D-6E8A-4147-A177-3AD203B41FA5}">
+                      <a16:colId xmlns:a16="http://schemas.microsoft.com/office/drawing/2014/main" val="20002"/>
+                    </a:ext>
+                  </a:extLst>
+                </a:gridCol>
+                <a:gridCol w="2011680">
+                  <a:extLst>
+                    <a:ext uri="{9D8B030D-6E8A-4147-A177-3AD203B41FA5}">
+                      <a16:colId xmlns:a16="http://schemas.microsoft.com/office/drawing/2014/main" val="20003"/>
+                    </a:ext>
+                  </a:extLst>
+                </a:gridCol>
+                <a:gridCol w="1645920">
+                  <a:extLst>
+                    <a:ext uri="{9D8B030D-6E8A-4147-A177-3AD203B41FA5}">
+                      <a16:colId xmlns:a16="http://schemas.microsoft.com/office/drawing/2014/main" val="20004"/>
+                    </a:ext>
+                  </a:extLst>
+                </a:gridCol>
+                <a:gridCol w="1920240">
+                  <a:extLst>
+                    <a:ext uri="{9D8B030D-6E8A-4147-A177-3AD203B41FA5}">
+                      <a16:colId xmlns:a16="http://schemas.microsoft.com/office/drawing/2014/main" val="20005"/>
+                    </a:ext>
+                  </a:extLst>
+                </a:gridCol>
               </a:tblGrid>
               <a:tr h="320040">
                 <a:tc>
@@ -5753,6 +6070,11 @@
                     </a:solidFill>
                   </a:tcPr>
                 </a:tc>
+                <a:extLst>
+                  <a:ext uri="{0D108BD9-81ED-4DB2-BD59-A6C34878D82A}">
+                    <a16:rowId xmlns:a16="http://schemas.microsoft.com/office/drawing/2014/main" val="10000"/>
+                  </a:ext>
+                </a:extLst>
               </a:tr>
               <a:tr h="320040">
                 <a:tc>
@@ -5869,6 +6191,11 @@
                   </a:txBody>
                   <a:tcPr/>
                 </a:tc>
+                <a:extLst>
+                  <a:ext uri="{0D108BD9-81ED-4DB2-BD59-A6C34878D82A}">
+                    <a16:rowId xmlns:a16="http://schemas.microsoft.com/office/drawing/2014/main" val="10001"/>
+                  </a:ext>
+                </a:extLst>
               </a:tr>
               <a:tr h="320040">
                 <a:tc>
@@ -6009,6 +6336,11 @@
                     </a:solidFill>
                   </a:tcPr>
                 </a:tc>
+                <a:extLst>
+                  <a:ext uri="{0D108BD9-81ED-4DB2-BD59-A6C34878D82A}">
+                    <a16:rowId xmlns:a16="http://schemas.microsoft.com/office/drawing/2014/main" val="10002"/>
+                  </a:ext>
+                </a:extLst>
               </a:tr>
               <a:tr h="320040">
                 <a:tc>
@@ -6125,6 +6457,11 @@
                   </a:txBody>
                   <a:tcPr/>
                 </a:tc>
+                <a:extLst>
+                  <a:ext uri="{0D108BD9-81ED-4DB2-BD59-A6C34878D82A}">
+                    <a16:rowId xmlns:a16="http://schemas.microsoft.com/office/drawing/2014/main" val="10003"/>
+                  </a:ext>
+                </a:extLst>
               </a:tr>
               <a:tr h="320040">
                 <a:tc>
@@ -6265,6 +6602,11 @@
                     </a:solidFill>
                   </a:tcPr>
                 </a:tc>
+                <a:extLst>
+                  <a:ext uri="{0D108BD9-81ED-4DB2-BD59-A6C34878D82A}">
+                    <a16:rowId xmlns:a16="http://schemas.microsoft.com/office/drawing/2014/main" val="10004"/>
+                  </a:ext>
+                </a:extLst>
               </a:tr>
               <a:tr h="320040">
                 <a:tc>
@@ -6381,6 +6723,11 @@
                   </a:txBody>
                   <a:tcPr/>
                 </a:tc>
+                <a:extLst>
+                  <a:ext uri="{0D108BD9-81ED-4DB2-BD59-A6C34878D82A}">
+                    <a16:rowId xmlns:a16="http://schemas.microsoft.com/office/drawing/2014/main" val="10005"/>
+                  </a:ext>
+                </a:extLst>
               </a:tr>
               <a:tr h="320040">
                 <a:tc>
@@ -6521,6 +6868,11 @@
                     </a:solidFill>
                   </a:tcPr>
                 </a:tc>
+                <a:extLst>
+                  <a:ext uri="{0D108BD9-81ED-4DB2-BD59-A6C34878D82A}">
+                    <a16:rowId xmlns:a16="http://schemas.microsoft.com/office/drawing/2014/main" val="10006"/>
+                  </a:ext>
+                </a:extLst>
               </a:tr>
               <a:tr h="320040">
                 <a:tc>
@@ -6637,6 +6989,11 @@
                   </a:txBody>
                   <a:tcPr/>
                 </a:tc>
+                <a:extLst>
+                  <a:ext uri="{0D108BD9-81ED-4DB2-BD59-A6C34878D82A}">
+                    <a16:rowId xmlns:a16="http://schemas.microsoft.com/office/drawing/2014/main" val="10007"/>
+                  </a:ext>
+                </a:extLst>
               </a:tr>
               <a:tr h="320040">
                 <a:tc>
@@ -6777,6 +7134,11 @@
                     </a:solidFill>
                   </a:tcPr>
                 </a:tc>
+                <a:extLst>
+                  <a:ext uri="{0D108BD9-81ED-4DB2-BD59-A6C34878D82A}">
+                    <a16:rowId xmlns:a16="http://schemas.microsoft.com/office/drawing/2014/main" val="10008"/>
+                  </a:ext>
+                </a:extLst>
               </a:tr>
               <a:tr h="320040">
                 <a:tc>
@@ -6893,6 +7255,11 @@
                   </a:txBody>
                   <a:tcPr/>
                 </a:tc>
+                <a:extLst>
+                  <a:ext uri="{0D108BD9-81ED-4DB2-BD59-A6C34878D82A}">
+                    <a16:rowId xmlns:a16="http://schemas.microsoft.com/office/drawing/2014/main" val="10009"/>
+                  </a:ext>
+                </a:extLst>
               </a:tr>
             </a:tbl>
           </a:graphicData>
@@ -6907,7 +7274,7 @@
         <p:spPr>
           <a:xfrm>
             <a:off x="731520" y="4846320"/>
-            <a:ext cx="10515600" cy="1645920"/>
+            <a:ext cx="10515600" cy="1671098"/>
           </a:xfrm>
           <a:prstGeom prst="rect">
             <a:avLst/>
@@ -6934,25 +7301,8 @@
               </a:defRPr>
             </a:pPr>
             <a:r>
+              <a:rPr dirty="0"/>
               <a:t>The high-income share has fallen from 76.3 per cent in 2018 to 54.5 per cent in 2026, while upper middle income countries have risen from 19.4 per cent to 41.7 per cent. In 2026, for the first time, upper middle income countries are generating nearly as many records as high-income countries.</a:t>
-            </a:r>
-          </a:p>
-          <a:p>
-            <a:pPr>
-              <a:lnSpc>
-                <a:spcPct val="130000"/>
-              </a:lnSpc>
-              <a:spcBef>
-                <a:spcPts val="800"/>
-              </a:spcBef>
-              <a:defRPr sz="1500" b="0">
-                <a:solidFill>
-                  <a:srgbClr val="1A1A1A"/>
-                </a:solidFill>
-              </a:defRPr>
-            </a:pPr>
-            <a:r>
-              <a:t>The 2021 spike to 84.7 per cent for high-income countries was driven by COVID-19 surveillance, particularly the COG-UK consortium. The subsequent decline reflects both the end of pandemic surveillance and continued growth in China and other upper middle income countries.</a:t>
             </a:r>
           </a:p>
           <a:p>
@@ -6970,6 +7320,7 @@
               </a:defRPr>
             </a:pPr>
             <a:r>
+              <a:rPr dirty="0"/>
               <a:t>Lower middle income and low-income countries have remained below 6 per cent combined throughout the entire period, showing almost no structural change in their share despite year-to-year fluctuations.</a:t>
             </a:r>
           </a:p>
@@ -6983,7 +7334,7 @@
         </p:nvSpPr>
         <p:spPr>
           <a:xfrm>
-            <a:off x="731520" y="6400800"/>
+            <a:off x="731520" y="6492240"/>
             <a:ext cx="10515600" cy="365760"/>
           </a:xfrm>
           <a:prstGeom prst="rect">
@@ -7005,6 +7356,7 @@
               </a:defRPr>
             </a:pPr>
             <a:r>
+              <a:rPr dirty="0"/>
               <a:t>Source: ENA Portal API, 13 October 2026. Percentages exclude records with unknown income classification. *2026 covers January to October only.</a:t>
             </a:r>
           </a:p>
@@ -7019,7 +7371,7 @@
 </file>
 
 <file path=ppt/slides/slide17.xml><?xml version="1.0" encoding="utf-8"?>
-<p:sld xmlns:a="http://schemas.openxmlformats.org/drawingml/2006/main" xmlns:p="http://schemas.openxmlformats.org/presentationml/2006/main" xmlns:r="http://schemas.openxmlformats.org/officeDocument/2006/relationships">
+<p:sld xmlns:a="http://schemas.openxmlformats.org/drawingml/2006/main" xmlns:r="http://schemas.openxmlformats.org/officeDocument/2006/relationships" xmlns:p="http://schemas.openxmlformats.org/presentationml/2006/main">
   <p:cSld>
     <p:spTree>
       <p:nvGrpSpPr>
@@ -7027,7 +7379,14 @@
         <p:cNvGrpSpPr/>
         <p:nvPr/>
       </p:nvGrpSpPr>
-      <p:grpSpPr/>
+      <p:grpSpPr>
+        <a:xfrm>
+          <a:off x="0" y="0"/>
+          <a:ext cx="0" cy="0"/>
+          <a:chOff x="0" y="0"/>
+          <a:chExt cx="0" cy="0"/>
+        </a:xfrm>
+      </p:grpSpPr>
       <p:sp>
         <p:nvSpPr>
           <p:cNvPr id="2" name="TextBox 1"/>
@@ -7118,6 +7477,7 @@
           <a:lstStyle/>
           <a:p>
             <a:pPr algn="ctr"/>
+            <a:endParaRPr/>
           </a:p>
         </p:txBody>
       </p:sp>
@@ -7140,10 +7500,34 @@
                 <a:tableStyleId>{5C22544A-7EE6-4342-B048-85BDC9FD1C3A}</a:tableStyleId>
               </a:tblPr>
               <a:tblGrid>
-                <a:gridCol w="1257300"/>
-                <a:gridCol w="1257300"/>
-                <a:gridCol w="1257300"/>
-                <a:gridCol w="1257300"/>
+                <a:gridCol w="1257300">
+                  <a:extLst>
+                    <a:ext uri="{9D8B030D-6E8A-4147-A177-3AD203B41FA5}">
+                      <a16:colId xmlns:a16="http://schemas.microsoft.com/office/drawing/2014/main" val="20000"/>
+                    </a:ext>
+                  </a:extLst>
+                </a:gridCol>
+                <a:gridCol w="1257300">
+                  <a:extLst>
+                    <a:ext uri="{9D8B030D-6E8A-4147-A177-3AD203B41FA5}">
+                      <a16:colId xmlns:a16="http://schemas.microsoft.com/office/drawing/2014/main" val="20001"/>
+                    </a:ext>
+                  </a:extLst>
+                </a:gridCol>
+                <a:gridCol w="1257300">
+                  <a:extLst>
+                    <a:ext uri="{9D8B030D-6E8A-4147-A177-3AD203B41FA5}">
+                      <a16:colId xmlns:a16="http://schemas.microsoft.com/office/drawing/2014/main" val="20002"/>
+                    </a:ext>
+                  </a:extLst>
+                </a:gridCol>
+                <a:gridCol w="1257300">
+                  <a:extLst>
+                    <a:ext uri="{9D8B030D-6E8A-4147-A177-3AD203B41FA5}">
+                      <a16:colId xmlns:a16="http://schemas.microsoft.com/office/drawing/2014/main" val="20003"/>
+                    </a:ext>
+                  </a:extLst>
+                </a:gridCol>
               </a:tblGrid>
               <a:tr h="320040">
                 <a:tc>
@@ -7238,6 +7622,11 @@
                     </a:solidFill>
                   </a:tcPr>
                 </a:tc>
+                <a:extLst>
+                  <a:ext uri="{0D108BD9-81ED-4DB2-BD59-A6C34878D82A}">
+                    <a16:rowId xmlns:a16="http://schemas.microsoft.com/office/drawing/2014/main" val="10000"/>
+                  </a:ext>
+                </a:extLst>
               </a:tr>
               <a:tr h="320040">
                 <a:tc>
@@ -7316,6 +7705,11 @@
                   </a:txBody>
                   <a:tcPr/>
                 </a:tc>
+                <a:extLst>
+                  <a:ext uri="{0D108BD9-81ED-4DB2-BD59-A6C34878D82A}">
+                    <a16:rowId xmlns:a16="http://schemas.microsoft.com/office/drawing/2014/main" val="10001"/>
+                  </a:ext>
+                </a:extLst>
               </a:tr>
               <a:tr h="320040">
                 <a:tc>
@@ -7410,6 +7804,11 @@
                     </a:solidFill>
                   </a:tcPr>
                 </a:tc>
+                <a:extLst>
+                  <a:ext uri="{0D108BD9-81ED-4DB2-BD59-A6C34878D82A}">
+                    <a16:rowId xmlns:a16="http://schemas.microsoft.com/office/drawing/2014/main" val="10002"/>
+                  </a:ext>
+                </a:extLst>
               </a:tr>
               <a:tr h="320040">
                 <a:tc>
@@ -7488,6 +7887,11 @@
                   </a:txBody>
                   <a:tcPr/>
                 </a:tc>
+                <a:extLst>
+                  <a:ext uri="{0D108BD9-81ED-4DB2-BD59-A6C34878D82A}">
+                    <a16:rowId xmlns:a16="http://schemas.microsoft.com/office/drawing/2014/main" val="10003"/>
+                  </a:ext>
+                </a:extLst>
               </a:tr>
             </a:tbl>
           </a:graphicData>
@@ -7502,7 +7906,7 @@
         <p:spPr>
           <a:xfrm>
             <a:off x="6217920" y="1554480"/>
-            <a:ext cx="5486400" cy="2286000"/>
+            <a:ext cx="5486400" cy="784830"/>
           </a:xfrm>
           <a:prstGeom prst="rect">
             <a:avLst/>
@@ -7516,18 +7920,6 @@
           <a:lstStyle/>
           <a:p>
             <a:pPr>
-              <a:defRPr sz="1800" b="1">
-                <a:solidFill>
-                  <a:srgbClr val="1F4E79"/>
-                </a:solidFill>
-              </a:defRPr>
-            </a:pPr>
-            <a:r>
-              <a:t>The Canada comparison</a:t>
-            </a:r>
-          </a:p>
-          <a:p>
-            <a:pPr>
               <a:spcBef>
                 <a:spcPts val="1200"/>
               </a:spcBef>
@@ -7538,6 +7930,7 @@
               </a:defRPr>
             </a:pPr>
             <a:r>
+              <a:rPr dirty="0"/>
               <a:t>47 LDCs combined: 527,519 records</a:t>
             </a:r>
           </a:p>
@@ -7553,6 +7946,7 @@
               </a:defRPr>
             </a:pPr>
             <a:r>
+              <a:rPr dirty="0"/>
               <a:t>Canada alone: 530,725 records</a:t>
             </a:r>
           </a:p>
@@ -7567,7 +7961,7 @@
         <p:spPr>
           <a:xfrm>
             <a:off x="731520" y="4114800"/>
-            <a:ext cx="10515600" cy="2286000"/>
+            <a:ext cx="10515600" cy="1026756"/>
           </a:xfrm>
           <a:prstGeom prst="rect">
             <a:avLst/>
@@ -7594,25 +7988,8 @@
               </a:defRPr>
             </a:pPr>
             <a:r>
+              <a:rPr dirty="0"/>
               <a:t>LDC records are highly volatile. A 407 per cent surge in 2022 was driven by a few large projects, not broad-based capacity growth. The following year, LDC records fell by 71 per cent. This illustrates how dependent these counts are on individual projects and funding cycles, rather than durable institutional capacity.</a:t>
-            </a:r>
-          </a:p>
-          <a:p>
-            <a:pPr>
-              <a:lnSpc>
-                <a:spcPct val="130000"/>
-              </a:lnSpc>
-              <a:spcBef>
-                <a:spcPts val="800"/>
-              </a:spcBef>
-              <a:defRPr sz="1600" b="0">
-                <a:solidFill>
-                  <a:srgbClr val="1A1A1A"/>
-                </a:solidFill>
-              </a:defRPr>
-            </a:pPr>
-            <a:r>
-              <a:t>The thin margin between 47 LDCs and a single G7 economy (approximately 3,200 records) could reverse with one large deposition. This fragility is itself a finding relevant to the Cali Fund equity objectives.</a:t>
             </a:r>
           </a:p>
         </p:txBody>
@@ -7626,7 +8003,7 @@
 </file>
 
 <file path=ppt/slides/slide18.xml><?xml version="1.0" encoding="utf-8"?>
-<p:sld xmlns:a="http://schemas.openxmlformats.org/drawingml/2006/main" xmlns:p="http://schemas.openxmlformats.org/presentationml/2006/main" xmlns:r="http://schemas.openxmlformats.org/officeDocument/2006/relationships">
+<p:sld xmlns:a="http://schemas.openxmlformats.org/drawingml/2006/main" xmlns:r="http://schemas.openxmlformats.org/officeDocument/2006/relationships" xmlns:p="http://schemas.openxmlformats.org/presentationml/2006/main">
   <p:cSld>
     <p:spTree>
       <p:nvGrpSpPr>
@@ -7634,7 +8011,14 @@
         <p:cNvGrpSpPr/>
         <p:nvPr/>
       </p:nvGrpSpPr>
-      <p:grpSpPr/>
+      <p:grpSpPr>
+        <a:xfrm>
+          <a:off x="0" y="0"/>
+          <a:ext cx="0" cy="0"/>
+          <a:chOff x="0" y="0"/>
+          <a:chExt cx="0" cy="0"/>
+        </a:xfrm>
+      </p:grpSpPr>
       <p:sp>
         <p:nvSpPr>
           <p:cNvPr id="2" name="TextBox 1"/>
@@ -7725,6 +8109,7 @@
           <a:lstStyle/>
           <a:p>
             <a:pPr algn="ctr"/>
+            <a:endParaRPr/>
           </a:p>
         </p:txBody>
       </p:sp>
@@ -7747,10 +8132,34 @@
                 <a:tableStyleId>{5C22544A-7EE6-4342-B048-85BDC9FD1C3A}</a:tableStyleId>
               </a:tblPr>
               <a:tblGrid>
-                <a:gridCol w="1371600"/>
-                <a:gridCol w="1371600"/>
-                <a:gridCol w="1371600"/>
-                <a:gridCol w="1371600"/>
+                <a:gridCol w="1371600">
+                  <a:extLst>
+                    <a:ext uri="{9D8B030D-6E8A-4147-A177-3AD203B41FA5}">
+                      <a16:colId xmlns:a16="http://schemas.microsoft.com/office/drawing/2014/main" val="20000"/>
+                    </a:ext>
+                  </a:extLst>
+                </a:gridCol>
+                <a:gridCol w="1371600">
+                  <a:extLst>
+                    <a:ext uri="{9D8B030D-6E8A-4147-A177-3AD203B41FA5}">
+                      <a16:colId xmlns:a16="http://schemas.microsoft.com/office/drawing/2014/main" val="20001"/>
+                    </a:ext>
+                  </a:extLst>
+                </a:gridCol>
+                <a:gridCol w="1371600">
+                  <a:extLst>
+                    <a:ext uri="{9D8B030D-6E8A-4147-A177-3AD203B41FA5}">
+                      <a16:colId xmlns:a16="http://schemas.microsoft.com/office/drawing/2014/main" val="20002"/>
+                    </a:ext>
+                  </a:extLst>
+                </a:gridCol>
+                <a:gridCol w="1371600">
+                  <a:extLst>
+                    <a:ext uri="{9D8B030D-6E8A-4147-A177-3AD203B41FA5}">
+                      <a16:colId xmlns:a16="http://schemas.microsoft.com/office/drawing/2014/main" val="20003"/>
+                    </a:ext>
+                  </a:extLst>
+                </a:gridCol>
               </a:tblGrid>
               <a:tr h="320040">
                 <a:tc>
@@ -7845,6 +8254,11 @@
                     </a:solidFill>
                   </a:tcPr>
                 </a:tc>
+                <a:extLst>
+                  <a:ext uri="{0D108BD9-81ED-4DB2-BD59-A6C34878D82A}">
+                    <a16:rowId xmlns:a16="http://schemas.microsoft.com/office/drawing/2014/main" val="10000"/>
+                  </a:ext>
+                </a:extLst>
               </a:tr>
               <a:tr h="320040">
                 <a:tc>
@@ -7923,6 +8337,11 @@
                   </a:txBody>
                   <a:tcPr/>
                 </a:tc>
+                <a:extLst>
+                  <a:ext uri="{0D108BD9-81ED-4DB2-BD59-A6C34878D82A}">
+                    <a16:rowId xmlns:a16="http://schemas.microsoft.com/office/drawing/2014/main" val="10001"/>
+                  </a:ext>
+                </a:extLst>
               </a:tr>
               <a:tr h="320040">
                 <a:tc>
@@ -8017,6 +8436,11 @@
                     </a:solidFill>
                   </a:tcPr>
                 </a:tc>
+                <a:extLst>
+                  <a:ext uri="{0D108BD9-81ED-4DB2-BD59-A6C34878D82A}">
+                    <a16:rowId xmlns:a16="http://schemas.microsoft.com/office/drawing/2014/main" val="10002"/>
+                  </a:ext>
+                </a:extLst>
               </a:tr>
               <a:tr h="320040">
                 <a:tc>
@@ -8095,6 +8519,11 @@
                   </a:txBody>
                   <a:tcPr/>
                 </a:tc>
+                <a:extLst>
+                  <a:ext uri="{0D108BD9-81ED-4DB2-BD59-A6C34878D82A}">
+                    <a16:rowId xmlns:a16="http://schemas.microsoft.com/office/drawing/2014/main" val="10003"/>
+                  </a:ext>
+                </a:extLst>
               </a:tr>
               <a:tr h="320040">
                 <a:tc>
@@ -8189,6 +8618,11 @@
                     </a:solidFill>
                   </a:tcPr>
                 </a:tc>
+                <a:extLst>
+                  <a:ext uri="{0D108BD9-81ED-4DB2-BD59-A6C34878D82A}">
+                    <a16:rowId xmlns:a16="http://schemas.microsoft.com/office/drawing/2014/main" val="10004"/>
+                  </a:ext>
+                </a:extLst>
               </a:tr>
               <a:tr h="320040">
                 <a:tc>
@@ -8267,6 +8701,11 @@
                   </a:txBody>
                   <a:tcPr/>
                 </a:tc>
+                <a:extLst>
+                  <a:ext uri="{0D108BD9-81ED-4DB2-BD59-A6C34878D82A}">
+                    <a16:rowId xmlns:a16="http://schemas.microsoft.com/office/drawing/2014/main" val="10005"/>
+                  </a:ext>
+                </a:extLst>
               </a:tr>
             </a:tbl>
           </a:graphicData>
@@ -8281,7 +8720,7 @@
         <p:spPr>
           <a:xfrm>
             <a:off x="6583680" y="1554480"/>
-            <a:ext cx="5303520" cy="4572000"/>
+            <a:ext cx="5303520" cy="3152466"/>
           </a:xfrm>
           <a:prstGeom prst="rect">
             <a:avLst/>
@@ -8308,7 +8747,16 @@
               </a:defRPr>
             </a:pPr>
             <a:r>
-              <a:t>Europe holds 40.9 per cent of all country-attributed records, more than any other region. This is heavily influenced by the United Kingdom, which alone accounts for 21.8 per cent of the country total, mostly from the COG-UK pandemic surveillance programme.</a:t>
+              <a:rPr dirty="0"/>
+              <a:t>Europe holds 40.9 per cent of all country-attributed records, more than any other region. This is heavily influenced by the United Kingdom</a:t>
+            </a:r>
+            <a:r>
+              <a:rPr lang="en-GB" dirty="0"/>
+              <a:t>. </a:t>
+            </a:r>
+            <a:r>
+              <a:rPr dirty="0"/>
+              <a:t>Without the UK, Europe share would fall to approximately 19 per cent, closer to the Americas and Asia.</a:t>
             </a:r>
           </a:p>
           <a:p>
@@ -8326,7 +8774,8 @@
               </a:defRPr>
             </a:pPr>
             <a:r>
-              <a:t>Without the UK, Europe share would fall to approximately 19 per cent, closer to the Americas and Asia.</a:t>
+              <a:rPr dirty="0"/>
+              <a:t>Africa, despite having 58 classified countries, holds only 3.6 per cent of records. This share has remained roughly constant throughout the period studied.</a:t>
             </a:r>
           </a:p>
           <a:p>
@@ -8344,24 +8793,7 @@
               </a:defRPr>
             </a:pPr>
             <a:r>
-              <a:t>Africa, despite having 58 classified countries, holds only 3.6 per cent of records. This share has remained roughly constant throughout the period studied.</a:t>
-            </a:r>
-          </a:p>
-          <a:p>
-            <a:pPr>
-              <a:lnSpc>
-                <a:spcPct val="130000"/>
-              </a:lnSpc>
-              <a:spcBef>
-                <a:spcPts val="800"/>
-              </a:spcBef>
-              <a:defRPr sz="1600" b="0">
-                <a:solidFill>
-                  <a:srgbClr val="1A1A1A"/>
-                </a:solidFill>
-              </a:defRPr>
-            </a:pPr>
-            <a:r>
+              <a:rPr dirty="0"/>
               <a:t>At the sub-regional level, Northern Europe and Northern America together hold over half of all records.</a:t>
             </a:r>
           </a:p>
@@ -8376,7 +8808,7 @@
 </file>
 
 <file path=ppt/slides/slide19.xml><?xml version="1.0" encoding="utf-8"?>
-<p:sld xmlns:a="http://schemas.openxmlformats.org/drawingml/2006/main" xmlns:p="http://schemas.openxmlformats.org/presentationml/2006/main" xmlns:r="http://schemas.openxmlformats.org/officeDocument/2006/relationships">
+<p:sld xmlns:a="http://schemas.openxmlformats.org/drawingml/2006/main" xmlns:r="http://schemas.openxmlformats.org/officeDocument/2006/relationships" xmlns:p="http://schemas.openxmlformats.org/presentationml/2006/main">
   <p:cSld>
     <p:spTree>
       <p:nvGrpSpPr>
@@ -8384,7 +8816,14 @@
         <p:cNvGrpSpPr/>
         <p:nvPr/>
       </p:nvGrpSpPr>
-      <p:grpSpPr/>
+      <p:grpSpPr>
+        <a:xfrm>
+          <a:off x="0" y="0"/>
+          <a:ext cx="0" cy="0"/>
+          <a:chOff x="0" y="0"/>
+          <a:chExt cx="0" cy="0"/>
+        </a:xfrm>
+      </p:grpSpPr>
       <p:sp>
         <p:nvSpPr>
           <p:cNvPr id="2" name="TextBox 1"/>
@@ -8475,6 +8914,7 @@
           <a:lstStyle/>
           <a:p>
             <a:pPr algn="ctr"/>
+            <a:endParaRPr/>
           </a:p>
         </p:txBody>
       </p:sp>
@@ -8497,10 +8937,34 @@
                 <a:tableStyleId>{5C22544A-7EE6-4342-B048-85BDC9FD1C3A}</a:tableStyleId>
               </a:tblPr>
               <a:tblGrid>
-                <a:gridCol w="1371600"/>
-                <a:gridCol w="1371600"/>
-                <a:gridCol w="1371600"/>
-                <a:gridCol w="1371600"/>
+                <a:gridCol w="1371600">
+                  <a:extLst>
+                    <a:ext uri="{9D8B030D-6E8A-4147-A177-3AD203B41FA5}">
+                      <a16:colId xmlns:a16="http://schemas.microsoft.com/office/drawing/2014/main" val="20000"/>
+                    </a:ext>
+                  </a:extLst>
+                </a:gridCol>
+                <a:gridCol w="1371600">
+                  <a:extLst>
+                    <a:ext uri="{9D8B030D-6E8A-4147-A177-3AD203B41FA5}">
+                      <a16:colId xmlns:a16="http://schemas.microsoft.com/office/drawing/2014/main" val="20001"/>
+                    </a:ext>
+                  </a:extLst>
+                </a:gridCol>
+                <a:gridCol w="1371600">
+                  <a:extLst>
+                    <a:ext uri="{9D8B030D-6E8A-4147-A177-3AD203B41FA5}">
+                      <a16:colId xmlns:a16="http://schemas.microsoft.com/office/drawing/2014/main" val="20002"/>
+                    </a:ext>
+                  </a:extLst>
+                </a:gridCol>
+                <a:gridCol w="1371600">
+                  <a:extLst>
+                    <a:ext uri="{9D8B030D-6E8A-4147-A177-3AD203B41FA5}">
+                      <a16:colId xmlns:a16="http://schemas.microsoft.com/office/drawing/2014/main" val="20003"/>
+                    </a:ext>
+                  </a:extLst>
+                </a:gridCol>
               </a:tblGrid>
               <a:tr h="320040">
                 <a:tc>
@@ -8595,6 +9059,11 @@
                     </a:solidFill>
                   </a:tcPr>
                 </a:tc>
+                <a:extLst>
+                  <a:ext uri="{0D108BD9-81ED-4DB2-BD59-A6C34878D82A}">
+                    <a16:rowId xmlns:a16="http://schemas.microsoft.com/office/drawing/2014/main" val="10000"/>
+                  </a:ext>
+                </a:extLst>
               </a:tr>
               <a:tr h="320040">
                 <a:tc>
@@ -8667,12 +9136,17 @@
                         </a:defRPr>
                       </a:pPr>
                       <a:r>
-                        <a:t>21.8%</a:t>
+                        <a:t>21.9%</a:t>
                       </a:r>
                     </a:p>
                   </a:txBody>
                   <a:tcPr/>
                 </a:tc>
+                <a:extLst>
+                  <a:ext uri="{0D108BD9-81ED-4DB2-BD59-A6C34878D82A}">
+                    <a16:rowId xmlns:a16="http://schemas.microsoft.com/office/drawing/2014/main" val="10001"/>
+                  </a:ext>
+                </a:extLst>
               </a:tr>
               <a:tr h="320040">
                 <a:tc>
@@ -8767,6 +9241,11 @@
                     </a:solidFill>
                   </a:tcPr>
                 </a:tc>
+                <a:extLst>
+                  <a:ext uri="{0D108BD9-81ED-4DB2-BD59-A6C34878D82A}">
+                    <a16:rowId xmlns:a16="http://schemas.microsoft.com/office/drawing/2014/main" val="10002"/>
+                  </a:ext>
+                </a:extLst>
               </a:tr>
               <a:tr h="320040">
                 <a:tc>
@@ -8845,6 +9324,11 @@
                   </a:txBody>
                   <a:tcPr/>
                 </a:tc>
+                <a:extLst>
+                  <a:ext uri="{0D108BD9-81ED-4DB2-BD59-A6C34878D82A}">
+                    <a16:rowId xmlns:a16="http://schemas.microsoft.com/office/drawing/2014/main" val="10003"/>
+                  </a:ext>
+                </a:extLst>
               </a:tr>
               <a:tr h="320040">
                 <a:tc>
@@ -8939,6 +9423,11 @@
                     </a:solidFill>
                   </a:tcPr>
                 </a:tc>
+                <a:extLst>
+                  <a:ext uri="{0D108BD9-81ED-4DB2-BD59-A6C34878D82A}">
+                    <a16:rowId xmlns:a16="http://schemas.microsoft.com/office/drawing/2014/main" val="10004"/>
+                  </a:ext>
+                </a:extLst>
               </a:tr>
               <a:tr h="320040">
                 <a:tc>
@@ -9017,6 +9506,11 @@
                   </a:txBody>
                   <a:tcPr/>
                 </a:tc>
+                <a:extLst>
+                  <a:ext uri="{0D108BD9-81ED-4DB2-BD59-A6C34878D82A}">
+                    <a16:rowId xmlns:a16="http://schemas.microsoft.com/office/drawing/2014/main" val="10005"/>
+                  </a:ext>
+                </a:extLst>
               </a:tr>
               <a:tr h="320040">
                 <a:tc>
@@ -9111,6 +9605,11 @@
                     </a:solidFill>
                   </a:tcPr>
                 </a:tc>
+                <a:extLst>
+                  <a:ext uri="{0D108BD9-81ED-4DB2-BD59-A6C34878D82A}">
+                    <a16:rowId xmlns:a16="http://schemas.microsoft.com/office/drawing/2014/main" val="10006"/>
+                  </a:ext>
+                </a:extLst>
               </a:tr>
               <a:tr h="320040">
                 <a:tc>
@@ -9189,6 +9688,11 @@
                   </a:txBody>
                   <a:tcPr/>
                 </a:tc>
+                <a:extLst>
+                  <a:ext uri="{0D108BD9-81ED-4DB2-BD59-A6C34878D82A}">
+                    <a16:rowId xmlns:a16="http://schemas.microsoft.com/office/drawing/2014/main" val="10007"/>
+                  </a:ext>
+                </a:extLst>
               </a:tr>
               <a:tr h="320040">
                 <a:tc>
@@ -9283,6 +9787,11 @@
                     </a:solidFill>
                   </a:tcPr>
                 </a:tc>
+                <a:extLst>
+                  <a:ext uri="{0D108BD9-81ED-4DB2-BD59-A6C34878D82A}">
+                    <a16:rowId xmlns:a16="http://schemas.microsoft.com/office/drawing/2014/main" val="10008"/>
+                  </a:ext>
+                </a:extLst>
               </a:tr>
               <a:tr h="320040">
                 <a:tc>
@@ -9361,6 +9870,11 @@
                   </a:txBody>
                   <a:tcPr/>
                 </a:tc>
+                <a:extLst>
+                  <a:ext uri="{0D108BD9-81ED-4DB2-BD59-A6C34878D82A}">
+                    <a16:rowId xmlns:a16="http://schemas.microsoft.com/office/drawing/2014/main" val="10009"/>
+                  </a:ext>
+                </a:extLst>
               </a:tr>
               <a:tr h="320040">
                 <a:tc>
@@ -9445,7 +9959,7 @@
                         </a:defRPr>
                       </a:pPr>
                       <a:r>
-                        <a:t>1.7%</a:t>
+                        <a:t>1.8%</a:t>
                       </a:r>
                     </a:p>
                   </a:txBody>
@@ -9455,6 +9969,11 @@
                     </a:solidFill>
                   </a:tcPr>
                 </a:tc>
+                <a:extLst>
+                  <a:ext uri="{0D108BD9-81ED-4DB2-BD59-A6C34878D82A}">
+                    <a16:rowId xmlns:a16="http://schemas.microsoft.com/office/drawing/2014/main" val="10010"/>
+                  </a:ext>
+                </a:extLst>
               </a:tr>
             </a:tbl>
           </a:graphicData>
@@ -9469,7 +9988,7 @@
         <p:spPr>
           <a:xfrm>
             <a:off x="6583680" y="1554480"/>
-            <a:ext cx="5303520" cy="4572000"/>
+            <a:ext cx="5303520" cy="2729786"/>
           </a:xfrm>
           <a:prstGeom prst="rect">
             <a:avLst/>
@@ -9496,7 +10015,8 @@
               </a:defRPr>
             </a:pPr>
             <a:r>
-              <a:t>The United Kingdom, the United States, and China together account for 60.7 per cent of all country-attributed records. No other country reaches 3 per cent.</a:t>
+              <a:rPr dirty="0"/>
+              <a:t>The United Kingdom, the United States, and China together account for 60.8 per cent of all country-attributed records. No other country reaches 3 per cent.</a:t>
             </a:r>
           </a:p>
           <a:p>
@@ -9514,25 +10034,8 @@
               </a:defRPr>
             </a:pPr>
             <a:r>
+              <a:rPr dirty="0"/>
               <a:t>This concentration is a critical consideration for any allocation formula. A formula based on raw record counts would channel most benefits to a small number of countries that already have substantial sequencing capacity, undermining the equity objectives of the Cali Fund.</a:t>
-            </a:r>
-          </a:p>
-          <a:p>
-            <a:pPr>
-              <a:lnSpc>
-                <a:spcPct val="130000"/>
-              </a:lnSpc>
-              <a:spcBef>
-                <a:spcPts val="800"/>
-              </a:spcBef>
-              <a:defRPr sz="1600" b="0">
-                <a:solidFill>
-                  <a:srgbClr val="1A1A1A"/>
-                </a:solidFill>
-              </a:defRPr>
-            </a:pPr>
-            <a:r>
-              <a:t>The UK count is inflated by the COG-UK consortium, which deposited over 1.5 million SARS-CoV-2 records in 2021. Without these pandemic records, the UK would rank below China and the USA.</a:t>
             </a:r>
           </a:p>
         </p:txBody>
@@ -9546,7 +10049,7 @@
 </file>
 
 <file path=ppt/slides/slide2.xml><?xml version="1.0" encoding="utf-8"?>
-<p:sld xmlns:a="http://schemas.openxmlformats.org/drawingml/2006/main" xmlns:p="http://schemas.openxmlformats.org/presentationml/2006/main" xmlns:r="http://schemas.openxmlformats.org/officeDocument/2006/relationships">
+<p:sld xmlns:a="http://schemas.openxmlformats.org/drawingml/2006/main" xmlns:r="http://schemas.openxmlformats.org/officeDocument/2006/relationships" xmlns:p="http://schemas.openxmlformats.org/presentationml/2006/main">
   <p:cSld>
     <p:spTree>
       <p:nvGrpSpPr>
@@ -9554,7 +10057,14 @@
         <p:cNvGrpSpPr/>
         <p:nvPr/>
       </p:nvGrpSpPr>
-      <p:grpSpPr/>
+      <p:grpSpPr>
+        <a:xfrm>
+          <a:off x="0" y="0"/>
+          <a:ext cx="0" cy="0"/>
+          <a:chOff x="0" y="0"/>
+          <a:chExt cx="0" cy="0"/>
+        </a:xfrm>
+      </p:grpSpPr>
       <p:sp>
         <p:nvSpPr>
           <p:cNvPr id="2" name="TextBox 1"/>
@@ -9630,6 +10140,7 @@
           <a:lstStyle/>
           <a:p>
             <a:pPr algn="ctr"/>
+            <a:endParaRPr/>
           </a:p>
         </p:txBody>
       </p:sp>
@@ -9642,7 +10153,7 @@
         <p:spPr>
           <a:xfrm>
             <a:off x="731520" y="1554480"/>
-            <a:ext cx="10515600" cy="4846320"/>
+            <a:ext cx="10515600" cy="4074577"/>
           </a:xfrm>
           <a:prstGeom prst="rect">
             <a:avLst/>
@@ -9669,6 +10180,7 @@
               </a:defRPr>
             </a:pPr>
             <a:r>
+              <a:rPr dirty="0"/>
               <a:t>The multilateral mechanism for benefit-sharing from digital sequence information (DSI), agreed at COP16 in Cali, includes a fund to which users of DSI are expected to contribute.</a:t>
             </a:r>
           </a:p>
@@ -9687,6 +10199,7 @@
               </a:defRPr>
             </a:pPr>
             <a:r>
+              <a:rPr dirty="0"/>
               <a:t>A central question is how to allocate those funds among eligible countries. One proposed basis is the geographic distribution of sequence records in public databases: countries that are the source of many sequenced organisms might be considered to have contributed more to the global commons.</a:t>
             </a:r>
           </a:p>
@@ -9705,8 +10218,18 @@
               </a:defRPr>
             </a:pPr>
             <a:r>
-              <a:t>This report tests whether INSDC provenance data are fit for that purpose. It does not prescribe a formula. Rather, it examines whether the data are complete enough, fair enough, and stable enough to support an allocation methodology.</a:t>
-            </a:r>
+              <a:rPr dirty="0"/>
+              <a:t>This report tests whether INSDC provenance data are fit for that purpose. </a:t>
+            </a:r>
+            <a:r>
+              <a:rPr lang="en-GB" dirty="0"/>
+              <a:t>It </a:t>
+            </a:r>
+            <a:r>
+              <a:rPr dirty="0"/>
+              <a:t>examines whether the data are complete enough, fair enough, and stable enough to support an allocation methodology.</a:t>
+            </a:r>
+            <a:endParaRPr lang="en-GB" dirty="0"/>
           </a:p>
           <a:p>
             <a:pPr>
@@ -9716,15 +10239,32 @@
               <a:spcBef>
                 <a:spcPts val="800"/>
               </a:spcBef>
-              <a:defRPr sz="1400" b="0">
-                <a:solidFill>
-                  <a:srgbClr val="999999"/>
+              <a:defRPr sz="1800" b="0">
+                <a:solidFill>
+                  <a:srgbClr val="1A1A1A"/>
                 </a:solidFill>
               </a:defRPr>
             </a:pPr>
             <a:r>
-              <a:t>INSDC: International Nucleotide Sequence Database Collaboration, comprising ENA (Europe), DDBJ (Japan), and NCBI (USA). The three databases exchange data daily.</a:t>
-            </a:r>
+              <a:rPr lang="en-GB" dirty="0"/>
+              <a:t>This analysis was conducted to provide the best information possible in the time available. It has not been peer reviewed.</a:t>
+            </a:r>
+          </a:p>
+          <a:p>
+            <a:pPr>
+              <a:lnSpc>
+                <a:spcPct val="130000"/>
+              </a:lnSpc>
+              <a:spcBef>
+                <a:spcPts val="800"/>
+              </a:spcBef>
+              <a:defRPr sz="1800" b="0">
+                <a:solidFill>
+                  <a:srgbClr val="1A1A1A"/>
+                </a:solidFill>
+              </a:defRPr>
+            </a:pPr>
+            <a:endParaRPr dirty="0"/>
           </a:p>
         </p:txBody>
       </p:sp>
@@ -9737,7 +10277,7 @@
 </file>
 
 <file path=ppt/slides/slide20.xml><?xml version="1.0" encoding="utf-8"?>
-<p:sld xmlns:a="http://schemas.openxmlformats.org/drawingml/2006/main" xmlns:p="http://schemas.openxmlformats.org/presentationml/2006/main" xmlns:r="http://schemas.openxmlformats.org/officeDocument/2006/relationships">
+<p:sld xmlns:a="http://schemas.openxmlformats.org/drawingml/2006/main" xmlns:r="http://schemas.openxmlformats.org/officeDocument/2006/relationships" xmlns:p="http://schemas.openxmlformats.org/presentationml/2006/main">
   <p:cSld>
     <p:spTree>
       <p:nvGrpSpPr>
@@ -9745,7 +10285,14 @@
         <p:cNvGrpSpPr/>
         <p:nvPr/>
       </p:nvGrpSpPr>
-      <p:grpSpPr/>
+      <p:grpSpPr>
+        <a:xfrm>
+          <a:off x="0" y="0"/>
+          <a:ext cx="0" cy="0"/>
+          <a:chOff x="0" y="0"/>
+          <a:chExt cx="0" cy="0"/>
+        </a:xfrm>
+      </p:grpSpPr>
       <p:sp>
         <p:nvSpPr>
           <p:cNvPr id="2" name="TextBox 1"/>
@@ -9836,6 +10383,7 @@
           <a:lstStyle/>
           <a:p>
             <a:pPr algn="ctr"/>
+            <a:endParaRPr/>
           </a:p>
         </p:txBody>
       </p:sp>
@@ -9848,7 +10396,7 @@
         <p:spPr>
           <a:xfrm>
             <a:off x="731520" y="1554480"/>
-            <a:ext cx="10515600" cy="4846320"/>
+            <a:ext cx="10515600" cy="4453783"/>
           </a:xfrm>
           <a:prstGeom prst="rect">
             <a:avLst/>
@@ -9875,7 +10423,16 @@
               </a:defRPr>
             </a:pPr>
             <a:r>
-              <a:t>In 2021, UK records jumped from 162,561 to 1,651,232, a tenfold increase driven by the COVID-19 Genomics UK (COG-UK) consortium. Similar surges occurred in the United States and other developed countries with large genomic surveillance programmes.</a:t>
+              <a:rPr dirty="0"/>
+              <a:t>In 2021, UK records jumped from 165,918 to 1,593,869, nearly a tenfold increase driven by the COVID-19 Genomics UK (COG-UK) consortium. Similar surges occurred in the United States and other developed countries with large genomic surveillance </a:t>
+            </a:r>
+            <a:r>
+              <a:rPr dirty="0" err="1"/>
+              <a:t>programmes</a:t>
+            </a:r>
+            <a:r>
+              <a:rPr dirty="0"/>
+              <a:t>.</a:t>
             </a:r>
           </a:p>
           <a:p>
@@ -9893,7 +10450,8 @@
               </a:defRPr>
             </a:pPr>
             <a:r>
-              <a:t>This single event inflated the developed-country share by approximately 13 percentage points, from 69.9 per cent in 2020 to 83.3 per cent in 2021. The pandemic records are SARS-CoV-2 sequences, not biodiversity DSI, and they are not representative of the underlying trend.</a:t>
+              <a:rPr dirty="0"/>
+              <a:t>This single event inflated the developed-country share by approximately 13 percentage points, from 70.0 per cent in 2020 to 83.3 per cent in 2021. The pandemic records are SARS-CoV-2 sequences, not biodiversity DSI, and they are not representative of the underlying trend.</a:t>
             </a:r>
           </a:p>
           <a:p>
@@ -9911,6 +10469,7 @@
               </a:defRPr>
             </a:pPr>
             <a:r>
+              <a:rPr dirty="0"/>
               <a:t>The decline from 2021 onwards reflects two forces: the winding down of pandemic surveillance in developed countries, and continued growth in developing-country sequencing, particularly from China. It is not yet clear whether the convergence visible in 2026 will be sustained once pandemic records are no longer distorting the baseline.</a:t>
             </a:r>
           </a:p>
@@ -9929,7 +10488,8 @@
               </a:defRPr>
             </a:pPr>
             <a:r>
-              <a:t>To assess genuine trends in biodiversity DSI, a sensitivity view excluding SARS-CoV-2 records would be needed. This was not available for this report but should be a priority for future analysis.</a:t>
+              <a:rPr dirty="0"/>
+              <a:t>To assess genuine trends in biodiversity DSI, a sensitivity view excluding SARS-CoV-2 records would be needed. This should be a priority for future analysis.</a:t>
             </a:r>
           </a:p>
         </p:txBody>
@@ -9943,7 +10503,7 @@
 </file>
 
 <file path=ppt/slides/slide21.xml><?xml version="1.0" encoding="utf-8"?>
-<p:sld xmlns:a="http://schemas.openxmlformats.org/drawingml/2006/main" xmlns:p="http://schemas.openxmlformats.org/presentationml/2006/main" xmlns:r="http://schemas.openxmlformats.org/officeDocument/2006/relationships">
+<p:sld xmlns:a="http://schemas.openxmlformats.org/drawingml/2006/main" xmlns:r="http://schemas.openxmlformats.org/officeDocument/2006/relationships" xmlns:p="http://schemas.openxmlformats.org/presentationml/2006/main">
   <p:cSld>
     <p:spTree>
       <p:nvGrpSpPr>
@@ -9951,7 +10511,14 @@
         <p:cNvGrpSpPr/>
         <p:nvPr/>
       </p:nvGrpSpPr>
-      <p:grpSpPr/>
+      <p:grpSpPr>
+        <a:xfrm>
+          <a:off x="0" y="0"/>
+          <a:ext cx="0" cy="0"/>
+          <a:chOff x="0" y="0"/>
+          <a:chExt cx="0" cy="0"/>
+        </a:xfrm>
+      </p:grpSpPr>
       <p:sp>
         <p:nvSpPr>
           <p:cNvPr id="2" name="TextBox 1"/>
@@ -10042,6 +10609,7 @@
           <a:lstStyle/>
           <a:p>
             <a:pPr algn="ctr"/>
+            <a:endParaRPr/>
           </a:p>
         </p:txBody>
       </p:sp>
@@ -10064,12 +10632,48 @@
                 <a:tableStyleId>{5C22544A-7EE6-4342-B048-85BDC9FD1C3A}</a:tableStyleId>
               </a:tblPr>
               <a:tblGrid>
-                <a:gridCol w="1645920"/>
-                <a:gridCol w="1828800"/>
-                <a:gridCol w="2011680"/>
-                <a:gridCol w="1371600"/>
-                <a:gridCol w="2011680"/>
-                <a:gridCol w="1371600"/>
+                <a:gridCol w="1645920">
+                  <a:extLst>
+                    <a:ext uri="{9D8B030D-6E8A-4147-A177-3AD203B41FA5}">
+                      <a16:colId xmlns:a16="http://schemas.microsoft.com/office/drawing/2014/main" val="20000"/>
+                    </a:ext>
+                  </a:extLst>
+                </a:gridCol>
+                <a:gridCol w="1828800">
+                  <a:extLst>
+                    <a:ext uri="{9D8B030D-6E8A-4147-A177-3AD203B41FA5}">
+                      <a16:colId xmlns:a16="http://schemas.microsoft.com/office/drawing/2014/main" val="20001"/>
+                    </a:ext>
+                  </a:extLst>
+                </a:gridCol>
+                <a:gridCol w="2011680">
+                  <a:extLst>
+                    <a:ext uri="{9D8B030D-6E8A-4147-A177-3AD203B41FA5}">
+                      <a16:colId xmlns:a16="http://schemas.microsoft.com/office/drawing/2014/main" val="20002"/>
+                    </a:ext>
+                  </a:extLst>
+                </a:gridCol>
+                <a:gridCol w="1371600">
+                  <a:extLst>
+                    <a:ext uri="{9D8B030D-6E8A-4147-A177-3AD203B41FA5}">
+                      <a16:colId xmlns:a16="http://schemas.microsoft.com/office/drawing/2014/main" val="20003"/>
+                    </a:ext>
+                  </a:extLst>
+                </a:gridCol>
+                <a:gridCol w="2011680">
+                  <a:extLst>
+                    <a:ext uri="{9D8B030D-6E8A-4147-A177-3AD203B41FA5}">
+                      <a16:colId xmlns:a16="http://schemas.microsoft.com/office/drawing/2014/main" val="20004"/>
+                    </a:ext>
+                  </a:extLst>
+                </a:gridCol>
+                <a:gridCol w="1371600">
+                  <a:extLst>
+                    <a:ext uri="{9D8B030D-6E8A-4147-A177-3AD203B41FA5}">
+                      <a16:colId xmlns:a16="http://schemas.microsoft.com/office/drawing/2014/main" val="20005"/>
+                    </a:ext>
+                  </a:extLst>
+                </a:gridCol>
               </a:tblGrid>
               <a:tr h="320040">
                 <a:tc>
@@ -10210,6 +10814,11 @@
                     </a:solidFill>
                   </a:tcPr>
                 </a:tc>
+                <a:extLst>
+                  <a:ext uri="{0D108BD9-81ED-4DB2-BD59-A6C34878D82A}">
+                    <a16:rowId xmlns:a16="http://schemas.microsoft.com/office/drawing/2014/main" val="10000"/>
+                  </a:ext>
+                </a:extLst>
               </a:tr>
               <a:tr h="320040">
                 <a:tc>
@@ -10263,7 +10872,7 @@
                         </a:defRPr>
                       </a:pPr>
                       <a:r>
-                        <a:t>1,985,212</a:t>
+                        <a:t>1,985,213</a:t>
                       </a:r>
                     </a:p>
                   </a:txBody>
@@ -10301,7 +10910,7 @@
                         </a:defRPr>
                       </a:pPr>
                       <a:r>
-                        <a:t>865,856</a:t>
+                        <a:t>865,857</a:t>
                       </a:r>
                     </a:p>
                   </a:txBody>
@@ -10326,6 +10935,11 @@
                   </a:txBody>
                   <a:tcPr/>
                 </a:tc>
+                <a:extLst>
+                  <a:ext uri="{0D108BD9-81ED-4DB2-BD59-A6C34878D82A}">
+                    <a16:rowId xmlns:a16="http://schemas.microsoft.com/office/drawing/2014/main" val="10001"/>
+                  </a:ext>
+                </a:extLst>
               </a:tr>
               <a:tr h="320040">
                 <a:tc>
@@ -10364,7 +10978,7 @@
                         </a:defRPr>
                       </a:pPr>
                       <a:r>
-                        <a:t>229,487</a:t>
+                        <a:t>229,488</a:t>
                       </a:r>
                     </a:p>
                   </a:txBody>
@@ -10466,6 +11080,11 @@
                     </a:solidFill>
                   </a:tcPr>
                 </a:tc>
+                <a:extLst>
+                  <a:ext uri="{0D108BD9-81ED-4DB2-BD59-A6C34878D82A}">
+                    <a16:rowId xmlns:a16="http://schemas.microsoft.com/office/drawing/2014/main" val="10002"/>
+                  </a:ext>
+                </a:extLst>
               </a:tr>
               <a:tr h="320040">
                 <a:tc>
@@ -10557,7 +11176,7 @@
                         </a:defRPr>
                       </a:pPr>
                       <a:r>
-                        <a:t>22,009</a:t>
+                        <a:t>22,010</a:t>
                       </a:r>
                     </a:p>
                   </a:txBody>
@@ -10582,6 +11201,11 @@
                   </a:txBody>
                   <a:tcPr/>
                 </a:tc>
+                <a:extLst>
+                  <a:ext uri="{0D108BD9-81ED-4DB2-BD59-A6C34878D82A}">
+                    <a16:rowId xmlns:a16="http://schemas.microsoft.com/office/drawing/2014/main" val="10003"/>
+                  </a:ext>
+                </a:extLst>
               </a:tr>
               <a:tr h="320040">
                 <a:tc>
@@ -10620,7 +11244,7 @@
                         </a:defRPr>
                       </a:pPr>
                       <a:r>
-                        <a:t>9,617</a:t>
+                        <a:t>9,618</a:t>
                       </a:r>
                     </a:p>
                   </a:txBody>
@@ -10722,6 +11346,11 @@
                     </a:solidFill>
                   </a:tcPr>
                 </a:tc>
+                <a:extLst>
+                  <a:ext uri="{0D108BD9-81ED-4DB2-BD59-A6C34878D82A}">
+                    <a16:rowId xmlns:a16="http://schemas.microsoft.com/office/drawing/2014/main" val="10004"/>
+                  </a:ext>
+                </a:extLst>
               </a:tr>
               <a:tr h="320040">
                 <a:tc>
@@ -10838,6 +11467,11 @@
                   </a:txBody>
                   <a:tcPr/>
                 </a:tc>
+                <a:extLst>
+                  <a:ext uri="{0D108BD9-81ED-4DB2-BD59-A6C34878D82A}">
+                    <a16:rowId xmlns:a16="http://schemas.microsoft.com/office/drawing/2014/main" val="10005"/>
+                  </a:ext>
+                </a:extLst>
               </a:tr>
             </a:tbl>
           </a:graphicData>
@@ -10851,7 +11485,7 @@
         </p:nvSpPr>
         <p:spPr>
           <a:xfrm>
-            <a:off x="731520" y="4389120"/>
+            <a:off x="731520" y="3840480"/>
             <a:ext cx="10515600" cy="2011680"/>
           </a:xfrm>
           <a:prstGeom prst="rect">
@@ -10879,6 +11513,7 @@
               </a:defRPr>
             </a:pPr>
             <a:r>
+              <a:rPr dirty="0"/>
               <a:t>The pandemic period saw dramatic growth across all groups, but the growth was far larger for developed countries (+244 per cent) than for developing countries (+143 per cent). This widened the absolute gap even as it temporarily increased the developed-country share.</a:t>
             </a:r>
           </a:p>
@@ -10897,6 +11532,7 @@
               </a:defRPr>
             </a:pPr>
             <a:r>
+              <a:rPr dirty="0"/>
               <a:t>In the post-pandemic period, developed-country records declined by 56 per cent from their pandemic peak, while developing-country records continued to grow, by 27 per cent. For the first time in the period studied, developing countries are generating more records per year than developed countries, though the 2026 figure is based on partial-year data.</a:t>
             </a:r>
           </a:p>
@@ -10915,6 +11551,7 @@
               </a:defRPr>
             </a:pPr>
             <a:r>
+              <a:rPr dirty="0"/>
               <a:t>All vulnerable country groups saw their records decline from pandemic peaks, suggesting that pandemic-era growth was project-specific and temporary.</a:t>
             </a:r>
           </a:p>
@@ -10929,7 +11566,7 @@
 </file>
 
 <file path=ppt/slides/slide22.xml><?xml version="1.0" encoding="utf-8"?>
-<p:sld xmlns:a="http://schemas.openxmlformats.org/drawingml/2006/main" xmlns:p="http://schemas.openxmlformats.org/presentationml/2006/main" xmlns:r="http://schemas.openxmlformats.org/officeDocument/2006/relationships">
+<p:sld xmlns:a="http://schemas.openxmlformats.org/drawingml/2006/main" xmlns:r="http://schemas.openxmlformats.org/officeDocument/2006/relationships" xmlns:p="http://schemas.openxmlformats.org/presentationml/2006/main">
   <p:cSld>
     <p:spTree>
       <p:nvGrpSpPr>
@@ -10937,7 +11574,14 @@
         <p:cNvGrpSpPr/>
         <p:nvPr/>
       </p:nvGrpSpPr>
-      <p:grpSpPr/>
+      <p:grpSpPr>
+        <a:xfrm>
+          <a:off x="0" y="0"/>
+          <a:ext cx="0" cy="0"/>
+          <a:chOff x="0" y="0"/>
+          <a:chExt cx="0" cy="0"/>
+        </a:xfrm>
+      </p:grpSpPr>
       <p:sp>
         <p:nvSpPr>
           <p:cNvPr id="2" name="TextBox 1"/>
@@ -11028,6 +11672,7 @@
           <a:lstStyle/>
           <a:p>
             <a:pPr algn="ctr"/>
+            <a:endParaRPr/>
           </a:p>
         </p:txBody>
       </p:sp>
@@ -11040,7 +11685,7 @@
         <p:spPr>
           <a:xfrm>
             <a:off x="731520" y="1554480"/>
-            <a:ext cx="10515600" cy="4846320"/>
+            <a:ext cx="10515600" cy="3106300"/>
           </a:xfrm>
           <a:prstGeom prst="rect">
             <a:avLst/>
@@ -11067,6 +11712,7 @@
               </a:defRPr>
             </a:pPr>
             <a:r>
+              <a:rPr dirty="0"/>
               <a:t>1.  Incompleteness</a:t>
             </a:r>
           </a:p>
@@ -11085,7 +11731,8 @@
               </a:defRPr>
             </a:pPr>
             <a:r>
-              <a:t>38.3 per cent of records cannot be attributed to any country, and 21.5 per cent have no date. The excluded fraction is not random.</a:t>
+              <a:rPr dirty="0"/>
+              <a:t>37.5 per cent of records cannot be attributed to any country, and 21.5 per cent have no date. The excluded fraction is not random.</a:t>
             </a:r>
           </a:p>
           <a:p>
@@ -11103,6 +11750,7 @@
               </a:defRPr>
             </a:pPr>
             <a:r>
+              <a:rPr dirty="0"/>
               <a:t>2.  Concentration</a:t>
             </a:r>
           </a:p>
@@ -11121,7 +11769,8 @@
               </a:defRPr>
             </a:pPr>
             <a:r>
-              <a:t>Three countries account for 60.7 per cent of records. A formula based on raw counts would channel benefits to countries that already have substantial sequencing capacity.</a:t>
+              <a:rPr dirty="0"/>
+              <a:t>Three countries account for 60.8 per cent of records. A formula based on raw counts would channel benefits to countries that already have substantial sequencing capacity.</a:t>
             </a:r>
           </a:p>
           <a:p>
@@ -11139,6 +11788,7 @@
               </a:defRPr>
             </a:pPr>
             <a:r>
+              <a:rPr dirty="0"/>
               <a:t>3.  Distortion</a:t>
             </a:r>
           </a:p>
@@ -11157,43 +11807,8 @@
               </a:defRPr>
             </a:pPr>
             <a:r>
-              <a:t>COVID-19 pandemic records severely distort temporal trends. The UK alone deposited 1.65 million records in 2021, ten times its 2020 count.</a:t>
-            </a:r>
-          </a:p>
-          <a:p>
-            <a:pPr>
-              <a:lnSpc>
-                <a:spcPct val="130000"/>
-              </a:lnSpc>
-              <a:spcBef>
-                <a:spcPts val="800"/>
-              </a:spcBef>
-              <a:defRPr sz="1800" b="1">
-                <a:solidFill>
-                  <a:srgbClr val="1F4E79"/>
-                </a:solidFill>
-              </a:defRPr>
-            </a:pPr>
-            <a:r>
-              <a:t>4.  Mismatch</a:t>
-            </a:r>
-          </a:p>
-          <a:p>
-            <a:pPr lvl="1">
-              <a:lnSpc>
-                <a:spcPct val="130000"/>
-              </a:lnSpc>
-              <a:spcBef>
-                <a:spcPts val="400"/>
-              </a:spcBef>
-              <a:defRPr sz="1600" b="0">
-                <a:solidFill>
-                  <a:srgbClr val="1A1A1A"/>
-                </a:solidFill>
-              </a:defRPr>
-            </a:pPr>
-            <a:r>
-              <a:t>The country field records where a sample was collected, not who sequenced it. A Kenyan sample sequenced in the UK appears as Kenya.</a:t>
+              <a:rPr dirty="0"/>
+              <a:t>COVID-19 pandemic records severely distort temporal trends. </a:t>
             </a:r>
           </a:p>
         </p:txBody>
@@ -11207,7 +11822,7 @@
 </file>
 
 <file path=ppt/slides/slide23.xml><?xml version="1.0" encoding="utf-8"?>
-<p:sld xmlns:a="http://schemas.openxmlformats.org/drawingml/2006/main" xmlns:p="http://schemas.openxmlformats.org/presentationml/2006/main" xmlns:r="http://schemas.openxmlformats.org/officeDocument/2006/relationships">
+<p:sld xmlns:a="http://schemas.openxmlformats.org/drawingml/2006/main" xmlns:r="http://schemas.openxmlformats.org/officeDocument/2006/relationships" xmlns:p="http://schemas.openxmlformats.org/presentationml/2006/main">
   <p:cSld>
     <p:spTree>
       <p:nvGrpSpPr>
@@ -11215,7 +11830,14 @@
         <p:cNvGrpSpPr/>
         <p:nvPr/>
       </p:nvGrpSpPr>
-      <p:grpSpPr/>
+      <p:grpSpPr>
+        <a:xfrm>
+          <a:off x="0" y="0"/>
+          <a:ext cx="0" cy="0"/>
+          <a:chOff x="0" y="0"/>
+          <a:chExt cx="0" cy="0"/>
+        </a:xfrm>
+      </p:grpSpPr>
       <p:sp>
         <p:nvSpPr>
           <p:cNvPr id="2" name="TextBox 1"/>
@@ -11291,6 +11913,7 @@
           <a:lstStyle/>
           <a:p>
             <a:pPr algn="ctr"/>
+            <a:endParaRPr/>
           </a:p>
         </p:txBody>
       </p:sp>
@@ -11303,7 +11926,7 @@
         <p:spPr>
           <a:xfrm>
             <a:off x="731520" y="1554480"/>
-            <a:ext cx="10515600" cy="4846320"/>
+            <a:ext cx="10515600" cy="3927485"/>
           </a:xfrm>
           <a:prstGeom prst="rect">
             <a:avLst/>
@@ -11330,6 +11953,7 @@
               </a:defRPr>
             </a:pPr>
             <a:r>
+              <a:rPr dirty="0"/>
               <a:t>INSDC provenance data should inform, but not determine, Cali Fund allocation decisions.</a:t>
             </a:r>
           </a:p>
@@ -11348,6 +11972,7 @@
               </a:defRPr>
             </a:pPr>
             <a:r>
+              <a:rPr dirty="0"/>
               <a:t>The data are useful for identifying broad patterns of inequality, for monitoring trends over time, and for highlighting the specific needs of regions and country groups. They are not suitable as a direct input to an allocation formula because they are too incomplete, too concentrated, and too distorted by external events.</a:t>
             </a:r>
           </a:p>
@@ -11366,6 +11991,7 @@
               </a:defRPr>
             </a:pPr>
             <a:r>
+              <a:rPr dirty="0"/>
               <a:t>A more robust approach might combine INSDC data with other indicators:</a:t>
             </a:r>
           </a:p>
@@ -11384,6 +12010,7 @@
               </a:defRPr>
             </a:pPr>
             <a:r>
+              <a:rPr dirty="0"/>
               <a:t>Biodiversity richness (for example, species counts from GBIF)</a:t>
             </a:r>
           </a:p>
@@ -11402,6 +12029,7 @@
               </a:defRPr>
             </a:pPr>
             <a:r>
+              <a:rPr dirty="0"/>
               <a:t>Sequencing capacity (for example, number of sequencing facilities per country)</a:t>
             </a:r>
           </a:p>
@@ -11420,7 +12048,16 @@
               </a:defRPr>
             </a:pPr>
             <a:r>
-              <a:t>Economic need (for example, GDP per capita or LDC/SIDS/LLDC status)</a:t>
+              <a:rPr dirty="0"/>
+              <a:t>Economic need (for example, </a:t>
+            </a:r>
+            <a:r>
+              <a:rPr lang="en-GB" dirty="0"/>
+              <a:t>inverted UN Scale of Assessment or inverted GNI</a:t>
+            </a:r>
+            <a:r>
+              <a:rPr dirty="0"/>
+              <a:t> or LDC/SIDS/LLDC status)</a:t>
             </a:r>
           </a:p>
           <a:p>
@@ -11438,6 +12075,7 @@
               </a:defRPr>
             </a:pPr>
             <a:r>
+              <a:rPr dirty="0"/>
               <a:t>The Cali Fund allocation methodology should be a matter for Parties to negotiate, informed by evidence but not determined by it.</a:t>
             </a:r>
           </a:p>
@@ -11452,7 +12090,7 @@
 </file>
 
 <file path=ppt/slides/slide24.xml><?xml version="1.0" encoding="utf-8"?>
-<p:sld xmlns:a="http://schemas.openxmlformats.org/drawingml/2006/main" xmlns:p="http://schemas.openxmlformats.org/presentationml/2006/main" xmlns:r="http://schemas.openxmlformats.org/officeDocument/2006/relationships">
+<p:sld xmlns:a="http://schemas.openxmlformats.org/drawingml/2006/main" xmlns:r="http://schemas.openxmlformats.org/officeDocument/2006/relationships" xmlns:p="http://schemas.openxmlformats.org/presentationml/2006/main">
   <p:cSld>
     <p:spTree>
       <p:nvGrpSpPr>
@@ -11460,7 +12098,14 @@
         <p:cNvGrpSpPr/>
         <p:nvPr/>
       </p:nvGrpSpPr>
-      <p:grpSpPr/>
+      <p:grpSpPr>
+        <a:xfrm>
+          <a:off x="0" y="0"/>
+          <a:ext cx="0" cy="0"/>
+          <a:chOff x="0" y="0"/>
+          <a:chExt cx="0" cy="0"/>
+        </a:xfrm>
+      </p:grpSpPr>
       <p:sp>
         <p:nvSpPr>
           <p:cNvPr id="2" name="TextBox 1"/>
@@ -11536,6 +12181,7 @@
           <a:lstStyle/>
           <a:p>
             <a:pPr algn="ctr"/>
+            <a:endParaRPr/>
           </a:p>
         </p:txBody>
       </p:sp>
@@ -11548,7 +12194,7 @@
         <p:spPr>
           <a:xfrm>
             <a:off x="731520" y="1554480"/>
-            <a:ext cx="10515600" cy="4846320"/>
+            <a:ext cx="10515600" cy="5169364"/>
           </a:xfrm>
           <a:prstGeom prst="rect">
             <a:avLst/>
@@ -11568,14 +12214,15 @@
               <a:spcBef>
                 <a:spcPts val="800"/>
               </a:spcBef>
-              <a:defRPr sz="1700" b="0">
+              <a:defRPr sz="1800" b="0">
                 <a:solidFill>
                   <a:srgbClr val="1A1A1A"/>
                 </a:solidFill>
               </a:defRPr>
             </a:pPr>
             <a:r>
-              <a:t>Snapshot: All counts are a point-in-time snapshot taken on 13 October 2026. The database grows daily.</a:t>
+              <a:rPr lang="en-GB" sz="1600" dirty="0"/>
+              <a:t>Rapid assessment: This analysis was conducted to provide the best information possible in the time available. It has not been peer reviewed.</a:t>
             </a:r>
           </a:p>
           <a:p>
@@ -11593,7 +12240,8 @@
               </a:defRPr>
             </a:pPr>
             <a:r>
-              <a:t>Partial year: 2026 covers January to October only.</a:t>
+              <a:rPr sz="1600" dirty="0"/>
+              <a:t>Snapshot: All counts are a point-in-time snapshot taken on 13 October 2026. The database grows daily.</a:t>
             </a:r>
           </a:p>
           <a:p>
@@ -11611,7 +12259,8 @@
               </a:defRPr>
             </a:pPr>
             <a:r>
-              <a:t>Undated records: 21.5 per cent have no public release date. Annual counts are partial censuses.</a:t>
+              <a:rPr sz="1600" dirty="0"/>
+              <a:t>Partial year: 2026 covers January to October only.</a:t>
             </a:r>
           </a:p>
           <a:p>
@@ -11629,7 +12278,8 @@
               </a:defRPr>
             </a:pPr>
             <a:r>
-              <a:t>Data quality: The country field is submitter-populated and not standardised.</a:t>
+              <a:rPr sz="1600" dirty="0"/>
+              <a:t>Undated records: 21.5 per cent have no public release date. Annual counts are partial censuses.</a:t>
             </a:r>
           </a:p>
           <a:p>
@@ -11647,7 +12297,16 @@
               </a:defRPr>
             </a:pPr>
             <a:r>
-              <a:t>Metagenomes: Environmental metagenomes (27.7 per cent) are included and inflate counts for some countries.</a:t>
+              <a:rPr sz="1600" dirty="0"/>
+              <a:t>Data quality: The country field is submitter-populated and not </a:t>
+            </a:r>
+            <a:r>
+              <a:rPr sz="1600" dirty="0" err="1"/>
+              <a:t>standardised</a:t>
+            </a:r>
+            <a:r>
+              <a:rPr sz="1600" dirty="0"/>
+              <a:t>.</a:t>
             </a:r>
           </a:p>
           <a:p>
@@ -11665,8 +12324,83 @@
               </a:defRPr>
             </a:pPr>
             <a:r>
+              <a:rPr sz="1600" dirty="0"/>
+              <a:t>Metagenomes: Environmental metagenomes (27.7 per cent) are included and inflate counts for some countries.</a:t>
+            </a:r>
+          </a:p>
+          <a:p>
+            <a:pPr>
+              <a:lnSpc>
+                <a:spcPct val="130000"/>
+              </a:lnSpc>
+              <a:spcBef>
+                <a:spcPts val="800"/>
+              </a:spcBef>
+              <a:defRPr sz="1700" b="0">
+                <a:solidFill>
+                  <a:srgbClr val="1A1A1A"/>
+                </a:solidFill>
+              </a:defRPr>
+            </a:pPr>
+            <a:r>
+              <a:rPr sz="1600" dirty="0"/>
               <a:t>Collection versus contribution: The country field records collection locality, not the sequencing institution.</a:t>
             </a:r>
+          </a:p>
+          <a:p>
+            <a:pPr>
+              <a:lnSpc>
+                <a:spcPct val="130000"/>
+              </a:lnSpc>
+              <a:spcBef>
+                <a:spcPts val="800"/>
+              </a:spcBef>
+              <a:defRPr sz="1600" b="0">
+                <a:solidFill>
+                  <a:srgbClr val="1A1A1A"/>
+                </a:solidFill>
+              </a:defRPr>
+            </a:pPr>
+            <a:r>
+              <a:rPr sz="1600" dirty="0"/>
+              <a:t>Token-matching collisions: The ENA search engine indexes the country field as a text field and cannot distinguish the country portion from the locality portion. Twenty collision exclusions were applied, but individual country counts may contain small errors from undiscovered collisions where a country name appears as a locality in another country’s records.</a:t>
+            </a:r>
+            <a:endParaRPr lang="en-GB" sz="1600" dirty="0"/>
+          </a:p>
+          <a:p>
+            <a:pPr>
+              <a:lnSpc>
+                <a:spcPct val="130000"/>
+              </a:lnSpc>
+              <a:spcBef>
+                <a:spcPts val="800"/>
+              </a:spcBef>
+              <a:defRPr sz="1600" b="0">
+                <a:solidFill>
+                  <a:srgbClr val="1A1A1A"/>
+                </a:solidFill>
+              </a:defRPr>
+            </a:pPr>
+            <a:r>
+              <a:rPr lang="en-GB" sz="1600" dirty="0"/>
+              <a:t>COVID-19 Distortion: SARS-CoV-2 samples bias the dataset </a:t>
+            </a:r>
+          </a:p>
+          <a:p>
+            <a:pPr>
+              <a:lnSpc>
+                <a:spcPct val="130000"/>
+              </a:lnSpc>
+              <a:spcBef>
+                <a:spcPts val="800"/>
+              </a:spcBef>
+              <a:defRPr sz="1600" b="0">
+                <a:solidFill>
+                  <a:srgbClr val="1A1A1A"/>
+                </a:solidFill>
+              </a:defRPr>
+            </a:pPr>
+            <a:endParaRPr sz="1700" dirty="0"/>
           </a:p>
         </p:txBody>
       </p:sp>
@@ -11679,7 +12413,7 @@
 </file>
 
 <file path=ppt/slides/slide25.xml><?xml version="1.0" encoding="utf-8"?>
-<p:sld xmlns:a="http://schemas.openxmlformats.org/drawingml/2006/main" xmlns:p="http://schemas.openxmlformats.org/presentationml/2006/main" xmlns:r="http://schemas.openxmlformats.org/officeDocument/2006/relationships">
+<p:sld xmlns:a="http://schemas.openxmlformats.org/drawingml/2006/main" xmlns:r="http://schemas.openxmlformats.org/officeDocument/2006/relationships" xmlns:p="http://schemas.openxmlformats.org/presentationml/2006/main">
   <p:cSld>
     <p:bg>
       <p:bgPr>
@@ -11695,7 +12429,14 @@
         <p:cNvGrpSpPr/>
         <p:nvPr/>
       </p:nvGrpSpPr>
-      <p:grpSpPr/>
+      <p:grpSpPr>
+        <a:xfrm>
+          <a:off x="0" y="0"/>
+          <a:ext cx="0" cy="0"/>
+          <a:chOff x="0" y="0"/>
+          <a:chExt cx="0" cy="0"/>
+        </a:xfrm>
+      </p:grpSpPr>
       <p:sp>
         <p:nvSpPr>
           <p:cNvPr id="2" name="TextBox 1"/>
@@ -11705,7 +12446,7 @@
         <p:spPr>
           <a:xfrm>
             <a:off x="914400" y="1828800"/>
-            <a:ext cx="10058400" cy="3200400"/>
+            <a:ext cx="10058400" cy="1190069"/>
           </a:xfrm>
           <a:prstGeom prst="rect">
             <a:avLst/>
@@ -11726,6 +12467,7 @@
               </a:defRPr>
             </a:pPr>
             <a:r>
+              <a:rPr dirty="0"/>
               <a:t>Thank you</a:t>
             </a:r>
           </a:p>
@@ -11741,26 +12483,8 @@
               </a:defRPr>
             </a:pPr>
             <a:r>
+              <a:rPr dirty="0"/>
               <a:t>Questions and discussion welcome</a:t>
-            </a:r>
-          </a:p>
-          <a:p>
-            <a:pPr>
-              <a:spcBef>
-                <a:spcPts val="2400"/>
-              </a:spcBef>
-              <a:defRPr sz="1800">
-                <a:solidFill>
-                  <a:srgbClr val="7BA8D4"/>
-                </a:solidFill>
-              </a:defRPr>
-            </a:pPr>
-            <a:r>
-              <a:t>Full report: Global Variation in Sequence Accessions Over Time</a:t>
-            </a:r>
-            <a:br/>
-            <a:r>
-              <a:t>13 October 2026</a:t>
             </a:r>
           </a:p>
         </p:txBody>
@@ -11774,7 +12498,7 @@
 </file>
 
 <file path=ppt/slides/slide3.xml><?xml version="1.0" encoding="utf-8"?>
-<p:sld xmlns:a="http://schemas.openxmlformats.org/drawingml/2006/main" xmlns:p="http://schemas.openxmlformats.org/presentationml/2006/main" xmlns:r="http://schemas.openxmlformats.org/officeDocument/2006/relationships">
+<p:sld xmlns:a="http://schemas.openxmlformats.org/drawingml/2006/main" xmlns:r="http://schemas.openxmlformats.org/officeDocument/2006/relationships" xmlns:p="http://schemas.openxmlformats.org/presentationml/2006/main">
   <p:cSld>
     <p:spTree>
       <p:nvGrpSpPr>
@@ -11782,7 +12506,14 @@
         <p:cNvGrpSpPr/>
         <p:nvPr/>
       </p:nvGrpSpPr>
-      <p:grpSpPr/>
+      <p:grpSpPr>
+        <a:xfrm>
+          <a:off x="0" y="0"/>
+          <a:ext cx="0" cy="0"/>
+          <a:chOff x="0" y="0"/>
+          <a:chExt cx="0" cy="0"/>
+        </a:xfrm>
+      </p:grpSpPr>
       <p:sp>
         <p:nvSpPr>
           <p:cNvPr id="2" name="TextBox 1"/>
@@ -11873,6 +12604,7 @@
           <a:lstStyle/>
           <a:p>
             <a:pPr algn="ctr"/>
+            <a:endParaRPr/>
           </a:p>
         </p:txBody>
       </p:sp>
@@ -11885,7 +12617,7 @@
         <p:spPr>
           <a:xfrm>
             <a:off x="731520" y="1554480"/>
-            <a:ext cx="10515600" cy="4846320"/>
+            <a:ext cx="10515600" cy="4547655"/>
           </a:xfrm>
           <a:prstGeom prst="rect">
             <a:avLst/>
@@ -11912,6 +12644,7 @@
               </a:defRPr>
             </a:pPr>
             <a:r>
+              <a:rPr dirty="0"/>
               <a:t>All counts were obtained from the European Nucleotide Archive (ENA) Portal API, which provides programmatic access to metadata for biological samples deposited in INSDC databases. ENA is the European partner of INSDC, which also includes DDBJ and NCBI. The three databases exchange data daily, so counts from ENA are representative of global holdings.</a:t>
             </a:r>
           </a:p>
@@ -11930,6 +12663,7 @@
               </a:defRPr>
             </a:pPr>
             <a:r>
+              <a:rPr dirty="0"/>
               <a:t>The analysis uses the sample record type, corresponding to one record per biological sample deposited. This is the appropriate unit for provenance questions because a single sample may generate multiple sequencing runs, and counting runs would inflate the numbers.</a:t>
             </a:r>
           </a:p>
@@ -11948,6 +12682,7 @@
               </a:defRPr>
             </a:pPr>
             <a:r>
+              <a:rPr dirty="0"/>
               <a:t>Three categories of records were excluded:</a:t>
             </a:r>
           </a:p>
@@ -11966,6 +12701,7 @@
               </a:defRPr>
             </a:pPr>
             <a:r>
+              <a:rPr dirty="0"/>
               <a:t>Human organism records, which are not relevant to biodiversity benefit-sharing</a:t>
             </a:r>
           </a:p>
@@ -11984,6 +12720,7 @@
               </a:defRPr>
             </a:pPr>
             <a:r>
+              <a:rPr dirty="0"/>
               <a:t>Human microbiome samples, where the host organism is a human</a:t>
             </a:r>
           </a:p>
@@ -12002,6 +12739,7 @@
               </a:defRPr>
             </a:pPr>
             <a:r>
+              <a:rPr dirty="0"/>
               <a:t>Synthetic constructs, which do not correspond to biological genetic resources</a:t>
             </a:r>
           </a:p>
@@ -12020,7 +12758,8 @@
               </a:defRPr>
             </a:pPr>
             <a:r>
-              <a:t>After applying these filters, the total record count was 30,313,212. This figure was verified by an independent query to the ENA API on the same date and matches exactly.</a:t>
+              <a:rPr dirty="0"/>
+              <a:t>After applying these filters, the total record count was 30,313,212.</a:t>
             </a:r>
           </a:p>
         </p:txBody>
@@ -12034,7 +12773,7 @@
 </file>
 
 <file path=ppt/slides/slide4.xml><?xml version="1.0" encoding="utf-8"?>
-<p:sld xmlns:a="http://schemas.openxmlformats.org/drawingml/2006/main" xmlns:p="http://schemas.openxmlformats.org/presentationml/2006/main" xmlns:r="http://schemas.openxmlformats.org/officeDocument/2006/relationships">
+<p:sld xmlns:a="http://schemas.openxmlformats.org/drawingml/2006/main" xmlns:r="http://schemas.openxmlformats.org/officeDocument/2006/relationships" xmlns:p="http://schemas.openxmlformats.org/presentationml/2006/main">
   <p:cSld>
     <p:spTree>
       <p:nvGrpSpPr>
@@ -12042,7 +12781,14 @@
         <p:cNvGrpSpPr/>
         <p:nvPr/>
       </p:nvGrpSpPr>
-      <p:grpSpPr/>
+      <p:grpSpPr>
+        <a:xfrm>
+          <a:off x="0" y="0"/>
+          <a:ext cx="0" cy="0"/>
+          <a:chOff x="0" y="0"/>
+          <a:chExt cx="0" cy="0"/>
+        </a:xfrm>
+      </p:grpSpPr>
       <p:sp>
         <p:nvSpPr>
           <p:cNvPr id="2" name="TextBox 1"/>
@@ -12133,6 +12879,7 @@
           <a:lstStyle/>
           <a:p>
             <a:pPr algn="ctr"/>
+            <a:endParaRPr/>
           </a:p>
         </p:txBody>
       </p:sp>
@@ -12145,7 +12892,7 @@
         <p:spPr>
           <a:xfrm>
             <a:off x="731520" y="1554480"/>
-            <a:ext cx="10515600" cy="4846320"/>
+            <a:ext cx="10515600" cy="4113690"/>
           </a:xfrm>
           <a:prstGeom prst="rect">
             <a:avLst/>
@@ -12172,6 +12919,7 @@
               </a:defRPr>
             </a:pPr>
             <a:r>
+              <a:rPr dirty="0"/>
               <a:t>Each record has a country of collection recorded in a geographic location field. The analysis queried 378 distinct values: 296 from the INSDC controlled vocabulary plus 82 additional values identified through systematic sampling (alternative country names, locality names, placeholders).</a:t>
             </a:r>
           </a:p>
@@ -12190,6 +12938,7 @@
               </a:defRPr>
             </a:pPr>
             <a:r>
+              <a:rPr dirty="0"/>
               <a:t>The database uses token-based matching: a query for a short country name matches any record where that name appears as a word anywhere in the field. This creates false matches, for example when querying Mexico and matching records from USA: New Mexico.</a:t>
             </a:r>
           </a:p>
@@ -12208,8 +12957,14 @@
               </a:defRPr>
             </a:pPr>
             <a:r>
+              <a:rPr dirty="0"/>
               <a:t>Twenty collision exclusions were applied to prevent these false matches, covering cross-country pairs (Guinea matching Papua New Guinea), sub-national pairs (Mexico matching the US state of New Mexico), and ocean name overlaps (China matching South China Sea).</a:t>
             </a:r>
+            <a:r>
+              <a:rPr lang="en-GB" dirty="0"/>
+              <a:t> </a:t>
+            </a:r>
+            <a:endParaRPr dirty="0"/>
           </a:p>
           <a:p>
             <a:pPr>
@@ -12226,6 +12981,7 @@
               </a:defRPr>
             </a:pPr>
             <a:r>
+              <a:rPr dirty="0"/>
               <a:t>Raw values were aggregated onto 267 sovereign countries using UN M.49 and World Bank income classifications. Historical names with multiple successor states (USSR, Yugoslavia) were set aside.</a:t>
             </a:r>
           </a:p>
@@ -12240,7 +12996,7 @@
 </file>
 
 <file path=ppt/slides/slide5.xml><?xml version="1.0" encoding="utf-8"?>
-<p:sld xmlns:a="http://schemas.openxmlformats.org/drawingml/2006/main" xmlns:p="http://schemas.openxmlformats.org/presentationml/2006/main" xmlns:r="http://schemas.openxmlformats.org/officeDocument/2006/relationships">
+<p:sld xmlns:a="http://schemas.openxmlformats.org/drawingml/2006/main" xmlns:r="http://schemas.openxmlformats.org/officeDocument/2006/relationships" xmlns:p="http://schemas.openxmlformats.org/presentationml/2006/main">
   <p:cSld>
     <p:spTree>
       <p:nvGrpSpPr>
@@ -12248,7 +13004,14 @@
         <p:cNvGrpSpPr/>
         <p:nvPr/>
       </p:nvGrpSpPr>
-      <p:grpSpPr/>
+      <p:grpSpPr>
+        <a:xfrm>
+          <a:off x="0" y="0"/>
+          <a:ext cx="0" cy="0"/>
+          <a:chOff x="0" y="0"/>
+          <a:chExt cx="0" cy="0"/>
+        </a:xfrm>
+      </p:grpSpPr>
       <p:sp>
         <p:nvSpPr>
           <p:cNvPr id="2" name="TextBox 1"/>
@@ -12339,6 +13102,7 @@
           <a:lstStyle/>
           <a:p>
             <a:pPr algn="ctr"/>
+            <a:endParaRPr/>
           </a:p>
         </p:txBody>
       </p:sp>
@@ -12446,7 +13210,7 @@
 </file>
 
 <file path=ppt/slides/slide6.xml><?xml version="1.0" encoding="utf-8"?>
-<p:sld xmlns:a="http://schemas.openxmlformats.org/drawingml/2006/main" xmlns:p="http://schemas.openxmlformats.org/presentationml/2006/main" xmlns:r="http://schemas.openxmlformats.org/officeDocument/2006/relationships">
+<p:sld xmlns:a="http://schemas.openxmlformats.org/drawingml/2006/main" xmlns:r="http://schemas.openxmlformats.org/officeDocument/2006/relationships" xmlns:p="http://schemas.openxmlformats.org/presentationml/2006/main">
   <p:cSld>
     <p:spTree>
       <p:nvGrpSpPr>
@@ -12454,7 +13218,14 @@
         <p:cNvGrpSpPr/>
         <p:nvPr/>
       </p:nvGrpSpPr>
-      <p:grpSpPr/>
+      <p:grpSpPr>
+        <a:xfrm>
+          <a:off x="0" y="0"/>
+          <a:ext cx="0" cy="0"/>
+          <a:chOff x="0" y="0"/>
+          <a:chExt cx="0" cy="0"/>
+        </a:xfrm>
+      </p:grpSpPr>
       <p:sp>
         <p:nvSpPr>
           <p:cNvPr id="2" name="TextBox 1"/>
@@ -12545,6 +13316,7 @@
           <a:lstStyle/>
           <a:p>
             <a:pPr algn="ctr"/>
+            <a:endParaRPr/>
           </a:p>
         </p:txBody>
       </p:sp>
@@ -12558,7 +13330,7 @@
         </p:nvGraphicFramePr>
         <p:xfrm>
           <a:off x="731520" y="1554480"/>
-          <a:ext cx="6858000" cy="1920240"/>
+          <a:ext cx="6858000" cy="2423160"/>
         </p:xfrm>
         <a:graphic>
           <a:graphicData uri="http://schemas.openxmlformats.org/drawingml/2006/table">
@@ -12567,9 +13339,27 @@
                 <a:tableStyleId>{5C22544A-7EE6-4342-B048-85BDC9FD1C3A}</a:tableStyleId>
               </a:tblPr>
               <a:tblGrid>
-                <a:gridCol w="2286000"/>
-                <a:gridCol w="2286000"/>
-                <a:gridCol w="2286000"/>
+                <a:gridCol w="2286000">
+                  <a:extLst>
+                    <a:ext uri="{9D8B030D-6E8A-4147-A177-3AD203B41FA5}">
+                      <a16:colId xmlns:a16="http://schemas.microsoft.com/office/drawing/2014/main" val="20000"/>
+                    </a:ext>
+                  </a:extLst>
+                </a:gridCol>
+                <a:gridCol w="2286000">
+                  <a:extLst>
+                    <a:ext uri="{9D8B030D-6E8A-4147-A177-3AD203B41FA5}">
+                      <a16:colId xmlns:a16="http://schemas.microsoft.com/office/drawing/2014/main" val="20001"/>
+                    </a:ext>
+                  </a:extLst>
+                </a:gridCol>
+                <a:gridCol w="2286000">
+                  <a:extLst>
+                    <a:ext uri="{9D8B030D-6E8A-4147-A177-3AD203B41FA5}">
+                      <a16:colId xmlns:a16="http://schemas.microsoft.com/office/drawing/2014/main" val="20002"/>
+                    </a:ext>
+                  </a:extLst>
+                </a:gridCol>
               </a:tblGrid>
               <a:tr h="320040">
                 <a:tc>
@@ -12641,6 +13431,11 @@
                     </a:solidFill>
                   </a:tcPr>
                 </a:tc>
+                <a:extLst>
+                  <a:ext uri="{0D108BD9-81ED-4DB2-BD59-A6C34878D82A}">
+                    <a16:rowId xmlns:a16="http://schemas.microsoft.com/office/drawing/2014/main" val="10000"/>
+                  </a:ext>
+                </a:extLst>
               </a:tr>
               <a:tr h="320040">
                 <a:tc>
@@ -12675,7 +13470,7 @@
                         </a:defRPr>
                       </a:pPr>
                       <a:r>
-                        <a:t>18,987,186</a:t>
+                        <a:t>18,934,645</a:t>
                       </a:r>
                     </a:p>
                   </a:txBody>
@@ -12694,12 +13489,17 @@
                         </a:defRPr>
                       </a:pPr>
                       <a:r>
-                        <a:t>62.6%</a:t>
+                        <a:t>62.5%</a:t>
                       </a:r>
                     </a:p>
                   </a:txBody>
                   <a:tcPr/>
                 </a:tc>
+                <a:extLst>
+                  <a:ext uri="{0D108BD9-81ED-4DB2-BD59-A6C34878D82A}">
+                    <a16:rowId xmlns:a16="http://schemas.microsoft.com/office/drawing/2014/main" val="10001"/>
+                  </a:ext>
+                </a:extLst>
               </a:tr>
               <a:tr h="320040">
                 <a:tc>
@@ -12771,6 +13571,11 @@
                     </a:solidFill>
                   </a:tcPr>
                 </a:tc>
+                <a:extLst>
+                  <a:ext uri="{0D108BD9-81ED-4DB2-BD59-A6C34878D82A}">
+                    <a16:rowId xmlns:a16="http://schemas.microsoft.com/office/drawing/2014/main" val="10002"/>
+                  </a:ext>
+                </a:extLst>
               </a:tr>
               <a:tr h="320040">
                 <a:tc>
@@ -12805,7 +13610,7 @@
                         </a:defRPr>
                       </a:pPr>
                       <a:r>
-                        <a:t>3,920,292</a:t>
+                        <a:t>3,662,923</a:t>
                       </a:r>
                     </a:p>
                   </a:txBody>
@@ -12824,12 +13629,17 @@
                         </a:defRPr>
                       </a:pPr>
                       <a:r>
-                        <a:t>12.9%</a:t>
+                        <a:t>12.1%</a:t>
                       </a:r>
                     </a:p>
                   </a:txBody>
                   <a:tcPr/>
                 </a:tc>
+                <a:extLst>
+                  <a:ext uri="{0D108BD9-81ED-4DB2-BD59-A6C34878D82A}">
+                    <a16:rowId xmlns:a16="http://schemas.microsoft.com/office/drawing/2014/main" val="10003"/>
+                  </a:ext>
+                </a:extLst>
               </a:tr>
               <a:tr h="320040">
                 <a:tc>
@@ -12901,6 +13711,11 @@
                     </a:solidFill>
                   </a:tcPr>
                 </a:tc>
+                <a:extLst>
+                  <a:ext uri="{0D108BD9-81ED-4DB2-BD59-A6C34878D82A}">
+                    <a16:rowId xmlns:a16="http://schemas.microsoft.com/office/drawing/2014/main" val="10004"/>
+                  </a:ext>
+                </a:extLst>
               </a:tr>
               <a:tr h="320040">
                 <a:tc>
@@ -12960,6 +13775,11 @@
                   </a:txBody>
                   <a:tcPr/>
                 </a:tc>
+                <a:extLst>
+                  <a:ext uri="{0D108BD9-81ED-4DB2-BD59-A6C34878D82A}">
+                    <a16:rowId xmlns:a16="http://schemas.microsoft.com/office/drawing/2014/main" val="10005"/>
+                  </a:ext>
+                </a:extLst>
               </a:tr>
             </a:tbl>
           </a:graphicData>
@@ -12974,7 +13794,7 @@
         <p:spPr>
           <a:xfrm>
             <a:off x="7955279" y="1554480"/>
-            <a:ext cx="3931920" cy="4572000"/>
+            <a:ext cx="3931920" cy="3690049"/>
           </a:xfrm>
           <a:prstGeom prst="rect">
             <a:avLst/>
@@ -13001,7 +13821,40 @@
               </a:defRPr>
             </a:pPr>
             <a:r>
-              <a:t>38.3 per cent of all records cannot be attributed to any country. This is either because no country was recorded, the recorded value is a placeholder such as missing or NULL, or the value is a geographic feature such as an ocean rather than a political jurisdiction.</a:t>
+              <a:rPr dirty="0"/>
+              <a:t>37.5 per cent of all records cannot be attributed to any country. This is either because no country was recorded, the recorded value is a placeholder such as </a:t>
+            </a:r>
+            <a:r>
+              <a:rPr lang="en-GB" dirty="0"/>
+              <a:t>'</a:t>
+            </a:r>
+            <a:r>
+              <a:rPr dirty="0"/>
+              <a:t>missing</a:t>
+            </a:r>
+            <a:r>
+              <a:rPr lang="en-GB" dirty="0"/>
+              <a:t>'</a:t>
+            </a:r>
+            <a:r>
+              <a:rPr dirty="0"/>
+              <a:t> or </a:t>
+            </a:r>
+            <a:r>
+              <a:rPr lang="en-GB" dirty="0"/>
+              <a:t>'</a:t>
+            </a:r>
+            <a:r>
+              <a:rPr dirty="0"/>
+              <a:t>NULL</a:t>
+            </a:r>
+            <a:r>
+              <a:rPr lang="en-GB" dirty="0"/>
+              <a:t>'</a:t>
+            </a:r>
+            <a:r>
+              <a:rPr dirty="0"/>
+              <a:t>, or the value is a geographic feature such as an ocean rather than a political jurisdiction.</a:t>
             </a:r>
           </a:p>
           <a:p>
@@ -13019,8 +13872,18 @@
               </a:defRPr>
             </a:pPr>
             <a:r>
-              <a:t>This is a critical finding for any proposal to use these data as an allocation basis: more than a third of records would be excluded from a country-level formula, and the excluded fraction is not randomly distributed.</a:t>
-            </a:r>
+              <a:rPr lang="en-GB" dirty="0"/>
+              <a:t>The implication for using these data as an allocation basis: </a:t>
+            </a:r>
+            <a:r>
+              <a:rPr dirty="0"/>
+              <a:t>more than a third of records would be excluded from a country-level formula</a:t>
+            </a:r>
+            <a:r>
+              <a:rPr lang="en-GB" dirty="0"/>
+              <a:t>.</a:t>
+            </a:r>
+            <a:endParaRPr dirty="0"/>
           </a:p>
         </p:txBody>
       </p:sp>
@@ -13033,7 +13896,7 @@
 </file>
 
 <file path=ppt/slides/slide7.xml><?xml version="1.0" encoding="utf-8"?>
-<p:sld xmlns:a="http://schemas.openxmlformats.org/drawingml/2006/main" xmlns:p="http://schemas.openxmlformats.org/presentationml/2006/main" xmlns:r="http://schemas.openxmlformats.org/officeDocument/2006/relationships">
+<p:sld xmlns:a="http://schemas.openxmlformats.org/drawingml/2006/main" xmlns:r="http://schemas.openxmlformats.org/officeDocument/2006/relationships" xmlns:p="http://schemas.openxmlformats.org/presentationml/2006/main">
   <p:cSld>
     <p:spTree>
       <p:nvGrpSpPr>
@@ -13041,7 +13904,14 @@
         <p:cNvGrpSpPr/>
         <p:nvPr/>
       </p:nvGrpSpPr>
-      <p:grpSpPr/>
+      <p:grpSpPr>
+        <a:xfrm>
+          <a:off x="0" y="0"/>
+          <a:ext cx="0" cy="0"/>
+          <a:chOff x="0" y="0"/>
+          <a:chExt cx="0" cy="0"/>
+        </a:xfrm>
+      </p:grpSpPr>
       <p:sp>
         <p:nvSpPr>
           <p:cNvPr id="2" name="TextBox 1"/>
@@ -13132,6 +14002,7 @@
           <a:lstStyle/>
           <a:p>
             <a:pPr algn="ctr"/>
+            <a:endParaRPr/>
           </a:p>
         </p:txBody>
       </p:sp>
@@ -13168,7 +14039,7 @@
         <p:spPr>
           <a:xfrm>
             <a:off x="8412480" y="1463040"/>
-            <a:ext cx="3474720" cy="4572000"/>
+            <a:ext cx="3474720" cy="3440109"/>
           </a:xfrm>
           <a:prstGeom prst="rect">
             <a:avLst/>
@@ -13195,6 +14066,7 @@
               </a:defRPr>
             </a:pPr>
             <a:r>
+              <a:rPr dirty="0"/>
               <a:t>What this shows</a:t>
             </a:r>
           </a:p>
@@ -13213,6 +14085,7 @@
               </a:defRPr>
             </a:pPr>
             <a:r>
+              <a:rPr dirty="0"/>
               <a:t>Blue line: records with no country field at all, falling from 44.9 per cent to 5.2 per cent.</a:t>
             </a:r>
           </a:p>
@@ -13231,6 +14104,7 @@
               </a:defRPr>
             </a:pPr>
             <a:r>
+              <a:rPr dirty="0"/>
               <a:t>Red line: records where the field exists but contains the placeholder value “missing”, rising from 3.2 per cent to 17.3 per cent.</a:t>
             </a:r>
           </a:p>
@@ -13249,6 +14123,7 @@
               </a:defRPr>
             </a:pPr>
             <a:r>
+              <a:rPr dirty="0"/>
               <a:t>Green line: the combined total with no usable country, falling from 48.1 per cent to 22.5 per cent.</a:t>
             </a:r>
           </a:p>
@@ -13267,7 +14142,16 @@
               </a:defRPr>
             </a:pPr>
             <a:r>
-              <a:t>The field became compulsory, so submitters now include it. But many put “missing” as the value.</a:t>
+              <a:rPr dirty="0"/>
+              <a:t>The</a:t>
+            </a:r>
+            <a:r>
+              <a:rPr lang="en-GB" dirty="0"/>
+              <a:t> country</a:t>
+            </a:r>
+            <a:r>
+              <a:rPr dirty="0"/>
+              <a:t> field became compulsory, so submitters now include it. But many put “missing” as the value.</a:t>
             </a:r>
           </a:p>
         </p:txBody>
@@ -13316,7 +14200,7 @@
 </file>
 
 <file path=ppt/slides/slide8.xml><?xml version="1.0" encoding="utf-8"?>
-<p:sld xmlns:a="http://schemas.openxmlformats.org/drawingml/2006/main" xmlns:p="http://schemas.openxmlformats.org/presentationml/2006/main" xmlns:r="http://schemas.openxmlformats.org/officeDocument/2006/relationships">
+<p:sld xmlns:a="http://schemas.openxmlformats.org/drawingml/2006/main" xmlns:r="http://schemas.openxmlformats.org/officeDocument/2006/relationships" xmlns:p="http://schemas.openxmlformats.org/presentationml/2006/main">
   <p:cSld>
     <p:spTree>
       <p:nvGrpSpPr>
@@ -13324,7 +14208,14 @@
         <p:cNvGrpSpPr/>
         <p:nvPr/>
       </p:nvGrpSpPr>
-      <p:grpSpPr/>
+      <p:grpSpPr>
+        <a:xfrm>
+          <a:off x="0" y="0"/>
+          <a:ext cx="0" cy="0"/>
+          <a:chOff x="0" y="0"/>
+          <a:chExt cx="0" cy="0"/>
+        </a:xfrm>
+      </p:grpSpPr>
       <p:sp>
         <p:nvSpPr>
           <p:cNvPr id="2" name="TextBox 1"/>
@@ -13415,6 +14306,7 @@
           <a:lstStyle/>
           <a:p>
             <a:pPr algn="ctr"/>
+            <a:endParaRPr/>
           </a:p>
         </p:txBody>
       </p:sp>
@@ -13454,6 +14346,7 @@
               </a:defRPr>
             </a:pPr>
             <a:r>
+              <a:rPr dirty="0"/>
               <a:t>The country field is now compulsory in ENA submissions. This has worked: the share of records with no country field at all fell from 44.9 per cent in 2018 to 5.2 per cent in 2026.</a:t>
             </a:r>
           </a:p>
@@ -13472,6 +14365,7 @@
               </a:defRPr>
             </a:pPr>
             <a:r>
+              <a:rPr dirty="0"/>
               <a:t>However, a new problem has emerged in its place. The share of records where the field is present but contains the value “missing” rose from 3.2 per cent in 2018 to 17.3 per cent in 2026. The surge began in 2023, coinciding with the introduction of the mandatory requirement.</a:t>
             </a:r>
           </a:p>
@@ -13490,6 +14384,7 @@
               </a:defRPr>
             </a:pPr>
             <a:r>
+              <a:rPr dirty="0"/>
               <a:t>INSDC does provide a structured missing-value reporting framework: submitters who genuinely cannot provide a country should use “missing: ” followed by a specific reason, such as “missing: lab stock” for model organisms, “missing: restricted access” for endangered species, or “missing: not collected”. Some “missing” records are therefore legitimate.</a:t>
             </a:r>
           </a:p>
@@ -13508,7 +14403,16 @@
               </a:defRPr>
             </a:pPr>
             <a:r>
-              <a:t>However, many submitters use bare “missing” without a reason, or “missing:missing”, both of which are non-compliant. Without granular reporting, we cannot distinguish legitimate omissions from compliance-without-substance.</a:t>
+              <a:rPr dirty="0"/>
+              <a:t>However, many submitters use bare “missing” without a reason, or “</a:t>
+            </a:r>
+            <a:r>
+              <a:rPr dirty="0" err="1"/>
+              <a:t>missing:missing</a:t>
+            </a:r>
+            <a:r>
+              <a:rPr dirty="0"/>
+              <a:t>”, both of which are non-compliant. Without granular reporting, we cannot distinguish legitimate omissions from compliance-without-substance.</a:t>
             </a:r>
           </a:p>
           <a:p>
@@ -13526,6 +14430,7 @@
               </a:defRPr>
             </a:pPr>
             <a:r>
+              <a:rPr dirty="0"/>
               <a:t>Implication for allocation: any formula based on country-level counts must decide how to handle the 22.5 per cent of recent records with no usable country. The inability to distinguish legitimate from non-compliant omissions makes this harder.</a:t>
             </a:r>
           </a:p>
@@ -13540,7 +14445,7 @@
 </file>
 
 <file path=ppt/slides/slide9.xml><?xml version="1.0" encoding="utf-8"?>
-<p:sld xmlns:a="http://schemas.openxmlformats.org/drawingml/2006/main" xmlns:p="http://schemas.openxmlformats.org/presentationml/2006/main" xmlns:r="http://schemas.openxmlformats.org/officeDocument/2006/relationships">
+<p:sld xmlns:a="http://schemas.openxmlformats.org/drawingml/2006/main" xmlns:r="http://schemas.openxmlformats.org/officeDocument/2006/relationships" xmlns:p="http://schemas.openxmlformats.org/presentationml/2006/main">
   <p:cSld>
     <p:spTree>
       <p:nvGrpSpPr>
@@ -13548,7 +14453,14 @@
         <p:cNvGrpSpPr/>
         <p:nvPr/>
       </p:nvGrpSpPr>
-      <p:grpSpPr/>
+      <p:grpSpPr>
+        <a:xfrm>
+          <a:off x="0" y="0"/>
+          <a:ext cx="0" cy="0"/>
+          <a:chOff x="0" y="0"/>
+          <a:chExt cx="0" cy="0"/>
+        </a:xfrm>
+      </p:grpSpPr>
       <p:sp>
         <p:nvSpPr>
           <p:cNvPr id="2" name="TextBox 1"/>
@@ -13639,6 +14551,7 @@
           <a:lstStyle/>
           <a:p>
             <a:pPr algn="ctr"/>
+            <a:endParaRPr/>
           </a:p>
         </p:txBody>
       </p:sp>
@@ -13650,8 +14563,8 @@
         </p:nvSpPr>
         <p:spPr>
           <a:xfrm>
-            <a:off x="731520" y="1554480"/>
-            <a:ext cx="10515600" cy="4846320"/>
+            <a:off x="731520" y="1503680"/>
+            <a:ext cx="10515600" cy="5138138"/>
           </a:xfrm>
           <a:prstGeom prst="rect">
             <a:avLst/>
@@ -13678,25 +14591,24 @@
               </a:defRPr>
             </a:pPr>
             <a:r>
-              <a:t>The INSDC specification defines the country field (geo_loc_name) as a controlled vocabulary. The country portion must be one of approximately 296 approved values, with an optional free-text region and locality after a colon, for example “Canada:Vancouver”.</a:t>
-            </a:r>
-          </a:p>
-          <a:p>
-            <a:pPr>
-              <a:lnSpc>
-                <a:spcPct val="130000"/>
-              </a:lnSpc>
-              <a:spcBef>
-                <a:spcPts val="800"/>
-              </a:spcBef>
-              <a:defRPr sz="1600" b="0">
-                <a:solidFill>
-                  <a:srgbClr val="1A1A1A"/>
-                </a:solidFill>
-              </a:defRPr>
-            </a:pPr>
-            <a:r>
-              <a:t>INSDC also provides a missing-value reporting vocabulary with specific terms: “not applicable” (e.g., for control samples) and “missing” (to be followed by a reason such as “lab stock”, “not collected”, “restricted access”, “human-identifiable”, or “synthetic construct”).</a:t>
+              <a:rPr dirty="0"/>
+              <a:t>The INSDC specification defines the country field (</a:t>
+            </a:r>
+            <a:r>
+              <a:rPr dirty="0" err="1"/>
+              <a:t>geo_loc_name</a:t>
+            </a:r>
+            <a:r>
+              <a:rPr dirty="0"/>
+              <a:t>) as a controlled vocabulary. The country portion must be one of approximately 296 approved values, with an optional free-text region and locality after a colon, for example “</a:t>
+            </a:r>
+            <a:r>
+              <a:rPr dirty="0" err="1"/>
+              <a:t>Canada:Vancouver</a:t>
+            </a:r>
+            <a:r>
+              <a:rPr dirty="0"/>
+              <a:t>”.</a:t>
             </a:r>
           </a:p>
           <a:p>
@@ -13714,6 +14626,7 @@
               </a:defRPr>
             </a:pPr>
             <a:r>
+              <a:rPr dirty="0"/>
               <a:t>In practice, enforcement is weak:</a:t>
             </a:r>
           </a:p>
@@ -13732,6 +14645,7 @@
               </a:defRPr>
             </a:pPr>
             <a:r>
+              <a:rPr dirty="0"/>
               <a:t>82 non-vocabulary country values were found in the database, including alternative names (“UK” instead of “United Kingdom”), misspellings (“Columbia” instead of “Colombia”), and locality names entered without a country prefix.</a:t>
             </a:r>
           </a:p>
@@ -13750,7 +14664,16 @@
               </a:defRPr>
             </a:pPr>
             <a:r>
-              <a:t>The value “missing” is an approved INSDC term, but the specification requires it to be used with a reporting-level reason (e.g., “missing: lab stock”). Many submitters use bare “missing” or the invalid “missing:missing”, both non-compliant.</a:t>
+              <a:rPr dirty="0"/>
+              <a:t>The value “missing” is an approved INSDC term, but the specification requires it to be used with a reporting-level reason (e.g., “missing: lab stock”). Many submitters use bare “missing” or the invalid “</a:t>
+            </a:r>
+            <a:r>
+              <a:rPr dirty="0" err="1"/>
+              <a:t>missing:missing</a:t>
+            </a:r>
+            <a:r>
+              <a:rPr dirty="0"/>
+              <a:t>”, both non-compliant.</a:t>
             </a:r>
           </a:p>
           <a:p>
@@ -13768,7 +14691,16 @@
               </a:defRPr>
             </a:pPr>
             <a:r>
-              <a:t>5.2 per cent of 2026 records have no country field at all, despite the field being compulsory since 2021.</a:t>
+              <a:rPr dirty="0"/>
+              <a:t>5.2 per cent of 2026 records have no country field at all, despite the field being compulsory since 202</a:t>
+            </a:r>
+            <a:r>
+              <a:rPr lang="en-GB" dirty="0"/>
+              <a:t>4</a:t>
+            </a:r>
+            <a:r>
+              <a:rPr dirty="0"/>
+              <a:t>.</a:t>
             </a:r>
           </a:p>
           <a:p>
@@ -13786,6 +14718,7 @@
               </a:defRPr>
             </a:pPr>
             <a:r>
+              <a:rPr dirty="0"/>
               <a:t>The free-text region and locality portion causes token-matching collisions, for example “USA: New Mexico” matching a query for “Mexico”.</a:t>
             </a:r>
           </a:p>
@@ -13804,7 +14737,16 @@
               </a:defRPr>
             </a:pPr>
             <a:r>
-              <a:t>Recommendation: INSDC should enforce both the controlled vocabulary for country names and the missing-value reporting format at submission time, rejecting records where the country portion is not from the approved list and where “missing” is used without a valid reporting-level term. This would improve data quality for all downstream uses, including any future allocation methodology under the Cali Fund.</a:t>
+              <a:rPr dirty="0"/>
+              <a:t>Recommendation: </a:t>
+            </a:r>
+            <a:r>
+              <a:rPr lang="en-GB" dirty="0"/>
+              <a:t>enforce </a:t>
+            </a:r>
+            <a:r>
+              <a:rPr dirty="0"/>
+              <a:t>both the controlled vocabulary for country names and the missing-value reporting format at submission time, rejecting records where the country portion is not from the approved list and where “missing” is used without a valid reporting-level term. This would improve data quality for all downstream uses, including any future allocation methodology under the Cali Fund.</a:t>
             </a:r>
           </a:p>
         </p:txBody>

</xml_diff>